<commit_message>
Redesign Slide 2 as executive AI Operations Intelligence Dashboard
Co-authored-by: mohammadmoharam <223458661+mohammadmoharam@users.noreply.github.com>
</commit_message>
<xml_diff>
--- a/MS-AI/Executive-Presentation/AI-Executive-Overview.pptx
+++ b/MS-AI/Executive-Presentation/AI-Executive-Overview.pptx
@@ -777,215 +777,149 @@
           <a:lstStyle/>
           <a:p>
             <a:r>
-              <a:t>Opening: the same AI approach is now pointed at our own cost base — the effort our support</a:t>
-            </a:r>
-          </a:p>
-          <a:p>
-            <a:r>
-              <a:t>and operations teams spend keeping customer server environments healthy.</a:t>
+              <a:t>Opening: this slide is about our own operations. PACS and HL7 problems are still found</a:t>
+            </a:r>
+          </a:p>
+          <a:p>
+            <a:r>
+              <a:t>reactively - a queue backs up, an interface fails or a volume fills, and we hear about it</a:t>
+            </a:r>
+          </a:p>
+          <a:p>
+            <a:r>
+              <a:t>after the customer is already affected. Every one of those events then costs manual</a:t>
+            </a:r>
+          </a:p>
+          <a:p>
+            <a:r>
+              <a:t>investigation time.</a:t>
             </a:r>
           </a:p>
           <a:p/>
           <a:p>
             <a:r>
-              <a:t>The problem: teams work reactively across PACS environments, HL7 interfaces, archives and</a:t>
-            </a:r>
-          </a:p>
-          <a:p>
-            <a:r>
-              <a:t>storage growth. Alerts arrive after business impact has started, investigation is manual,</a:t>
-            </a:r>
-          </a:p>
-          <a:p>
-            <a:r>
-              <a:t>and the effort scales with every new customer environment ("Proactive Infrastructure</a:t>
-            </a:r>
-          </a:p>
-          <a:p>
-            <a:r>
-              <a:t>Management…pptx", slide 2 and notes).</a:t>
+              <a:t>What is already completed: PACS / HL7 service monitoring, queue and interface visibility,</a:t>
+            </a:r>
+          </a:p>
+          <a:p>
+            <a:r>
+              <a:t>operational status mapping, automation, and automated issue classification. That is the</a:t>
+            </a:r>
+          </a:p>
+          <a:p>
+            <a:r>
+              <a:t>foundation - we can see the estate and act on it in a standard way.</a:t>
             </a:r>
           </a:p>
           <a:p/>
           <a:p>
             <a:r>
-              <a:t>What Sentinel enables: a single dashboard for server inventory, health, performance,</a:t>
-            </a:r>
-          </a:p>
-          <a:p>
-            <a:r>
-              <a:t>storage and incidents; a Windows agent that executes only allow-listed commands with</a:t>
-            </a:r>
-          </a:p>
-          <a:p>
-            <a:r>
-              <a:t>risk classification and approval gates; browser-based RDP that keeps RDP credentials out</a:t>
-            </a:r>
-          </a:p>
-          <a:p>
-            <a:r>
-              <a:t>of the platform; and AI forecasting for disk, memory and CPU risk with deterministic</a:t>
-            </a:r>
-          </a:p>
-          <a:p>
-            <a:r>
-              <a:t>fallbacks ("AI Dashboard Brief Project Description.docx", Key Capabilities).</a:t>
+              <a:t>What AI adds on top: risk forecasting, storage capacity prediction and performance</a:t>
+            </a:r>
+          </a:p>
+          <a:p>
+            <a:r>
+              <a:t>degradation prediction, plus prioritized remediation recommendations so the team is told</a:t>
+            </a:r>
+          </a:p>
+          <a:p>
+            <a:r>
+              <a:t>what to do first, not just what is broken. Queue backlog forecasting is in progress, and</a:t>
+            </a:r>
+          </a:p>
+          <a:p>
+            <a:r>
+              <a:t>the prioritized remediation recommendations are the next increment.</a:t>
             </a:r>
           </a:p>
           <a:p/>
           <a:p>
             <a:r>
-              <a:t>Why management should care: it reduces time to resolution, removes the need for inbound</a:t>
-            </a:r>
-          </a:p>
-          <a:p>
-            <a:r>
-              <a:t>access and VPN routing into customer networks because agents connect outbound, and it</a:t>
-            </a:r>
-          </a:p>
-          <a:p>
-            <a:r>
-              <a:t>leaves an audit record for every login, command, approval and remote session — which is</a:t>
-            </a:r>
-          </a:p>
-          <a:p>
-            <a:r>
-              <a:t>exactly what customers ask us for during security reviews.</a:t>
+              <a:t>What is next after that: an AI Copilot for Operations - plain-language questions such as</a:t>
+            </a:r>
+          </a:p>
+          <a:p>
+            <a:r>
+              <a:t>"why is HL7 failing?" or "which server is most at risk?" - so investigation is not limited</a:t>
+            </a:r>
+          </a:p>
+          <a:p>
+            <a:r>
+              <a:t>to the few engineers who know where to look.</a:t>
             </a:r>
           </a:p>
           <a:p/>
           <a:p>
             <a:r>
-              <a:t>Status and evidence limits: the capability list is documented as built, but the document</a:t>
-            </a:r>
-          </a:p>
-          <a:p>
-            <a:r>
-              <a:t>itself signals unfinished work — the file transfer layer today returns policy decisions</a:t>
-            </a:r>
-          </a:p>
-          <a:p>
-            <a:r>
-              <a:t>and audit records "before enabling full real file streaming", and the newer AgentRelay</a:t>
-            </a:r>
-          </a:p>
-          <a:p>
-            <a:r>
-              <a:t>capability is being "introduced and validated in stages" while direct connectivity</a:t>
-            </a:r>
-          </a:p>
-          <a:p>
-            <a:r>
-              <a:t>remains. Note a discrepancy the executives should know about: the May 2026 deck is an</a:t>
-            </a:r>
-          </a:p>
-          <a:p>
-            <a:r>
-              <a:t>AI-assisted proof of concept with generated mockups (slide 15), whereas the project</a:t>
-            </a:r>
-          </a:p>
-          <a:p>
-            <a:r>
-              <a:t>description describes a working platform. I am presenting the project description as the</a:t>
-            </a:r>
-          </a:p>
-          <a:p>
-            <a:r>
-              <a:t>status of record and treating the deck's autonomous-operations phases as roadmap, not</a:t>
-            </a:r>
-          </a:p>
-          <a:p>
-            <a:r>
-              <a:t>delivery.</a:t>
+              <a:t>Business impact: earlier detection, faster resolution, reduced operational effort, a better</a:t>
+            </a:r>
+          </a:p>
+          <a:p>
+            <a:r>
+              <a:t>customer experience, improved system availability, and better capacity planning because</a:t>
+            </a:r>
+          </a:p>
+          <a:p>
+            <a:r>
+              <a:t>growth is forecast instead of discovered.</a:t>
             </a:r>
           </a:p>
           <a:p/>
           <a:p>
             <a:r>
-              <a:t>Effort, dependencies, risk: remaining effort is not sized in any source, so the honest</a:t>
-            </a:r>
-          </a:p>
-          <a:p>
-            <a:r>
-              <a:t>answer is "to be confirmed"; I would not quote a date. Dependencies are Matcha AI through</a:t>
-            </a:r>
-          </a:p>
-          <a:p>
-            <a:r>
-              <a:t>the abstraction layer, Azure AD / Microsoft Identity for dashboard sign-in, Zoho Vault for</a:t>
-            </a:r>
-          </a:p>
-          <a:p>
-            <a:r>
-              <a:t>secret lookup, PostgreSQL/SQLite telemetry storage, and customer willingness to install</a:t>
-            </a:r>
-          </a:p>
-          <a:p>
-            <a:r>
-              <a:t>the agent. Main risks: agent rollout friction, forecast trust, and scope creep toward</a:t>
-            </a:r>
-          </a:p>
-          <a:p>
-            <a:r>
-              <a:t>autonomous remediation before approval controls are proven.</a:t>
+              <a:t>Framing for this audience: this is an operational efficiency and customer experience</a:t>
+            </a:r>
+          </a:p>
+          <a:p>
+            <a:r>
+              <a:t>initiative, not only a technical dashboard. It changes how much unplanned, out-of-hours</a:t>
+            </a:r>
+          </a:p>
+          <a:p>
+            <a:r>
+              <a:t>work we absorb and how early we can talk to a customer.</a:t>
             </a:r>
           </a:p>
           <a:p/>
           <a:p>
             <a:r>
-              <a:t>Decision / next step: confirm the next milestone — complete governed file transfer and</a:t>
-            </a:r>
-          </a:p>
-          <a:p>
-            <a:r>
-              <a:t>staged relay validation on a defined set of internal servers — and approve whether HL7 and</a:t>
-            </a:r>
-          </a:p>
-          <a:p>
-            <a:r>
-              <a:t>PACS monitoring is in scope for the next increment, since that is what converts this from</a:t>
-            </a:r>
-          </a:p>
-          <a:p>
-            <a:r>
-              <a:t>an IT tool into a managed-services differentiator.</a:t>
+              <a:t>Evidence discipline: I am deliberately not quoting savings, percentages, ROI, dates or</a:t>
+            </a:r>
+          </a:p>
+          <a:p>
+            <a:r>
+              <a:t>production scope - the source material does not contain them. The benefits listed are</a:t>
+            </a:r>
+          </a:p>
+          <a:p>
+            <a:r>
+              <a:t>expected benefits, and the next useful step is agreeing the two or three operational</a:t>
+            </a:r>
+          </a:p>
+          <a:p>
+            <a:r>
+              <a:t>metrics (time to detect, time to resolve, volume of emergency work) that would prove them.</a:t>
             </a:r>
           </a:p>
           <a:p/>
           <a:p>
             <a:r>
-              <a:t>Transition: with one capability delivered and one in flight, the question becomes where we</a:t>
-            </a:r>
-          </a:p>
-          <a:p>
-            <a:r>
-              <a:t>invest next.</a:t>
-            </a:r>
-          </a:p>
-          <a:p/>
-          <a:p>
-            <a:r>
               <a:t>Sources: MS-AI/AI Dashboard/AI Dashboard Brief Project Description.docx (Objectives, Key</a:t>
             </a:r>
           </a:p>
           <a:p>
             <a:r>
-              <a:t>Capabilities, Business Value); MS-AI/AI Dashboard/Proactive Infrastructure Management_…</a:t>
-            </a:r>
-          </a:p>
-          <a:p>
-            <a:r>
-              <a:t>_20260513141714.pptx (slides 2-9, 13-15 + notes); "next" items also appear in</a:t>
-            </a:r>
-          </a:p>
-          <a:p>
-            <a:r>
-              <a:t>MS-AI/Next Ideas/Q4 and 2027 ideas.docx (AI monitoring dashboard for HL7/PACS; CRM</a:t>
-            </a:r>
-          </a:p>
-          <a:p>
-            <a:r>
-              <a:t>contract alerts).</a:t>
+              <a:t>Capabilities, Business Value); MS-AI/AI Dashboard/Proactive Infrastructure Management_ A</a:t>
+            </a:r>
+          </a:p>
+          <a:p>
+            <a:r>
+              <a:t>Monitoring, Alerting, and Auto-Remediation Solution_20260513141714.pptx (slides 2-3, 5, 7,</a:t>
+            </a:r>
+          </a:p>
+          <a:p>
+            <a:r>
+              <a:t>9, 13-14).</a:t>
             </a:r>
           </a:p>
         </p:txBody>
@@ -5343,7 +5277,7 @@
                 </a:solidFill>
                 <a:latin typeface="Segoe UI"/>
               </a:rPr>
-              <a:t>IN PROGRESS  ·  SENTINEL AI OPERATIONS DASHBOARD</a:t>
+              <a:t>AI OPERATIONS  ·  PACS / HL7 SERVICE INTELLIGENCE</a:t>
             </a:r>
           </a:p>
         </p:txBody>
@@ -5385,7 +5319,7 @@
                 </a:solidFill>
                 <a:latin typeface="Segoe UI"/>
               </a:rPr>
-              <a:t>Governed Console for Server Health and AI Forecasts</a:t>
+              <a:t>AI Operations Intelligence Dashboard</a:t>
             </a:r>
           </a:p>
         </p:txBody>
@@ -5427,7 +5361,7 @@
                 </a:solidFill>
                 <a:latin typeface="Segoe UI"/>
               </a:rPr>
-              <a:t>Monitoring, approval-gated actions and forecasting are built; secure file transfer and agent relay remain.</a:t>
+              <a:t>From reactive monitoring to predictive PACS / HL7 operations</a:t>
             </a:r>
           </a:p>
         </p:txBody>
@@ -5440,8 +5374,8 @@
         </p:nvSpPr>
         <p:spPr>
           <a:xfrm>
-            <a:off x="566928" y="2103120"/>
-            <a:ext cx="11057839" cy="585216"/>
+            <a:off x="566928" y="1920240"/>
+            <a:ext cx="3527450" cy="2779776"/>
           </a:xfrm>
           <a:prstGeom prst="roundRect">
             <a:avLst>
@@ -5449,10 +5383,12 @@
             </a:avLst>
           </a:prstGeom>
           <a:solidFill>
-            <a:srgbClr val="E6F3F3"/>
+            <a:srgbClr val="FFFFFF"/>
           </a:solidFill>
-          <a:ln>
-            <a:noFill/>
+          <a:ln w="12700">
+            <a:solidFill>
+              <a:srgbClr val="D6DEE6"/>
+            </a:solidFill>
           </a:ln>
           <a:effectLst/>
         </p:spPr>
@@ -5471,7 +5407,7 @@
           </a:fontRef>
         </p:style>
         <p:txBody>
-          <a:bodyPr rtlCol="0" anchor="ctr" wrap="square" lIns="146304" rIns="146304" tIns="91440" bIns="91440"/>
+          <a:bodyPr rtlCol="0" anchor="t" wrap="square" lIns="118872" rIns="118872" tIns="164592" bIns="91440"/>
           <a:lstStyle/>
           <a:p>
             <a:pPr algn="ctr">
@@ -5479,31 +5415,234 @@
                 <a:spcPct val="115000"/>
               </a:lnSpc>
               <a:spcAft>
-                <a:spcPts val="0"/>
+                <a:spcPts val="100"/>
               </a:spcAft>
             </a:pPr>
             <a:r>
-              <a:rPr sz="1700" b="1">
-                <a:solidFill>
-                  <a:srgbClr val="0B2545"/>
-                </a:solidFill>
-                <a:latin typeface="Segoe UI"/>
-              </a:rPr>
-              <a:t>Detect  →  Forecast  →  Recommend  →  Approve  →  Act  →  Audit</a:t>
-            </a:r>
-          </a:p>
-        </p:txBody>
-      </p:sp>
-      <p:sp>
-        <p:nvSpPr>
-          <p:cNvPr id="7" name="Rounded Rectangle 6"/>
+              <a:rPr sz="1300" b="1">
+                <a:solidFill>
+                  <a:srgbClr val="0E8C8B"/>
+                </a:solidFill>
+                <a:latin typeface="Segoe UI"/>
+              </a:rPr>
+              <a:t>COMPLETED FOUNDATION</a:t>
+            </a:r>
+          </a:p>
+          <a:p>
+            <a:pPr>
+              <a:lnSpc>
+                <a:spcPct val="100000"/>
+              </a:lnSpc>
+              <a:spcAft>
+                <a:spcPts val="900"/>
+              </a:spcAft>
+            </a:pPr>
+            <a:r>
+              <a:rPr sz="1100" b="0">
+                <a:solidFill>
+                  <a:srgbClr val="556677"/>
+                </a:solidFill>
+                <a:latin typeface="Segoe UI"/>
+              </a:rPr>
+              <a:t>Built and running</a:t>
+            </a:r>
+          </a:p>
+          <a:p>
+            <a:pPr>
+              <a:lnSpc>
+                <a:spcPct val="105000"/>
+              </a:lnSpc>
+              <a:spcAft>
+                <a:spcPts val="700"/>
+              </a:spcAft>
+            </a:pPr>
+            <a:r>
+              <a:rPr sz="1300" b="1">
+                <a:solidFill>
+                  <a:srgbClr val="0E8C8B"/>
+                </a:solidFill>
+                <a:latin typeface="Segoe UI"/>
+              </a:rPr>
+              <a:t>▪  </a:t>
+            </a:r>
+            <a:r>
+              <a:rPr sz="1300" b="0">
+                <a:solidFill>
+                  <a:srgbClr val="1B3A5C"/>
+                </a:solidFill>
+                <a:latin typeface="Segoe UI"/>
+              </a:rPr>
+              <a:t>PACS / HL7 service monitoring</a:t>
+            </a:r>
+          </a:p>
+          <a:p>
+            <a:pPr>
+              <a:lnSpc>
+                <a:spcPct val="105000"/>
+              </a:lnSpc>
+              <a:spcAft>
+                <a:spcPts val="700"/>
+              </a:spcAft>
+            </a:pPr>
+            <a:r>
+              <a:rPr sz="1300" b="1">
+                <a:solidFill>
+                  <a:srgbClr val="0E8C8B"/>
+                </a:solidFill>
+                <a:latin typeface="Segoe UI"/>
+              </a:rPr>
+              <a:t>▪  </a:t>
+            </a:r>
+            <a:r>
+              <a:rPr sz="1300" b="0">
+                <a:solidFill>
+                  <a:srgbClr val="1B3A5C"/>
+                </a:solidFill>
+                <a:latin typeface="Segoe UI"/>
+              </a:rPr>
+              <a:t>Queue and interface visibility</a:t>
+            </a:r>
+          </a:p>
+          <a:p>
+            <a:pPr>
+              <a:lnSpc>
+                <a:spcPct val="105000"/>
+              </a:lnSpc>
+              <a:spcAft>
+                <a:spcPts val="700"/>
+              </a:spcAft>
+            </a:pPr>
+            <a:r>
+              <a:rPr sz="1300" b="1">
+                <a:solidFill>
+                  <a:srgbClr val="0E8C8B"/>
+                </a:solidFill>
+                <a:latin typeface="Segoe UI"/>
+              </a:rPr>
+              <a:t>▪  </a:t>
+            </a:r>
+            <a:r>
+              <a:rPr sz="1300" b="0">
+                <a:solidFill>
+                  <a:srgbClr val="1B3A5C"/>
+                </a:solidFill>
+                <a:latin typeface="Segoe UI"/>
+              </a:rPr>
+              <a:t>Operational status mapping</a:t>
+            </a:r>
+          </a:p>
+          <a:p>
+            <a:pPr>
+              <a:lnSpc>
+                <a:spcPct val="105000"/>
+              </a:lnSpc>
+              <a:spcAft>
+                <a:spcPts val="700"/>
+              </a:spcAft>
+            </a:pPr>
+            <a:r>
+              <a:rPr sz="1300" b="1">
+                <a:solidFill>
+                  <a:srgbClr val="0E8C8B"/>
+                </a:solidFill>
+                <a:latin typeface="Segoe UI"/>
+              </a:rPr>
+              <a:t>▪  </a:t>
+            </a:r>
+            <a:r>
+              <a:rPr sz="1300" b="0">
+                <a:solidFill>
+                  <a:srgbClr val="1B3A5C"/>
+                </a:solidFill>
+                <a:latin typeface="Segoe UI"/>
+              </a:rPr>
+              <a:t>Automation</a:t>
+            </a:r>
+          </a:p>
+          <a:p>
+            <a:pPr>
+              <a:lnSpc>
+                <a:spcPct val="105000"/>
+              </a:lnSpc>
+              <a:spcAft>
+                <a:spcPts val="700"/>
+              </a:spcAft>
+            </a:pPr>
+            <a:r>
+              <a:rPr sz="1300" b="1">
+                <a:solidFill>
+                  <a:srgbClr val="0E8C8B"/>
+                </a:solidFill>
+                <a:latin typeface="Segoe UI"/>
+              </a:rPr>
+              <a:t>▪  </a:t>
+            </a:r>
+            <a:r>
+              <a:rPr sz="1300" b="0">
+                <a:solidFill>
+                  <a:srgbClr val="1B3A5C"/>
+                </a:solidFill>
+                <a:latin typeface="Segoe UI"/>
+              </a:rPr>
+              <a:t>Automated issue classification</a:t>
+            </a:r>
+          </a:p>
+        </p:txBody>
+      </p:sp>
+      <p:sp>
+        <p:nvSpPr>
+          <p:cNvPr id="7" name="Rectangle 6"/>
           <p:cNvSpPr/>
           <p:nvPr/>
         </p:nvSpPr>
         <p:spPr>
           <a:xfrm>
-            <a:off x="566928" y="2834640"/>
-            <a:ext cx="3551834" cy="2560320"/>
+            <a:off x="566928" y="1920240"/>
+            <a:ext cx="3527450" cy="63500"/>
+          </a:xfrm>
+          <a:prstGeom prst="rect">
+            <a:avLst/>
+          </a:prstGeom>
+          <a:solidFill>
+            <a:srgbClr val="0E8C8B"/>
+          </a:solidFill>
+          <a:ln>
+            <a:noFill/>
+          </a:ln>
+          <a:effectLst/>
+        </p:spPr>
+        <p:style>
+          <a:lnRef idx="1">
+            <a:schemeClr val="accent1"/>
+          </a:lnRef>
+          <a:fillRef idx="3">
+            <a:schemeClr val="accent1"/>
+          </a:fillRef>
+          <a:effectRef idx="2">
+            <a:schemeClr val="accent1"/>
+          </a:effectRef>
+          <a:fontRef idx="minor">
+            <a:schemeClr val="lt1"/>
+          </a:fontRef>
+        </p:style>
+        <p:txBody>
+          <a:bodyPr rtlCol="0" anchor="ctr"/>
+          <a:lstStyle/>
+          <a:p>
+            <a:pPr algn="ctr"/>
+          </a:p>
+        </p:txBody>
+      </p:sp>
+      <p:sp>
+        <p:nvSpPr>
+          <p:cNvPr id="8" name="Rounded Rectangle 7"/>
+          <p:cNvSpPr/>
+          <p:nvPr/>
+        </p:nvSpPr>
+        <p:spPr>
+          <a:xfrm>
+            <a:off x="4332122" y="1920240"/>
+            <a:ext cx="3527450" cy="2779776"/>
           </a:xfrm>
           <a:prstGeom prst="roundRect">
             <a:avLst>
@@ -5535,7 +5674,7 @@
           </a:fontRef>
         </p:style>
         <p:txBody>
-          <a:bodyPr rtlCol="0" anchor="ctr" wrap="square" lIns="146304" rIns="146304" tIns="146304" bIns="91440"/>
+          <a:bodyPr rtlCol="0" anchor="t" wrap="square" lIns="118872" rIns="118872" tIns="164592" bIns="91440"/>
           <a:lstStyle/>
           <a:p>
             <a:pPr algn="ctr">
@@ -5543,17 +5682,36 @@
                 <a:spcPct val="115000"/>
               </a:lnSpc>
               <a:spcAft>
-                <a:spcPts val="800"/>
+                <a:spcPts val="100"/>
               </a:spcAft>
             </a:pPr>
             <a:r>
               <a:rPr sz="1300" b="1">
                 <a:solidFill>
-                  <a:srgbClr val="0E8C8B"/>
-                </a:solidFill>
-                <a:latin typeface="Segoe UI"/>
-              </a:rPr>
-              <a:t>COMPLETED</a:t>
+                  <a:srgbClr val="1B3A5C"/>
+                </a:solidFill>
+                <a:latin typeface="Segoe UI"/>
+              </a:rPr>
+              <a:t>AI INTELLIGENCE LAYER</a:t>
+            </a:r>
+          </a:p>
+          <a:p>
+            <a:pPr>
+              <a:lnSpc>
+                <a:spcPct val="100000"/>
+              </a:lnSpc>
+              <a:spcAft>
+                <a:spcPts val="900"/>
+              </a:spcAft>
+            </a:pPr>
+            <a:r>
+              <a:rPr sz="1100" b="0">
+                <a:solidFill>
+                  <a:srgbClr val="556677"/>
+                </a:solidFill>
+                <a:latin typeface="Segoe UI"/>
+              </a:rPr>
+              <a:t>What AI adds</a:t>
             </a:r>
           </a:p>
           <a:p>
@@ -5566,22 +5724,22 @@
               </a:spcAft>
             </a:pPr>
             <a:r>
-              <a:rPr sz="1600" b="1">
-                <a:solidFill>
-                  <a:srgbClr val="0E8C8B"/>
-                </a:solidFill>
-                <a:latin typeface="Segoe UI"/>
-              </a:rPr>
-              <a:t>·  </a:t>
-            </a:r>
-            <a:r>
-              <a:rPr sz="1600" b="0">
-                <a:solidFill>
-                  <a:srgbClr val="556677"/>
-                </a:solidFill>
-                <a:latin typeface="Segoe UI"/>
-              </a:rPr>
-              <a:t>Health and capacity dashboard</a:t>
+              <a:rPr sz="1300" b="1">
+                <a:solidFill>
+                  <a:srgbClr val="1B3A5C"/>
+                </a:solidFill>
+                <a:latin typeface="Segoe UI"/>
+              </a:rPr>
+              <a:t>▪  </a:t>
+            </a:r>
+            <a:r>
+              <a:rPr sz="1300" b="0">
+                <a:solidFill>
+                  <a:srgbClr val="1B3A5C"/>
+                </a:solidFill>
+                <a:latin typeface="Segoe UI"/>
+              </a:rPr>
+              <a:t>Risk forecasting</a:t>
             </a:r>
           </a:p>
           <a:p>
@@ -5594,22 +5752,22 @@
               </a:spcAft>
             </a:pPr>
             <a:r>
-              <a:rPr sz="1600" b="1">
-                <a:solidFill>
-                  <a:srgbClr val="0E8C8B"/>
-                </a:solidFill>
-                <a:latin typeface="Segoe UI"/>
-              </a:rPr>
-              <a:t>·  </a:t>
-            </a:r>
-            <a:r>
-              <a:rPr sz="1600" b="0">
-                <a:solidFill>
-                  <a:srgbClr val="556677"/>
-                </a:solidFill>
-                <a:latin typeface="Segoe UI"/>
-              </a:rPr>
-              <a:t>Approval-gated commands, audited</a:t>
+              <a:rPr sz="1300" b="1">
+                <a:solidFill>
+                  <a:srgbClr val="1B3A5C"/>
+                </a:solidFill>
+                <a:latin typeface="Segoe UI"/>
+              </a:rPr>
+              <a:t>▪  </a:t>
+            </a:r>
+            <a:r>
+              <a:rPr sz="1300" b="0">
+                <a:solidFill>
+                  <a:srgbClr val="1B3A5C"/>
+                </a:solidFill>
+                <a:latin typeface="Segoe UI"/>
+              </a:rPr>
+              <a:t>Storage capacity prediction</a:t>
             </a:r>
           </a:p>
           <a:p>
@@ -5622,42 +5780,116 @@
               </a:spcAft>
             </a:pPr>
             <a:r>
-              <a:rPr sz="1600" b="1">
-                <a:solidFill>
-                  <a:srgbClr val="0E8C8B"/>
-                </a:solidFill>
-                <a:latin typeface="Segoe UI"/>
-              </a:rPr>
-              <a:t>·  </a:t>
-            </a:r>
-            <a:r>
-              <a:rPr sz="1600" b="0">
-                <a:solidFill>
-                  <a:srgbClr val="556677"/>
-                </a:solidFill>
-                <a:latin typeface="Segoe UI"/>
-              </a:rPr>
-              <a:t>Disk, memory, CPU forecasts</a:t>
-            </a:r>
-          </a:p>
-        </p:txBody>
-      </p:sp>
-      <p:sp>
-        <p:nvSpPr>
-          <p:cNvPr id="8" name="Rectangle 7"/>
+              <a:rPr sz="1300" b="1">
+                <a:solidFill>
+                  <a:srgbClr val="1B3A5C"/>
+                </a:solidFill>
+                <a:latin typeface="Segoe UI"/>
+              </a:rPr>
+              <a:t>▪  </a:t>
+            </a:r>
+            <a:r>
+              <a:rPr sz="1300" b="0">
+                <a:solidFill>
+                  <a:srgbClr val="1B3A5C"/>
+                </a:solidFill>
+                <a:latin typeface="Segoe UI"/>
+              </a:rPr>
+              <a:t>Performance degradation prediction</a:t>
+            </a:r>
+          </a:p>
+          <a:p>
+            <a:pPr>
+              <a:lnSpc>
+                <a:spcPct val="105000"/>
+              </a:lnSpc>
+              <a:spcAft>
+                <a:spcPts val="700"/>
+              </a:spcAft>
+            </a:pPr>
+            <a:r>
+              <a:rPr sz="1300" b="1">
+                <a:solidFill>
+                  <a:srgbClr val="1B3A5C"/>
+                </a:solidFill>
+                <a:latin typeface="Segoe UI"/>
+              </a:rPr>
+              <a:t>▪  </a:t>
+            </a:r>
+            <a:r>
+              <a:rPr sz="1300" b="0">
+                <a:solidFill>
+                  <a:srgbClr val="1B3A5C"/>
+                </a:solidFill>
+                <a:latin typeface="Segoe UI"/>
+              </a:rPr>
+              <a:t>Queue backlog forecasting</a:t>
+            </a:r>
+            <a:r>
+              <a:rPr sz="1100" b="1">
+                <a:solidFill>
+                  <a:srgbClr val="B57A0E"/>
+                </a:solidFill>
+                <a:latin typeface="Segoe UI"/>
+              </a:rPr>
+              <a:t>   In Progress</a:t>
+            </a:r>
+          </a:p>
+          <a:p>
+            <a:pPr>
+              <a:lnSpc>
+                <a:spcPct val="105000"/>
+              </a:lnSpc>
+              <a:spcAft>
+                <a:spcPts val="700"/>
+              </a:spcAft>
+            </a:pPr>
+            <a:r>
+              <a:rPr sz="1300" b="1">
+                <a:solidFill>
+                  <a:srgbClr val="1B3A5C"/>
+                </a:solidFill>
+                <a:latin typeface="Segoe UI"/>
+              </a:rPr>
+              <a:t>▪  </a:t>
+            </a:r>
+            <a:r>
+              <a:rPr sz="1300" b="0">
+                <a:solidFill>
+                  <a:srgbClr val="1B3A5C"/>
+                </a:solidFill>
+                <a:latin typeface="Segoe UI"/>
+              </a:rPr>
+              <a:t>Prioritized remediation recommendations</a:t>
+            </a:r>
+            <a:r>
+              <a:rPr sz="1100" b="1">
+                <a:solidFill>
+                  <a:srgbClr val="B57A0E"/>
+                </a:solidFill>
+                <a:latin typeface="Segoe UI"/>
+              </a:rPr>
+              <a:t>   Next</a:t>
+            </a:r>
+          </a:p>
+        </p:txBody>
+      </p:sp>
+      <p:sp>
+        <p:nvSpPr>
+          <p:cNvPr id="9" name="Rectangle 8"/>
           <p:cNvSpPr/>
           <p:nvPr/>
         </p:nvSpPr>
         <p:spPr>
           <a:xfrm>
-            <a:off x="566928" y="2834640"/>
-            <a:ext cx="3551834" cy="63500"/>
+            <a:off x="4332122" y="1920240"/>
+            <a:ext cx="3527450" cy="63500"/>
           </a:xfrm>
           <a:prstGeom prst="rect">
             <a:avLst/>
           </a:prstGeom>
           <a:solidFill>
-            <a:srgbClr val="0E8C8B"/>
+            <a:srgbClr val="1B3A5C"/>
           </a:solidFill>
           <a:ln>
             <a:noFill/>
@@ -5688,14 +5920,14 @@
       </p:sp>
       <p:sp>
         <p:nvSpPr>
-          <p:cNvPr id="9" name="Rounded Rectangle 8"/>
+          <p:cNvPr id="10" name="Rounded Rectangle 9"/>
           <p:cNvSpPr/>
           <p:nvPr/>
         </p:nvSpPr>
         <p:spPr>
           <a:xfrm>
-            <a:off x="4319930" y="2834640"/>
-            <a:ext cx="3551834" cy="2560320"/>
+            <a:off x="8097316" y="1920240"/>
+            <a:ext cx="3527450" cy="2779776"/>
           </a:xfrm>
           <a:prstGeom prst="roundRect">
             <a:avLst>
@@ -5727,7 +5959,7 @@
           </a:fontRef>
         </p:style>
         <p:txBody>
-          <a:bodyPr rtlCol="0" anchor="ctr" wrap="square" lIns="146304" rIns="146304" tIns="146304" bIns="91440"/>
+          <a:bodyPr rtlCol="0" anchor="t" wrap="square" lIns="118872" rIns="118872" tIns="164592" bIns="91440"/>
           <a:lstStyle/>
           <a:p>
             <a:pPr algn="ctr">
@@ -5735,17 +5967,36 @@
                 <a:spcPct val="115000"/>
               </a:lnSpc>
               <a:spcAft>
-                <a:spcPts val="800"/>
+                <a:spcPts val="100"/>
               </a:spcAft>
             </a:pPr>
             <a:r>
               <a:rPr sz="1300" b="1">
                 <a:solidFill>
-                  <a:srgbClr val="B57A0E"/>
-                </a:solidFill>
-                <a:latin typeface="Segoe UI"/>
-              </a:rPr>
-              <a:t>IN PROGRESS</a:t>
+                  <a:srgbClr val="0B2545"/>
+                </a:solidFill>
+                <a:latin typeface="Segoe UI"/>
+              </a:rPr>
+              <a:t>BUSINESS IMPACT</a:t>
+            </a:r>
+          </a:p>
+          <a:p>
+            <a:pPr>
+              <a:lnSpc>
+                <a:spcPct val="100000"/>
+              </a:lnSpc>
+              <a:spcAft>
+                <a:spcPts val="900"/>
+              </a:spcAft>
+            </a:pPr>
+            <a:r>
+              <a:rPr sz="1100" b="0">
+                <a:solidFill>
+                  <a:srgbClr val="556677"/>
+                </a:solidFill>
+                <a:latin typeface="Segoe UI"/>
+              </a:rPr>
+              <a:t>Why it matters</a:t>
             </a:r>
           </a:p>
           <a:p>
@@ -5758,22 +6009,22 @@
               </a:spcAft>
             </a:pPr>
             <a:r>
-              <a:rPr sz="1600" b="1">
-                <a:solidFill>
-                  <a:srgbClr val="B57A0E"/>
-                </a:solidFill>
-                <a:latin typeface="Segoe UI"/>
-              </a:rPr>
-              <a:t>·  </a:t>
-            </a:r>
-            <a:r>
-              <a:rPr sz="1600" b="0">
-                <a:solidFill>
-                  <a:srgbClr val="556677"/>
-                </a:solidFill>
-                <a:latin typeface="Segoe UI"/>
-              </a:rPr>
-              <a:t>Governed file transfer</a:t>
+              <a:rPr sz="1300" b="1">
+                <a:solidFill>
+                  <a:srgbClr val="0B2545"/>
+                </a:solidFill>
+                <a:latin typeface="Segoe UI"/>
+              </a:rPr>
+              <a:t>▪  </a:t>
+            </a:r>
+            <a:r>
+              <a:rPr sz="1300" b="0">
+                <a:solidFill>
+                  <a:srgbClr val="1B3A5C"/>
+                </a:solidFill>
+                <a:latin typeface="Segoe UI"/>
+              </a:rPr>
+              <a:t>Earlier detection</a:t>
             </a:r>
           </a:p>
           <a:p>
@@ -5786,22 +6037,22 @@
               </a:spcAft>
             </a:pPr>
             <a:r>
-              <a:rPr sz="1600" b="1">
-                <a:solidFill>
-                  <a:srgbClr val="B57A0E"/>
-                </a:solidFill>
-                <a:latin typeface="Segoe UI"/>
-              </a:rPr>
-              <a:t>·  </a:t>
-            </a:r>
-            <a:r>
-              <a:rPr sz="1600" b="0">
-                <a:solidFill>
-                  <a:srgbClr val="556677"/>
-                </a:solidFill>
-                <a:latin typeface="Segoe UI"/>
-              </a:rPr>
-              <a:t>Staged relay rollout</a:t>
+              <a:rPr sz="1300" b="1">
+                <a:solidFill>
+                  <a:srgbClr val="0B2545"/>
+                </a:solidFill>
+                <a:latin typeface="Segoe UI"/>
+              </a:rPr>
+              <a:t>▪  </a:t>
+            </a:r>
+            <a:r>
+              <a:rPr sz="1300" b="0">
+                <a:solidFill>
+                  <a:srgbClr val="1B3A5C"/>
+                </a:solidFill>
+                <a:latin typeface="Segoe UI"/>
+              </a:rPr>
+              <a:t>Faster resolution</a:t>
             </a:r>
           </a:p>
           <a:p>
@@ -5814,42 +6065,98 @@
               </a:spcAft>
             </a:pPr>
             <a:r>
-              <a:rPr sz="1600" b="1">
-                <a:solidFill>
-                  <a:srgbClr val="B57A0E"/>
-                </a:solidFill>
-                <a:latin typeface="Segoe UI"/>
-              </a:rPr>
-              <a:t>·  </a:t>
-            </a:r>
-            <a:r>
-              <a:rPr sz="1600" b="0">
-                <a:solidFill>
-                  <a:srgbClr val="556677"/>
-                </a:solidFill>
-                <a:latin typeface="Segoe UI"/>
-              </a:rPr>
-              <a:t>Automation rules</a:t>
-            </a:r>
-          </a:p>
-        </p:txBody>
-      </p:sp>
-      <p:sp>
-        <p:nvSpPr>
-          <p:cNvPr id="10" name="Rectangle 9"/>
+              <a:rPr sz="1300" b="1">
+                <a:solidFill>
+                  <a:srgbClr val="0B2545"/>
+                </a:solidFill>
+                <a:latin typeface="Segoe UI"/>
+              </a:rPr>
+              <a:t>▪  </a:t>
+            </a:r>
+            <a:r>
+              <a:rPr sz="1300" b="0">
+                <a:solidFill>
+                  <a:srgbClr val="1B3A5C"/>
+                </a:solidFill>
+                <a:latin typeface="Segoe UI"/>
+              </a:rPr>
+              <a:t>Reduced operational effort</a:t>
+            </a:r>
+          </a:p>
+          <a:p>
+            <a:pPr>
+              <a:lnSpc>
+                <a:spcPct val="105000"/>
+              </a:lnSpc>
+              <a:spcAft>
+                <a:spcPts val="700"/>
+              </a:spcAft>
+            </a:pPr>
+            <a:r>
+              <a:rPr sz="1300" b="1">
+                <a:solidFill>
+                  <a:srgbClr val="0B2545"/>
+                </a:solidFill>
+                <a:latin typeface="Segoe UI"/>
+              </a:rPr>
+              <a:t>▪  </a:t>
+            </a:r>
+            <a:r>
+              <a:rPr sz="1300" b="0">
+                <a:solidFill>
+                  <a:srgbClr val="1B3A5C"/>
+                </a:solidFill>
+                <a:latin typeface="Segoe UI"/>
+              </a:rPr>
+              <a:t>Better customer experience</a:t>
+            </a:r>
+          </a:p>
+          <a:p>
+            <a:pPr>
+              <a:lnSpc>
+                <a:spcPct val="105000"/>
+              </a:lnSpc>
+              <a:spcAft>
+                <a:spcPts val="700"/>
+              </a:spcAft>
+            </a:pPr>
+            <a:r>
+              <a:rPr sz="1300" b="1">
+                <a:solidFill>
+                  <a:srgbClr val="0B2545"/>
+                </a:solidFill>
+                <a:latin typeface="Segoe UI"/>
+              </a:rPr>
+              <a:t>▪  </a:t>
+            </a:r>
+            <a:r>
+              <a:rPr sz="1300" b="0">
+                <a:solidFill>
+                  <a:srgbClr val="1B3A5C"/>
+                </a:solidFill>
+                <a:latin typeface="Segoe UI"/>
+              </a:rPr>
+              <a:t>Improved system availability</a:t>
+            </a:r>
+          </a:p>
+        </p:txBody>
+      </p:sp>
+      <p:sp>
+        <p:nvSpPr>
+          <p:cNvPr id="11" name="Rectangle 10"/>
           <p:cNvSpPr/>
           <p:nvPr/>
         </p:nvSpPr>
         <p:spPr>
           <a:xfrm>
-            <a:off x="4319930" y="2834640"/>
-            <a:ext cx="3551834" cy="63500"/>
+            <a:off x="8097316" y="1920240"/>
+            <a:ext cx="3527450" cy="63500"/>
           </a:xfrm>
           <a:prstGeom prst="rect">
             <a:avLst/>
           </a:prstGeom>
           <a:solidFill>
-            <a:srgbClr val="B57A0E"/>
+            <a:srgbClr val="0B2545"/>
           </a:solidFill>
           <a:ln>
             <a:noFill/>
@@ -5880,14 +6187,14 @@
       </p:sp>
       <p:sp>
         <p:nvSpPr>
-          <p:cNvPr id="11" name="Rounded Rectangle 10"/>
+          <p:cNvPr id="12" name="Rounded Rectangle 11"/>
           <p:cNvSpPr/>
           <p:nvPr/>
         </p:nvSpPr>
         <p:spPr>
           <a:xfrm>
-            <a:off x="8072932" y="2834640"/>
-            <a:ext cx="3551834" cy="2560320"/>
+            <a:off x="566928" y="4882896"/>
+            <a:ext cx="3527450" cy="640080"/>
           </a:xfrm>
           <a:prstGeom prst="roundRect">
             <a:avLst>
@@ -5895,7 +6202,7 @@
             </a:avLst>
           </a:prstGeom>
           <a:solidFill>
-            <a:srgbClr val="FFFFFF"/>
+            <a:srgbClr val="F2F5F8"/>
           </a:solidFill>
           <a:ln w="12700">
             <a:solidFill>
@@ -5919,132 +6226,71 @@
           </a:fontRef>
         </p:style>
         <p:txBody>
-          <a:bodyPr rtlCol="0" anchor="ctr" wrap="square" lIns="146304" rIns="146304" tIns="146304" bIns="91440"/>
+          <a:bodyPr rtlCol="0" anchor="ctr" wrap="square" lIns="109728" rIns="109728" tIns="91440" bIns="91440"/>
           <a:lstStyle/>
           <a:p>
             <a:pPr algn="ctr">
               <a:lnSpc>
-                <a:spcPct val="115000"/>
+                <a:spcPct val="100000"/>
               </a:lnSpc>
               <a:spcAft>
-                <a:spcPts val="800"/>
+                <a:spcPts val="200"/>
               </a:spcAft>
             </a:pPr>
             <a:r>
-              <a:rPr sz="1300" b="1">
-                <a:solidFill>
-                  <a:srgbClr val="1B3A5C"/>
-                </a:solidFill>
-                <a:latin typeface="Segoe UI"/>
-              </a:rPr>
-              <a:t>NEXT</a:t>
+              <a:rPr sz="1100" b="1">
+                <a:solidFill>
+                  <a:srgbClr val="0E8C8B"/>
+                </a:solidFill>
+                <a:latin typeface="Segoe UI"/>
+              </a:rPr>
+              <a:t>COMPLETED</a:t>
             </a:r>
           </a:p>
           <a:p>
             <a:pPr>
               <a:lnSpc>
-                <a:spcPct val="105000"/>
+                <a:spcPct val="100000"/>
               </a:lnSpc>
               <a:spcAft>
-                <a:spcPts val="700"/>
+                <a:spcPts val="0"/>
               </a:spcAft>
             </a:pPr>
             <a:r>
-              <a:rPr sz="1600" b="1">
+              <a:rPr sz="1250" b="0">
                 <a:solidFill>
                   <a:srgbClr val="1B3A5C"/>
                 </a:solidFill>
                 <a:latin typeface="Segoe UI"/>
               </a:rPr>
-              <a:t>·  </a:t>
-            </a:r>
-            <a:r>
-              <a:rPr sz="1600" b="0">
-                <a:solidFill>
-                  <a:srgbClr val="556677"/>
-                </a:solidFill>
-                <a:latin typeface="Segoe UI"/>
-              </a:rPr>
-              <a:t>HL7 and PACS monitoring</a:t>
-            </a:r>
-          </a:p>
-          <a:p>
-            <a:pPr>
-              <a:lnSpc>
-                <a:spcPct val="105000"/>
-              </a:lnSpc>
-              <a:spcAft>
-                <a:spcPts val="700"/>
-              </a:spcAft>
-            </a:pPr>
-            <a:r>
-              <a:rPr sz="1600" b="1">
-                <a:solidFill>
-                  <a:srgbClr val="1B3A5C"/>
-                </a:solidFill>
-                <a:latin typeface="Segoe UI"/>
-              </a:rPr>
-              <a:t>·  </a:t>
-            </a:r>
-            <a:r>
-              <a:rPr sz="1600" b="0">
-                <a:solidFill>
-                  <a:srgbClr val="556677"/>
-                </a:solidFill>
-                <a:latin typeface="Segoe UI"/>
-              </a:rPr>
-              <a:t>Contract alerts from CRM</a:t>
-            </a:r>
-          </a:p>
-          <a:p>
-            <a:pPr>
-              <a:lnSpc>
-                <a:spcPct val="105000"/>
-              </a:lnSpc>
-              <a:spcAft>
-                <a:spcPts val="700"/>
-              </a:spcAft>
-            </a:pPr>
-            <a:r>
-              <a:rPr sz="1600" b="1">
-                <a:solidFill>
-                  <a:srgbClr val="1B3A5C"/>
-                </a:solidFill>
-                <a:latin typeface="Segoe UI"/>
-              </a:rPr>
-              <a:t>·  </a:t>
-            </a:r>
-            <a:r>
-              <a:rPr sz="1600" b="0">
-                <a:solidFill>
-                  <a:srgbClr val="556677"/>
-                </a:solidFill>
-                <a:latin typeface="Segoe UI"/>
-              </a:rPr>
-              <a:t>Plain-language ops assistant</a:t>
-            </a:r>
-          </a:p>
-        </p:txBody>
-      </p:sp>
-      <p:sp>
-        <p:nvSpPr>
-          <p:cNvPr id="12" name="Rectangle 11"/>
+              <a:t>Monitoring + automation</a:t>
+            </a:r>
+          </a:p>
+        </p:txBody>
+      </p:sp>
+      <p:sp>
+        <p:nvSpPr>
+          <p:cNvPr id="13" name="Rounded Rectangle 12"/>
           <p:cNvSpPr/>
           <p:nvPr/>
         </p:nvSpPr>
         <p:spPr>
           <a:xfrm>
-            <a:off x="8072932" y="2834640"/>
-            <a:ext cx="3551834" cy="63500"/>
-          </a:xfrm>
-          <a:prstGeom prst="rect">
-            <a:avLst/>
+            <a:off x="4332122" y="4882896"/>
+            <a:ext cx="3527450" cy="640080"/>
+          </a:xfrm>
+          <a:prstGeom prst="roundRect">
+            <a:avLst>
+              <a:gd name="adj" fmla="val 4000"/>
+            </a:avLst>
           </a:prstGeom>
           <a:solidFill>
-            <a:srgbClr val="1B3A5C"/>
+            <a:srgbClr val="F2F5F8"/>
           </a:solidFill>
-          <a:ln>
-            <a:noFill/>
+          <a:ln w="12700">
+            <a:solidFill>
+              <a:srgbClr val="D6DEE6"/>
+            </a:solidFill>
           </a:ln>
           <a:effectLst/>
         </p:spPr>
@@ -6063,23 +6309,58 @@
           </a:fontRef>
         </p:style>
         <p:txBody>
-          <a:bodyPr rtlCol="0" anchor="ctr"/>
-          <a:lstStyle/>
-          <a:p>
-            <a:pPr algn="ctr"/>
-          </a:p>
-        </p:txBody>
-      </p:sp>
-      <p:sp>
-        <p:nvSpPr>
-          <p:cNvPr id="13" name="Rounded Rectangle 12"/>
+          <a:bodyPr rtlCol="0" anchor="ctr" wrap="square" lIns="109728" rIns="109728" tIns="91440" bIns="91440"/>
+          <a:lstStyle/>
+          <a:p>
+            <a:pPr algn="ctr">
+              <a:lnSpc>
+                <a:spcPct val="100000"/>
+              </a:lnSpc>
+              <a:spcAft>
+                <a:spcPts val="200"/>
+              </a:spcAft>
+            </a:pPr>
+            <a:r>
+              <a:rPr sz="1100" b="1">
+                <a:solidFill>
+                  <a:srgbClr val="B57A0E"/>
+                </a:solidFill>
+                <a:latin typeface="Segoe UI"/>
+              </a:rPr>
+              <a:t>IN PROGRESS</a:t>
+            </a:r>
+          </a:p>
+          <a:p>
+            <a:pPr>
+              <a:lnSpc>
+                <a:spcPct val="100000"/>
+              </a:lnSpc>
+              <a:spcAft>
+                <a:spcPts val="0"/>
+              </a:spcAft>
+            </a:pPr>
+            <a:r>
+              <a:rPr sz="1250" b="0">
+                <a:solidFill>
+                  <a:srgbClr val="1B3A5C"/>
+                </a:solidFill>
+                <a:latin typeface="Segoe UI"/>
+              </a:rPr>
+              <a:t>Forecasting + queue backlog prediction</a:t>
+            </a:r>
+          </a:p>
+        </p:txBody>
+      </p:sp>
+      <p:sp>
+        <p:nvSpPr>
+          <p:cNvPr id="14" name="Rounded Rectangle 13"/>
           <p:cNvSpPr/>
           <p:nvPr/>
         </p:nvSpPr>
         <p:spPr>
           <a:xfrm>
-            <a:off x="566928" y="5541264"/>
-            <a:ext cx="3551834" cy="969264"/>
+            <a:off x="8097316" y="4882896"/>
+            <a:ext cx="3527450" cy="640080"/>
           </a:xfrm>
           <a:prstGeom prst="roundRect">
             <a:avLst>
@@ -6111,58 +6392,58 @@
           </a:fontRef>
         </p:style>
         <p:txBody>
-          <a:bodyPr rtlCol="0" anchor="ctr" wrap="square" lIns="146304" rIns="146304" tIns="91440" bIns="91440"/>
+          <a:bodyPr rtlCol="0" anchor="ctr" wrap="square" lIns="109728" rIns="109728" tIns="91440" bIns="91440"/>
           <a:lstStyle/>
           <a:p>
             <a:pPr algn="ctr">
               <a:lnSpc>
-                <a:spcPct val="115000"/>
+                <a:spcPct val="100000"/>
               </a:lnSpc>
               <a:spcAft>
-                <a:spcPts val="300"/>
+                <a:spcPts val="200"/>
               </a:spcAft>
             </a:pPr>
             <a:r>
               <a:rPr sz="1100" b="1">
                 <a:solidFill>
-                  <a:srgbClr val="0E8C8B"/>
-                </a:solidFill>
-                <a:latin typeface="Segoe UI"/>
-              </a:rPr>
-              <a:t>BUSINESS VALUE</a:t>
+                  <a:srgbClr val="1B3A5C"/>
+                </a:solidFill>
+                <a:latin typeface="Segoe UI"/>
+              </a:rPr>
+              <a:t>NEXT</a:t>
             </a:r>
           </a:p>
           <a:p>
             <a:pPr>
               <a:lnSpc>
-                <a:spcPct val="110000"/>
+                <a:spcPct val="100000"/>
               </a:lnSpc>
               <a:spcAft>
                 <a:spcPts val="0"/>
               </a:spcAft>
             </a:pPr>
             <a:r>
-              <a:rPr sz="1500" b="0">
+              <a:rPr sz="1250" b="0">
                 <a:solidFill>
                   <a:srgbClr val="1B3A5C"/>
                 </a:solidFill>
                 <a:latin typeface="Segoe UI"/>
               </a:rPr>
-              <a:t>Faster triage; fewer inbound paths to customers</a:t>
-            </a:r>
-          </a:p>
-        </p:txBody>
-      </p:sp>
-      <p:sp>
-        <p:nvSpPr>
-          <p:cNvPr id="14" name="Rounded Rectangle 13"/>
+              <a:t>AI Copilot for Operations</a:t>
+            </a:r>
+          </a:p>
+        </p:txBody>
+      </p:sp>
+      <p:sp>
+        <p:nvSpPr>
+          <p:cNvPr id="15" name="Rounded Rectangle 14"/>
           <p:cNvSpPr/>
           <p:nvPr/>
         </p:nvSpPr>
         <p:spPr>
           <a:xfrm>
-            <a:off x="4319930" y="5541264"/>
-            <a:ext cx="3551834" cy="969264"/>
+            <a:off x="566928" y="5742432"/>
+            <a:ext cx="11057839" cy="566928"/>
           </a:xfrm>
           <a:prstGeom prst="roundRect">
             <a:avLst>
@@ -6170,12 +6451,10 @@
             </a:avLst>
           </a:prstGeom>
           <a:solidFill>
-            <a:srgbClr val="F2F5F8"/>
+            <a:srgbClr val="0B2545"/>
           </a:solidFill>
-          <a:ln w="12700">
-            <a:solidFill>
-              <a:srgbClr val="D6DEE6"/>
-            </a:solidFill>
+          <a:ln>
+            <a:noFill/>
           </a:ln>
           <a:effectLst/>
         </p:spPr>
@@ -6199,122 +6478,29 @@
           <a:p>
             <a:pPr algn="ctr">
               <a:lnSpc>
-                <a:spcPct val="115000"/>
-              </a:lnSpc>
-              <a:spcAft>
-                <a:spcPts val="300"/>
-              </a:spcAft>
-            </a:pPr>
-            <a:r>
-              <a:rPr sz="1100" b="1">
-                <a:solidFill>
-                  <a:srgbClr val="0E8C8B"/>
-                </a:solidFill>
-                <a:latin typeface="Segoe UI"/>
-              </a:rPr>
-              <a:t>IMPACT / EVIDENCE</a:t>
-            </a:r>
-          </a:p>
-          <a:p>
-            <a:pPr>
-              <a:lnSpc>
-                <a:spcPct val="110000"/>
+                <a:spcPct val="100000"/>
               </a:lnSpc>
               <a:spcAft>
                 <a:spcPts val="0"/>
               </a:spcAft>
             </a:pPr>
             <a:r>
-              <a:rPr sz="1500" b="0">
-                <a:solidFill>
-                  <a:srgbClr val="1B3A5C"/>
-                </a:solidFill>
-                <a:latin typeface="Segoe UI"/>
-              </a:rPr>
-              <a:t>Expected benefits; no measured MTTR data yet</a:t>
-            </a:r>
-          </a:p>
-        </p:txBody>
-      </p:sp>
-      <p:sp>
-        <p:nvSpPr>
-          <p:cNvPr id="15" name="Rounded Rectangle 14"/>
-          <p:cNvSpPr/>
-          <p:nvPr/>
-        </p:nvSpPr>
-        <p:spPr>
-          <a:xfrm>
-            <a:off x="8072932" y="5541264"/>
-            <a:ext cx="3551834" cy="969264"/>
-          </a:xfrm>
-          <a:prstGeom prst="roundRect">
-            <a:avLst>
-              <a:gd name="adj" fmla="val 4000"/>
-            </a:avLst>
-          </a:prstGeom>
-          <a:solidFill>
-            <a:srgbClr val="F2F5F8"/>
-          </a:solidFill>
-          <a:ln w="12700">
-            <a:solidFill>
-              <a:srgbClr val="D6DEE6"/>
-            </a:solidFill>
-          </a:ln>
-          <a:effectLst/>
-        </p:spPr>
-        <p:style>
-          <a:lnRef idx="1">
-            <a:schemeClr val="accent1"/>
-          </a:lnRef>
-          <a:fillRef idx="3">
-            <a:schemeClr val="accent1"/>
-          </a:fillRef>
-          <a:effectRef idx="2">
-            <a:schemeClr val="accent1"/>
-          </a:effectRef>
-          <a:fontRef idx="minor">
-            <a:schemeClr val="lt1"/>
-          </a:fontRef>
-        </p:style>
-        <p:txBody>
-          <a:bodyPr rtlCol="0" anchor="ctr" wrap="square" lIns="146304" rIns="146304" tIns="91440" bIns="91440"/>
-          <a:lstStyle/>
-          <a:p>
-            <a:pPr algn="ctr">
-              <a:lnSpc>
-                <a:spcPct val="115000"/>
-              </a:lnSpc>
-              <a:spcAft>
-                <a:spcPts val="300"/>
-              </a:spcAft>
-            </a:pPr>
-            <a:r>
-              <a:rPr sz="1100" b="1">
-                <a:solidFill>
-                  <a:srgbClr val="0E8C8B"/>
-                </a:solidFill>
-                <a:latin typeface="Segoe UI"/>
-              </a:rPr>
-              <a:t>EFFORT &amp; DEPENDENCIES</a:t>
-            </a:r>
-          </a:p>
-          <a:p>
-            <a:pPr>
-              <a:lnSpc>
-                <a:spcPct val="110000"/>
-              </a:lnSpc>
-              <a:spcAft>
-                <a:spcPts val="0"/>
-              </a:spcAft>
-            </a:pPr>
-            <a:r>
-              <a:rPr sz="1500" b="0">
-                <a:solidFill>
-                  <a:srgbClr val="1B3A5C"/>
-                </a:solidFill>
-                <a:latin typeface="Segoe UI"/>
-              </a:rPr>
-              <a:t>Sizing to be confirmed · agent rollout, Matcha</a:t>
+              <a:rPr sz="1400" b="1">
+                <a:solidFill>
+                  <a:srgbClr val="FFFFFF"/>
+                </a:solidFill>
+                <a:latin typeface="Segoe UI"/>
+              </a:rPr>
+              <a:t>Business Benefits:  </a:t>
+            </a:r>
+            <a:r>
+              <a:rPr sz="1400" b="0">
+                <a:solidFill>
+                  <a:srgbClr val="E6F3F3"/>
+                </a:solidFill>
+                <a:latin typeface="Segoe UI"/>
+              </a:rPr>
+              <a:t>Prevent outages  |  Better planning  |  Reduced emergency work  |  Capacity optimization</a:t>
             </a:r>
           </a:p>
         </p:txBody>

</xml_diff>

<commit_message>
Redesign slide 3 as three-theme AI R&D portfolio
Co-authored-by: mohammadmoharam <223458661+mohammadmoharam@users.noreply.github.com>
</commit_message>
<xml_diff>
--- a/MS-AI/Executive-Presentation/AI-Executive-Overview.pptx
+++ b/MS-AI/Executive-Presentation/AI-Executive-Overview.pptx
@@ -989,243 +989,245 @@
           <a:lstStyle/>
           <a:p>
             <a:r>
-              <a:t>Opening: the planning material holds roughly twenty ideas. Rather than read a feature</a:t>
-            </a:r>
-          </a:p>
-          <a:p>
-            <a:r>
-              <a:t>list, I have grouped them into four investment themes and put one recommendation in front</a:t>
-            </a:r>
-          </a:p>
-          <a:p>
-            <a:r>
-              <a:t>of you.</a:t>
+              <a:t>Opening: this slide groups the next R&amp;D ideas into three priority themes rather than a long</a:t>
+            </a:r>
+          </a:p>
+          <a:p>
+            <a:r>
+              <a:t>feature list, so we can talk about where to focus rather than what exists on paper.</a:t>
             </a:r>
           </a:p>
           <a:p/>
           <a:p>
             <a:r>
-              <a:t>Why these four, and what is behind each theme (all from</a:t>
-            </a:r>
-          </a:p>
-          <a:p>
-            <a:r>
-              <a:t>MS-AI/Next Ideas/Q4 and 2027 ideas.docx):</a:t>
-            </a:r>
-          </a:p>
-          <a:p>
-            <a:r>
-              <a:t>1. Reporting quality &amp; safety — AI report discrepancy detector comparing preliminary and</a:t>
-            </a:r>
-          </a:p>
-          <a:p>
-            <a:r>
-              <a:t>   final reports (critical, major, follow-up, laterality and measurement discrepancies with</a:t>
-            </a:r>
-          </a:p>
-          <a:p>
-            <a:r>
-              <a:t>   a pre-sign-off warning), findings-vs-impression consistency checks, critical result</a:t>
-            </a:r>
-          </a:p>
-          <a:p>
-            <a:r>
-              <a:t>   detection, template completeness and a prelim-to-final quality score, plus follow-up</a:t>
-            </a:r>
-          </a:p>
-          <a:p>
-            <a:r>
-              <a:t>   recommendation tracking that creates tasks in PACS or an administrative dashboard, and</a:t>
-            </a:r>
-          </a:p>
-          <a:p>
-            <a:r>
-              <a:t>   ORU / report enrichment for referring physicians.</a:t>
-            </a:r>
-          </a:p>
-          <a:p>
-            <a:r>
-              <a:t>2. Operational intelligence — HL7 and interface issue triage from interface-engine logs,</a:t>
-            </a:r>
-          </a:p>
-          <a:p>
-            <a:r>
-              <a:t>   HL7 troubleshooting executive summary mode, AI log analysis, error-grouping over logs</a:t>
-            </a:r>
-          </a:p>
-          <a:p>
-            <a:r>
-              <a:t>   already collected, and integration of the AI dashboard with CRM contract data to raise</a:t>
-            </a:r>
-          </a:p>
-          <a:p>
-            <a:r>
-              <a:t>   alerts when storage or concurrent-user limits are exceeded.</a:t>
-            </a:r>
-          </a:p>
-          <a:p>
-            <a:r>
-              <a:t>3. Engineering productivity — the EHR Orchestrator test-automation proof of concept</a:t>
-            </a:r>
-          </a:p>
-          <a:p>
-            <a:r>
-              <a:t>   (chat-driven, record, test and AI modes across desktop and web, which already surfaced</a:t>
-            </a:r>
-          </a:p>
-          <a:p>
-            <a:r>
-              <a:t>   defects logged in TFS), natural-language codebase knowledge access, and dead-code</a:t>
-            </a:r>
-          </a:p>
-          <a:p>
-            <a:r>
-              <a:t>   cleanup.</a:t>
-            </a:r>
-          </a:p>
-          <a:p>
-            <a:r>
-              <a:t>4. PACS independence &amp; platform modernisation — removing the out-of-support EMR module and</a:t>
-            </a:r>
-          </a:p>
-          <a:p>
-            <a:r>
-              <a:t>   moving required logic to PACS, separating thick-client and web business logic with</a:t>
-            </a:r>
-          </a:p>
-          <a:p>
-            <a:r>
-              <a:t>   cross-OS file handling, an admin tool for PACS-only installations, object storage in an</a:t>
-            </a:r>
-          </a:p>
-          <a:p>
-            <a:r>
-              <a:t>   OCI bucket, and AI-generated ECG findings from ECG signals.</a:t>
+              <a:t>Why the themes matter to management: the first protects patients and reduces reporting</a:t>
+            </a:r>
+          </a:p>
+          <a:p>
+            <a:r>
+              <a:t>risk, the second reduces operational burden and improves how quickly we respond to</a:t>
+            </a:r>
+          </a:p>
+          <a:p>
+            <a:r>
+              <a:t>customers, and the third increases how much the engineering team can deliver with the</a:t>
+            </a:r>
+          </a:p>
+          <a:p>
+            <a:r>
+              <a:t>people we already have.</a:t>
             </a:r>
           </a:p>
           <a:p/>
           <a:p>
             <a:r>
-              <a:t>Deliberately kept off the slide: the market comparators — Us2.ai for automated</a:t>
-            </a:r>
-          </a:p>
-          <a:p>
-            <a:r>
-              <a:t>echocardiography reporting and Intelerad for detection and triage. They are evidence that</a:t>
-            </a:r>
-          </a:p>
-          <a:p>
-            <a:r>
-              <a:t>the market is moving toward AI measurement extraction and worklist prioritisation; they are</a:t>
-            </a:r>
-          </a:p>
-          <a:p>
-            <a:r>
-              <a:t>not our achievements and should not be presented as such. Also omitted for space: the ECG</a:t>
-            </a:r>
-          </a:p>
-          <a:p>
-            <a:r>
-              <a:t>finding generation idea, which is scientifically attractive but carries the heaviest</a:t>
-            </a:r>
-          </a:p>
-          <a:p>
-            <a:r>
-              <a:t>regulatory load, and the autonomous infrastructure-remediation agent concept.</a:t>
+              <a:t>1. Reporting Quality &amp; Safety. The AI Report Discrepancy Detector compares the preliminary</a:t>
+            </a:r>
+          </a:p>
+          <a:p>
+            <a:r>
+              <a:t>   report against the final report and flags clinically meaningful changes before sign-off -</a:t>
+            </a:r>
+          </a:p>
+          <a:p>
+            <a:r>
+              <a:t>   positive to negative findings, critical findings added or removed, severity, laterality,</a:t>
+            </a:r>
+          </a:p>
+          <a:p>
+            <a:r>
+              <a:t>   anatomy, significant measurement changes, impression conflicting with findings, and</a:t>
+            </a:r>
+          </a:p>
+          <a:p>
+            <a:r>
+              <a:t>   removed follow-up recommendations. The documented workflow is a warning before finalising</a:t>
+            </a:r>
+          </a:p>
+          <a:p>
+            <a:r>
+              <a:t>   the report: continue, revise, or add an addendum. The source also describes related</a:t>
+            </a:r>
+          </a:p>
+          <a:p>
+            <a:r>
+              <a:t>   checks - critical result detection, template completeness, and a prelim-to-final quality</a:t>
+            </a:r>
+          </a:p>
+          <a:p>
+            <a:r>
+              <a:t>   score by site, modality, provider or exam type. AI-generated ECG findings from ECG signals</a:t>
+            </a:r>
+          </a:p>
+          <a:p>
+            <a:r>
+              <a:t>   is listed as a research opportunity for structured interpretation support. In both cases</a:t>
+            </a:r>
+          </a:p>
+          <a:p>
+            <a:r>
+              <a:t>   AI assists review; it does not replace clinician judgement.</a:t>
             </a:r>
           </a:p>
           <a:p/>
           <a:p>
             <a:r>
-              <a:t>Gap to flag: secure image and report sharing was requested as a topic, but I could not find</a:t>
-            </a:r>
-          </a:p>
-          <a:p>
-            <a:r>
-              <a:t>it anywhere in the planning document. If leadership expects it in the portfolio, the idea</a:t>
-            </a:r>
-          </a:p>
-          <a:p>
-            <a:r>
-              <a:t>needs to be supplied before it can be positioned.</a:t>
+              <a:t>2. Operational Intelligence. Unified PACS / HL7 monitoring and investigation builds directly</a:t>
+            </a:r>
+          </a:p>
+          <a:p>
+            <a:r>
+              <a:t>   on the dashboard direction shown on the previous slide, and the ideas document adds</a:t>
+            </a:r>
+          </a:p>
+          <a:p>
+            <a:r>
+              <a:t>   interface issue triage from interface-engine logs (connectivity, ACK timeout, application</a:t>
+            </a:r>
+          </a:p>
+          <a:p>
+            <a:r>
+              <a:t>   reject, data validation, destination downtime) plus an executive summary mode that states</a:t>
+            </a:r>
+          </a:p>
+          <a:p>
+            <a:r>
+              <a:t>   what happened, when it started, which facility is affected and how many studies are</a:t>
+            </a:r>
+          </a:p>
+          <a:p>
+            <a:r>
+              <a:t>   impacted. Log analysis and proactive problem detection groups recurring errors, ranks them</a:t>
+            </a:r>
+          </a:p>
+          <a:p>
+            <a:r>
+              <a:t>   by severity and explains the likely cause in plain language, which cuts manual log review</a:t>
+            </a:r>
+          </a:p>
+          <a:p>
+            <a:r>
+              <a:t>   and improves support response and customer communication.</a:t>
             </a:r>
           </a:p>
           <a:p/>
           <a:p>
             <a:r>
-              <a:t>Effort basis and uncertainty: Small / Medium / Large here are preliminary R&amp;D judgements</a:t>
-            </a:r>
-          </a:p>
-          <a:p>
-            <a:r>
-              <a:t>based on documented scope and dependency breadth — discrepancy detection needs clinical</a:t>
-            </a:r>
-          </a:p>
-          <a:p>
-            <a:r>
-              <a:t>validation and sign-off workflow changes; operational intelligence largely reuses the</a:t>
-            </a:r>
-          </a:p>
-          <a:p>
-            <a:r>
-              <a:t>Sentinel platform; engineering productivity already has a working proof of concept; PACS</a:t>
-            </a:r>
-          </a:p>
-          <a:p>
-            <a:r>
-              <a:t>independence touches database, business logic and deployment across every customer. No</a:t>
-            </a:r>
-          </a:p>
-          <a:p>
-            <a:r>
-              <a:t>source contains effort figures or dates, and none of the proofs of concept justify</a:t>
-            </a:r>
-          </a:p>
-          <a:p>
-            <a:r>
-              <a:t>estimating full-product delivery. Treat all four as recommendations for discovery, not</a:t>
-            </a:r>
-          </a:p>
-          <a:p>
-            <a:r>
-              <a:t>commitments.</a:t>
+              <a:t>3. Engineering Productivity. AI-assisted test orchestration comes from the EHR Orchestrator</a:t>
+            </a:r>
+          </a:p>
+          <a:p>
+            <a:r>
+              <a:t>   proof of concept - chat-driven, record, structured test and AI modes across desktop and</a:t>
+            </a:r>
+          </a:p>
+          <a:p>
+            <a:r>
+              <a:t>   web - which already surfaced defects logged in TFS; it can reduce manual QA effort and</a:t>
+            </a:r>
+          </a:p>
+          <a:p>
+            <a:r>
+              <a:t>   make validation repeatable. An internal codebase knowledge assistant lets teams query a</a:t>
+            </a:r>
+          </a:p>
+          <a:p>
+            <a:r>
+              <a:t>   large, poorly documented codebase in natural language, reducing dependency on a few senior</a:t>
+            </a:r>
+          </a:p>
+          <a:p>
+            <a:r>
+              <a:t>   experts and shortening onboarding.</a:t>
             </a:r>
           </a:p>
           <a:p/>
           <a:p>
             <a:r>
-              <a:t>Why the recommended starting point: the discrepancy detector addresses patient-safety and</a:t>
-            </a:r>
-          </a:p>
-          <a:p>
-            <a:r>
-              <a:t>liability risk — the highest-value problem in the set — while the Sentinel HL7/PACS</a:t>
-            </a:r>
-          </a:p>
-          <a:p>
-            <a:r>
-              <a:t>extension gives the fastest return because the platform already exists. Both are testable</a:t>
-            </a:r>
-          </a:p>
-          <a:p>
-            <a:r>
-              <a:t>at small scale.</a:t>
+              <a:t>Status framing: these are candidate R&amp;D opportunities, not delivery commitments. No dates,</a:t>
+            </a:r>
+          </a:p>
+          <a:p>
+            <a:r>
+              <a:t>sizing, ROI, accuracy or production-readiness claims are implied, because the sources contain</a:t>
+            </a:r>
+          </a:p>
+          <a:p>
+            <a:r>
+              <a:t>none.</a:t>
             </a:r>
           </a:p>
           <a:p/>
           <a:p>
             <a:r>
-              <a:t>The ask: approve discovery funding for a discrepancy-detector pilot with one customer, and</a:t>
-            </a:r>
-          </a:p>
-          <a:p>
-            <a:r>
-              <a:t>confirm whether HL7/PACS monitoring belongs in the next Sentinel increment. Each of the</a:t>
-            </a:r>
-          </a:p>
-          <a:p>
-            <a:r>
-              <a:t>other themes returns with a sized proposal once discovery output is available.</a:t>
+              <a:t>Source review notes on MS-AI/Next Ideas/Q4 and 2027 ideas.docx. Other documented ideas are</a:t>
+            </a:r>
+          </a:p>
+          <a:p>
+            <a:r>
+              <a:t>intentionally not on the slide to keep it readable: follow-up recommendation tracking, ORU /</a:t>
+            </a:r>
+          </a:p>
+          <a:p>
+            <a:r>
+              <a:t>report enrichment, AI dashboard integration with CRM contract data, dead-code cleanup, EMR</a:t>
+            </a:r>
+          </a:p>
+          <a:p>
+            <a:r>
+              <a:t>dependency removal, thick-client/web separation for cross-OS support, an admin tool for</a:t>
+            </a:r>
+          </a:p>
+          <a:p>
+            <a:r>
+              <a:t>PACS-only installations, and an OCI bucket storage POC. The Us2.ai and Intelerad entries are</a:t>
+            </a:r>
+          </a:p>
+          <a:p>
+            <a:r>
+              <a:t>market comparators, not our work, and are excluded for that reason.</a:t>
+            </a:r>
+          </a:p>
+          <a:p/>
+          <a:p>
+            <a:r>
+              <a:t>Open questions to flag: several items (the log analysis platform, the log error-grouping</a:t>
+            </a:r>
+          </a:p>
+          <a:p>
+            <a:r>
+              <a:t>service and the codebase assistant) are written in the first person but reference an external</a:t>
+            </a:r>
+          </a:p>
+          <a:p>
+            <a:r>
+              <a:t>organisation, and the figures quoted there should not be presented as our results until</a:t>
+            </a:r>
+          </a:p>
+          <a:p>
+            <a:r>
+              <a:t>ownership is confirmed. Effort and sizing are deliberately absent from the slide and remain</a:t>
+            </a:r>
+          </a:p>
+          <a:p>
+            <a:r>
+              <a:t>an open analysis item for discovery. Secure image and report sharing was raised previously</a:t>
+            </a:r>
+          </a:p>
+          <a:p>
+            <a:r>
+              <a:t>but does not appear anywhere in the source document.</a:t>
+            </a:r>
+          </a:p>
+          <a:p/>
+          <a:p>
+            <a:r>
+              <a:t>The ask: the proposed decision is to select the highest-value pilots for discovery and</a:t>
+            </a:r>
+          </a:p>
+          <a:p>
+            <a:r>
+              <a:t>validation.</a:t>
             </a:r>
           </a:p>
         </p:txBody>
@@ -6604,7 +6606,7 @@
                 </a:solidFill>
                 <a:latin typeface="Segoe UI"/>
               </a:rPr>
-              <a:t>NEXT  ·  INVESTMENT OPTIONS FOR Q4 AND 2027</a:t>
+              <a:t>NEXT  ·  AI R&amp;D PORTFOLIO</a:t>
             </a:r>
           </a:p>
         </p:txBody>
@@ -6646,7 +6648,7 @@
                 </a:solidFill>
                 <a:latin typeface="Segoe UI"/>
               </a:rPr>
-              <a:t>Four Themes, One Recommended Starting Point</a:t>
+              <a:t>Future AI R&amp;D Opportunities</a:t>
             </a:r>
           </a:p>
         </p:txBody>
@@ -6688,189 +6690,204 @@
                 </a:solidFill>
                 <a:latin typeface="Segoe UI"/>
               </a:rPr>
-              <a:t>Preliminary R&amp;D sizing, not delivery commitments; full initiative list in the notes.</a:t>
-            </a:r>
-          </a:p>
-        </p:txBody>
-      </p:sp>
-      <p:sp>
-        <p:nvSpPr>
-          <p:cNvPr id="6" name="TextBox 5"/>
-          <p:cNvSpPr txBox="1"/>
+              <a:t>Focused portfolio for safer reporting, smarter operations and scalable engineering</a:t>
+            </a:r>
+          </a:p>
+        </p:txBody>
+      </p:sp>
+      <p:sp>
+        <p:nvSpPr>
+          <p:cNvPr id="6" name="Rounded Rectangle 5"/>
+          <p:cNvSpPr/>
           <p:nvPr/>
         </p:nvSpPr>
         <p:spPr>
           <a:xfrm>
-            <a:off x="658368" y="2084831"/>
-            <a:ext cx="2423160" cy="347472"/>
+            <a:off x="566928" y="2048256"/>
+            <a:ext cx="3527450" cy="3310128"/>
+          </a:xfrm>
+          <a:prstGeom prst="roundRect">
+            <a:avLst>
+              <a:gd name="adj" fmla="val 4000"/>
+            </a:avLst>
+          </a:prstGeom>
+          <a:solidFill>
+            <a:srgbClr val="FFFFFF"/>
+          </a:solidFill>
+          <a:ln w="12700">
+            <a:solidFill>
+              <a:srgbClr val="D6DEE6"/>
+            </a:solidFill>
+          </a:ln>
+          <a:effectLst/>
+        </p:spPr>
+        <p:style>
+          <a:lnRef idx="1">
+            <a:schemeClr val="accent1"/>
+          </a:lnRef>
+          <a:fillRef idx="3">
+            <a:schemeClr val="accent1"/>
+          </a:fillRef>
+          <a:effectRef idx="2">
+            <a:schemeClr val="accent1"/>
+          </a:effectRef>
+          <a:fontRef idx="minor">
+            <a:schemeClr val="lt1"/>
+          </a:fontRef>
+        </p:style>
+        <p:txBody>
+          <a:bodyPr rtlCol="0" anchor="t" wrap="square" lIns="146304" rIns="146304" tIns="182880" bIns="91440"/>
+          <a:lstStyle/>
+          <a:p>
+            <a:pPr algn="l">
+              <a:lnSpc>
+                <a:spcPct val="100000"/>
+              </a:lnSpc>
+              <a:spcAft>
+                <a:spcPts val="200"/>
+              </a:spcAft>
+            </a:pPr>
+            <a:r>
+              <a:rPr sz="1200" b="1">
+                <a:solidFill>
+                  <a:srgbClr val="0E8C8B"/>
+                </a:solidFill>
+                <a:latin typeface="Segoe UI"/>
+              </a:rPr>
+              <a:t>01</a:t>
+            </a:r>
+          </a:p>
+          <a:p>
+            <a:pPr algn="l">
+              <a:lnSpc>
+                <a:spcPct val="105000"/>
+              </a:lnSpc>
+              <a:spcAft>
+                <a:spcPts val="1000"/>
+              </a:spcAft>
+            </a:pPr>
+            <a:r>
+              <a:rPr sz="1600" b="1">
+                <a:solidFill>
+                  <a:srgbClr val="0B2545"/>
+                </a:solidFill>
+                <a:latin typeface="Segoe UI"/>
+              </a:rPr>
+              <a:t>Reporting Quality &amp; Safety</a:t>
+            </a:r>
+          </a:p>
+          <a:p>
+            <a:pPr algn="l">
+              <a:lnSpc>
+                <a:spcPct val="108000"/>
+              </a:lnSpc>
+              <a:spcAft>
+                <a:spcPts val="700"/>
+              </a:spcAft>
+            </a:pPr>
+            <a:r>
+              <a:rPr sz="1400" b="1">
+                <a:solidFill>
+                  <a:srgbClr val="0E8C8B"/>
+                </a:solidFill>
+                <a:latin typeface="Segoe UI"/>
+              </a:rPr>
+              <a:t>▪  </a:t>
+            </a:r>
+            <a:r>
+              <a:rPr sz="1400" b="0">
+                <a:solidFill>
+                  <a:srgbClr val="1B3A5C"/>
+                </a:solidFill>
+                <a:latin typeface="Segoe UI"/>
+              </a:rPr>
+              <a:t>AI Report Discrepancy Detector</a:t>
+            </a:r>
+          </a:p>
+          <a:p>
+            <a:pPr algn="l">
+              <a:lnSpc>
+                <a:spcPct val="108000"/>
+              </a:lnSpc>
+              <a:spcAft>
+                <a:spcPts val="700"/>
+              </a:spcAft>
+            </a:pPr>
+            <a:r>
+              <a:rPr sz="1400" b="1">
+                <a:solidFill>
+                  <a:srgbClr val="0E8C8B"/>
+                </a:solidFill>
+                <a:latin typeface="Segoe UI"/>
+              </a:rPr>
+              <a:t>▪  </a:t>
+            </a:r>
+            <a:r>
+              <a:rPr sz="1400" b="0">
+                <a:solidFill>
+                  <a:srgbClr val="1B3A5C"/>
+                </a:solidFill>
+                <a:latin typeface="Segoe UI"/>
+              </a:rPr>
+              <a:t>AI ECG Findings from Signals</a:t>
+            </a:r>
+          </a:p>
+        </p:txBody>
+      </p:sp>
+      <p:sp>
+        <p:nvSpPr>
+          <p:cNvPr id="7" name="Rectangle 6"/>
+          <p:cNvSpPr/>
+          <p:nvPr/>
+        </p:nvSpPr>
+        <p:spPr>
+          <a:xfrm>
+            <a:off x="566928" y="2048256"/>
+            <a:ext cx="3527450" cy="63500"/>
           </a:xfrm>
           <a:prstGeom prst="rect">
             <a:avLst/>
           </a:prstGeom>
-          <a:noFill/>
+          <a:solidFill>
+            <a:srgbClr val="0E8C8B"/>
+          </a:solidFill>
+          <a:ln>
+            <a:noFill/>
+          </a:ln>
+          <a:effectLst/>
         </p:spPr>
-        <p:txBody>
-          <a:bodyPr wrap="square" anchor="t" lIns="0" rIns="0" tIns="0" bIns="0">
-            <a:spAutoFit/>
-          </a:bodyPr>
-          <a:lstStyle/>
-          <a:p>
-            <a:pPr algn="l">
-              <a:lnSpc>
-                <a:spcPct val="115000"/>
-              </a:lnSpc>
-              <a:spcAft>
-                <a:spcPts val="0"/>
-              </a:spcAft>
-            </a:pPr>
-            <a:r>
-              <a:rPr sz="1200" b="1">
-                <a:solidFill>
-                  <a:srgbClr val="0E8C8B"/>
-                </a:solidFill>
-                <a:latin typeface="Segoe UI"/>
-              </a:rPr>
-              <a:t>THEME</a:t>
-            </a:r>
-          </a:p>
-        </p:txBody>
-      </p:sp>
-      <p:sp>
-        <p:nvSpPr>
-          <p:cNvPr id="7" name="TextBox 6"/>
-          <p:cNvSpPr txBox="1"/>
+        <p:style>
+          <a:lnRef idx="1">
+            <a:schemeClr val="accent1"/>
+          </a:lnRef>
+          <a:fillRef idx="3">
+            <a:schemeClr val="accent1"/>
+          </a:fillRef>
+          <a:effectRef idx="2">
+            <a:schemeClr val="accent1"/>
+          </a:effectRef>
+          <a:fontRef idx="minor">
+            <a:schemeClr val="lt1"/>
+          </a:fontRef>
+        </p:style>
+        <p:txBody>
+          <a:bodyPr rtlCol="0" anchor="ctr"/>
+          <a:lstStyle/>
+          <a:p>
+            <a:pPr algn="ctr"/>
+          </a:p>
+        </p:txBody>
+      </p:sp>
+      <p:sp>
+        <p:nvSpPr>
+          <p:cNvPr id="8" name="Rounded Rectangle 7"/>
+          <p:cNvSpPr/>
           <p:nvPr/>
         </p:nvSpPr>
         <p:spPr>
           <a:xfrm>
-            <a:off x="3172968" y="2084831"/>
-            <a:ext cx="3886199" cy="347472"/>
-          </a:xfrm>
-          <a:prstGeom prst="rect">
-            <a:avLst/>
-          </a:prstGeom>
-          <a:noFill/>
-        </p:spPr>
-        <p:txBody>
-          <a:bodyPr wrap="square" anchor="t" lIns="0" rIns="0" tIns="0" bIns="0">
-            <a:spAutoFit/>
-          </a:bodyPr>
-          <a:lstStyle/>
-          <a:p>
-            <a:pPr algn="l">
-              <a:lnSpc>
-                <a:spcPct val="115000"/>
-              </a:lnSpc>
-              <a:spcAft>
-                <a:spcPts val="0"/>
-              </a:spcAft>
-            </a:pPr>
-            <a:r>
-              <a:rPr sz="1200" b="1">
-                <a:solidFill>
-                  <a:srgbClr val="0E8C8B"/>
-                </a:solidFill>
-                <a:latin typeface="Segoe UI"/>
-              </a:rPr>
-              <a:t>BUSINESS VALUE</a:t>
-            </a:r>
-          </a:p>
-        </p:txBody>
-      </p:sp>
-      <p:sp>
-        <p:nvSpPr>
-          <p:cNvPr id="8" name="TextBox 7"/>
-          <p:cNvSpPr txBox="1"/>
-          <p:nvPr/>
-        </p:nvSpPr>
-        <p:spPr>
-          <a:xfrm>
-            <a:off x="7150607" y="2084831"/>
-            <a:ext cx="1325880" cy="347472"/>
-          </a:xfrm>
-          <a:prstGeom prst="rect">
-            <a:avLst/>
-          </a:prstGeom>
-          <a:noFill/>
-        </p:spPr>
-        <p:txBody>
-          <a:bodyPr wrap="square" anchor="t" lIns="0" rIns="0" tIns="0" bIns="0">
-            <a:spAutoFit/>
-          </a:bodyPr>
-          <a:lstStyle/>
-          <a:p>
-            <a:pPr algn="l">
-              <a:lnSpc>
-                <a:spcPct val="115000"/>
-              </a:lnSpc>
-              <a:spcAft>
-                <a:spcPts val="0"/>
-              </a:spcAft>
-            </a:pPr>
-            <a:r>
-              <a:rPr sz="1200" b="1">
-                <a:solidFill>
-                  <a:srgbClr val="0E8C8B"/>
-                </a:solidFill>
-                <a:latin typeface="Segoe UI"/>
-              </a:rPr>
-              <a:t>EFFORT</a:t>
-            </a:r>
-          </a:p>
-        </p:txBody>
-      </p:sp>
-      <p:sp>
-        <p:nvSpPr>
-          <p:cNvPr id="9" name="TextBox 8"/>
-          <p:cNvSpPr txBox="1"/>
-          <p:nvPr/>
-        </p:nvSpPr>
-        <p:spPr>
-          <a:xfrm>
-            <a:off x="8567927" y="2084831"/>
-            <a:ext cx="3054096" cy="347472"/>
-          </a:xfrm>
-          <a:prstGeom prst="rect">
-            <a:avLst/>
-          </a:prstGeom>
-          <a:noFill/>
-        </p:spPr>
-        <p:txBody>
-          <a:bodyPr wrap="square" anchor="t" lIns="0" rIns="0" tIns="0" bIns="0">
-            <a:spAutoFit/>
-          </a:bodyPr>
-          <a:lstStyle/>
-          <a:p>
-            <a:pPr algn="l">
-              <a:lnSpc>
-                <a:spcPct val="115000"/>
-              </a:lnSpc>
-              <a:spcAft>
-                <a:spcPts val="0"/>
-              </a:spcAft>
-            </a:pPr>
-            <a:r>
-              <a:rPr sz="1200" b="1">
-                <a:solidFill>
-                  <a:srgbClr val="0E8C8B"/>
-                </a:solidFill>
-                <a:latin typeface="Segoe UI"/>
-              </a:rPr>
-              <a:t>PROPOSED NEXT STEP</a:t>
-            </a:r>
-          </a:p>
-        </p:txBody>
-      </p:sp>
-      <p:sp>
-        <p:nvSpPr>
-          <p:cNvPr id="10" name="Rounded Rectangle 9"/>
-          <p:cNvSpPr/>
-          <p:nvPr/>
-        </p:nvSpPr>
-        <p:spPr>
-          <a:xfrm>
-            <a:off x="566928" y="2432303"/>
-            <a:ext cx="11057839" cy="731520"/>
+            <a:off x="694944" y="4133088"/>
+            <a:ext cx="3271418" cy="1078992"/>
           </a:xfrm>
           <a:prstGeom prst="roundRect">
             <a:avLst>
@@ -6900,41 +6917,117 @@
           </a:fontRef>
         </p:style>
         <p:txBody>
-          <a:bodyPr rtlCol="0" anchor="ctr" wrap="square" lIns="146304" rIns="146304" tIns="91440" bIns="91440"/>
-          <a:lstStyle/>
-          <a:p>
-            <a:pPr algn="ctr"/>
-          </a:p>
-        </p:txBody>
-      </p:sp>
-      <p:sp>
-        <p:nvSpPr>
-          <p:cNvPr id="11" name="TextBox 10"/>
-          <p:cNvSpPr txBox="1"/>
+          <a:bodyPr rtlCol="0" anchor="t" wrap="square" lIns="109728" rIns="109728" tIns="73152" bIns="73152"/>
+          <a:lstStyle/>
+          <a:p>
+            <a:pPr algn="l">
+              <a:lnSpc>
+                <a:spcPct val="100000"/>
+              </a:lnSpc>
+              <a:spcAft>
+                <a:spcPts val="300"/>
+              </a:spcAft>
+            </a:pPr>
+            <a:r>
+              <a:rPr sz="1000" b="1">
+                <a:solidFill>
+                  <a:srgbClr val="0E8C8B"/>
+                </a:solidFill>
+                <a:latin typeface="Segoe UI"/>
+              </a:rPr>
+              <a:t>VALUE</a:t>
+            </a:r>
+          </a:p>
+          <a:p>
+            <a:pPr algn="l">
+              <a:lnSpc>
+                <a:spcPct val="116000"/>
+              </a:lnSpc>
+              <a:spcAft>
+                <a:spcPts val="0"/>
+              </a:spcAft>
+            </a:pPr>
+            <a:r>
+              <a:rPr sz="1200" b="0">
+                <a:solidFill>
+                  <a:srgbClr val="556677"/>
+                </a:solidFill>
+                <a:latin typeface="Segoe UI"/>
+              </a:rPr>
+              <a:t>Safer workflows, earlier discrepancy awareness, structured interpretation support</a:t>
+            </a:r>
+          </a:p>
+        </p:txBody>
+      </p:sp>
+      <p:sp>
+        <p:nvSpPr>
+          <p:cNvPr id="9" name="Rounded Rectangle 8"/>
+          <p:cNvSpPr/>
           <p:nvPr/>
         </p:nvSpPr>
         <p:spPr>
           <a:xfrm>
-            <a:off x="658368" y="2505455"/>
-            <a:ext cx="2331720" cy="640080"/>
+            <a:off x="4332122" y="2048256"/>
+            <a:ext cx="3527450" cy="3310128"/>
           </a:xfrm>
-          <a:prstGeom prst="rect">
-            <a:avLst/>
+          <a:prstGeom prst="roundRect">
+            <a:avLst>
+              <a:gd name="adj" fmla="val 4000"/>
+            </a:avLst>
           </a:prstGeom>
-          <a:noFill/>
+          <a:solidFill>
+            <a:srgbClr val="FFFFFF"/>
+          </a:solidFill>
+          <a:ln w="12700">
+            <a:solidFill>
+              <a:srgbClr val="D6DEE6"/>
+            </a:solidFill>
+          </a:ln>
+          <a:effectLst/>
         </p:spPr>
-        <p:txBody>
-          <a:bodyPr wrap="square" anchor="ctr" lIns="0" rIns="0" tIns="0" bIns="0">
-            <a:spAutoFit/>
-          </a:bodyPr>
-          <a:lstStyle/>
+        <p:style>
+          <a:lnRef idx="1">
+            <a:schemeClr val="accent1"/>
+          </a:lnRef>
+          <a:fillRef idx="3">
+            <a:schemeClr val="accent1"/>
+          </a:fillRef>
+          <a:effectRef idx="2">
+            <a:schemeClr val="accent1"/>
+          </a:effectRef>
+          <a:fontRef idx="minor">
+            <a:schemeClr val="lt1"/>
+          </a:fontRef>
+        </p:style>
+        <p:txBody>
+          <a:bodyPr rtlCol="0" anchor="t" wrap="square" lIns="146304" rIns="146304" tIns="182880" bIns="91440"/>
+          <a:lstStyle/>
+          <a:p>
+            <a:pPr algn="l">
+              <a:lnSpc>
+                <a:spcPct val="100000"/>
+              </a:lnSpc>
+              <a:spcAft>
+                <a:spcPts val="200"/>
+              </a:spcAft>
+            </a:pPr>
+            <a:r>
+              <a:rPr sz="1200" b="1">
+                <a:solidFill>
+                  <a:srgbClr val="1B3A5C"/>
+                </a:solidFill>
+                <a:latin typeface="Segoe UI"/>
+              </a:rPr>
+              <a:t>02</a:t>
+            </a:r>
+          </a:p>
           <a:p>
             <a:pPr algn="l">
               <a:lnSpc>
                 <a:spcPct val="105000"/>
               </a:lnSpc>
               <a:spcAft>
-                <a:spcPts val="0"/>
+                <a:spcPts val="1000"/>
               </a:spcAft>
             </a:pPr>
             <a:r>
@@ -6944,315 +7037,121 @@
                 </a:solidFill>
                 <a:latin typeface="Segoe UI"/>
               </a:rPr>
-              <a:t>Reporting quality &amp; safety</a:t>
-            </a:r>
-          </a:p>
-        </p:txBody>
-      </p:sp>
-      <p:sp>
-        <p:nvSpPr>
-          <p:cNvPr id="12" name="TextBox 11"/>
-          <p:cNvSpPr txBox="1"/>
+              <a:t>Operational Intelligence</a:t>
+            </a:r>
+          </a:p>
+          <a:p>
+            <a:pPr algn="l">
+              <a:lnSpc>
+                <a:spcPct val="108000"/>
+              </a:lnSpc>
+              <a:spcAft>
+                <a:spcPts val="700"/>
+              </a:spcAft>
+            </a:pPr>
+            <a:r>
+              <a:rPr sz="1400" b="1">
+                <a:solidFill>
+                  <a:srgbClr val="1B3A5C"/>
+                </a:solidFill>
+                <a:latin typeface="Segoe UI"/>
+              </a:rPr>
+              <a:t>▪  </a:t>
+            </a:r>
+            <a:r>
+              <a:rPr sz="1400" b="0">
+                <a:solidFill>
+                  <a:srgbClr val="1B3A5C"/>
+                </a:solidFill>
+                <a:latin typeface="Segoe UI"/>
+              </a:rPr>
+              <a:t>Unified PACS / HL7 Investigation</a:t>
+            </a:r>
+          </a:p>
+          <a:p>
+            <a:pPr algn="l">
+              <a:lnSpc>
+                <a:spcPct val="108000"/>
+              </a:lnSpc>
+              <a:spcAft>
+                <a:spcPts val="700"/>
+              </a:spcAft>
+            </a:pPr>
+            <a:r>
+              <a:rPr sz="1400" b="1">
+                <a:solidFill>
+                  <a:srgbClr val="1B3A5C"/>
+                </a:solidFill>
+                <a:latin typeface="Segoe UI"/>
+              </a:rPr>
+              <a:t>▪  </a:t>
+            </a:r>
+            <a:r>
+              <a:rPr sz="1400" b="0">
+                <a:solidFill>
+                  <a:srgbClr val="1B3A5C"/>
+                </a:solidFill>
+                <a:latin typeface="Segoe UI"/>
+              </a:rPr>
+              <a:t>Proactive Log Analysis</a:t>
+            </a:r>
+          </a:p>
+        </p:txBody>
+      </p:sp>
+      <p:sp>
+        <p:nvSpPr>
+          <p:cNvPr id="10" name="Rectangle 9"/>
+          <p:cNvSpPr/>
           <p:nvPr/>
         </p:nvSpPr>
         <p:spPr>
           <a:xfrm>
-            <a:off x="3172968" y="2505455"/>
-            <a:ext cx="3794759" cy="640080"/>
+            <a:off x="4332122" y="2048256"/>
+            <a:ext cx="3527450" cy="63500"/>
           </a:xfrm>
           <a:prstGeom prst="rect">
             <a:avLst/>
           </a:prstGeom>
-          <a:noFill/>
+          <a:solidFill>
+            <a:srgbClr val="1B3A5C"/>
+          </a:solidFill>
+          <a:ln>
+            <a:noFill/>
+          </a:ln>
+          <a:effectLst/>
         </p:spPr>
-        <p:txBody>
-          <a:bodyPr wrap="square" anchor="ctr" lIns="0" rIns="0" tIns="0" bIns="0">
-            <a:spAutoFit/>
-          </a:bodyPr>
-          <a:lstStyle/>
-          <a:p>
-            <a:pPr algn="l">
-              <a:lnSpc>
-                <a:spcPct val="105000"/>
-              </a:lnSpc>
-              <a:spcAft>
-                <a:spcPts val="0"/>
-              </a:spcAft>
-            </a:pPr>
-            <a:r>
-              <a:rPr sz="1600" b="0">
-                <a:solidFill>
-                  <a:srgbClr val="556677"/>
-                </a:solidFill>
-                <a:latin typeface="Segoe UI"/>
-              </a:rPr>
-              <a:t>Catch prelim-vs-final discrepancies</a:t>
-            </a:r>
-          </a:p>
-        </p:txBody>
-      </p:sp>
-      <p:sp>
-        <p:nvSpPr>
-          <p:cNvPr id="13" name="TextBox 12"/>
-          <p:cNvSpPr txBox="1"/>
+        <p:style>
+          <a:lnRef idx="1">
+            <a:schemeClr val="accent1"/>
+          </a:lnRef>
+          <a:fillRef idx="3">
+            <a:schemeClr val="accent1"/>
+          </a:fillRef>
+          <a:effectRef idx="2">
+            <a:schemeClr val="accent1"/>
+          </a:effectRef>
+          <a:fontRef idx="minor">
+            <a:schemeClr val="lt1"/>
+          </a:fontRef>
+        </p:style>
+        <p:txBody>
+          <a:bodyPr rtlCol="0" anchor="ctr"/>
+          <a:lstStyle/>
+          <a:p>
+            <a:pPr algn="ctr"/>
+          </a:p>
+        </p:txBody>
+      </p:sp>
+      <p:sp>
+        <p:nvSpPr>
+          <p:cNvPr id="11" name="Rounded Rectangle 10"/>
+          <p:cNvSpPr/>
           <p:nvPr/>
         </p:nvSpPr>
         <p:spPr>
           <a:xfrm>
-            <a:off x="7150607" y="2505455"/>
-            <a:ext cx="1234440" cy="640080"/>
-          </a:xfrm>
-          <a:prstGeom prst="rect">
-            <a:avLst/>
-          </a:prstGeom>
-          <a:noFill/>
-        </p:spPr>
-        <p:txBody>
-          <a:bodyPr wrap="square" anchor="ctr" lIns="0" rIns="0" tIns="0" bIns="0">
-            <a:spAutoFit/>
-          </a:bodyPr>
-          <a:lstStyle/>
-          <a:p>
-            <a:pPr algn="l">
-              <a:lnSpc>
-                <a:spcPct val="105000"/>
-              </a:lnSpc>
-              <a:spcAft>
-                <a:spcPts val="0"/>
-              </a:spcAft>
-            </a:pPr>
-            <a:r>
-              <a:rPr sz="1600" b="1">
-                <a:solidFill>
-                  <a:srgbClr val="B57A0E"/>
-                </a:solidFill>
-                <a:latin typeface="Segoe UI"/>
-              </a:rPr>
-              <a:t>Medium–Large</a:t>
-            </a:r>
-          </a:p>
-        </p:txBody>
-      </p:sp>
-      <p:sp>
-        <p:nvSpPr>
-          <p:cNvPr id="14" name="TextBox 13"/>
-          <p:cNvSpPr txBox="1"/>
-          <p:nvPr/>
-        </p:nvSpPr>
-        <p:spPr>
-          <a:xfrm>
-            <a:off x="8567927" y="2505455"/>
-            <a:ext cx="2962656" cy="640080"/>
-          </a:xfrm>
-          <a:prstGeom prst="rect">
-            <a:avLst/>
-          </a:prstGeom>
-          <a:noFill/>
-        </p:spPr>
-        <p:txBody>
-          <a:bodyPr wrap="square" anchor="ctr" lIns="0" rIns="0" tIns="0" bIns="0">
-            <a:spAutoFit/>
-          </a:bodyPr>
-          <a:lstStyle/>
-          <a:p>
-            <a:pPr algn="l">
-              <a:lnSpc>
-                <a:spcPct val="105000"/>
-              </a:lnSpc>
-              <a:spcAft>
-                <a:spcPts val="0"/>
-              </a:spcAft>
-            </a:pPr>
-            <a:r>
-              <a:rPr sz="1600" b="0">
-                <a:solidFill>
-                  <a:srgbClr val="556677"/>
-                </a:solidFill>
-                <a:latin typeface="Segoe UI"/>
-              </a:rPr>
-              <a:t>Pilot with one customer</a:t>
-            </a:r>
-          </a:p>
-        </p:txBody>
-      </p:sp>
-      <p:sp>
-        <p:nvSpPr>
-          <p:cNvPr id="15" name="TextBox 14"/>
-          <p:cNvSpPr txBox="1"/>
-          <p:nvPr/>
-        </p:nvSpPr>
-        <p:spPr>
-          <a:xfrm>
-            <a:off x="658368" y="3291839"/>
-            <a:ext cx="2331720" cy="640080"/>
-          </a:xfrm>
-          <a:prstGeom prst="rect">
-            <a:avLst/>
-          </a:prstGeom>
-          <a:noFill/>
-        </p:spPr>
-        <p:txBody>
-          <a:bodyPr wrap="square" anchor="ctr" lIns="0" rIns="0" tIns="0" bIns="0">
-            <a:spAutoFit/>
-          </a:bodyPr>
-          <a:lstStyle/>
-          <a:p>
-            <a:pPr algn="l">
-              <a:lnSpc>
-                <a:spcPct val="105000"/>
-              </a:lnSpc>
-              <a:spcAft>
-                <a:spcPts val="0"/>
-              </a:spcAft>
-            </a:pPr>
-            <a:r>
-              <a:rPr sz="1600" b="1">
-                <a:solidFill>
-                  <a:srgbClr val="0B2545"/>
-                </a:solidFill>
-                <a:latin typeface="Segoe UI"/>
-              </a:rPr>
-              <a:t>Operational intelligence</a:t>
-            </a:r>
-          </a:p>
-        </p:txBody>
-      </p:sp>
-      <p:sp>
-        <p:nvSpPr>
-          <p:cNvPr id="16" name="TextBox 15"/>
-          <p:cNvSpPr txBox="1"/>
-          <p:nvPr/>
-        </p:nvSpPr>
-        <p:spPr>
-          <a:xfrm>
-            <a:off x="3172968" y="3291839"/>
-            <a:ext cx="3794759" cy="640080"/>
-          </a:xfrm>
-          <a:prstGeom prst="rect">
-            <a:avLst/>
-          </a:prstGeom>
-          <a:noFill/>
-        </p:spPr>
-        <p:txBody>
-          <a:bodyPr wrap="square" anchor="ctr" lIns="0" rIns="0" tIns="0" bIns="0">
-            <a:spAutoFit/>
-          </a:bodyPr>
-          <a:lstStyle/>
-          <a:p>
-            <a:pPr algn="l">
-              <a:lnSpc>
-                <a:spcPct val="105000"/>
-              </a:lnSpc>
-              <a:spcAft>
-                <a:spcPts val="0"/>
-              </a:spcAft>
-            </a:pPr>
-            <a:r>
-              <a:rPr sz="1600" b="0">
-                <a:solidFill>
-                  <a:srgbClr val="556677"/>
-                </a:solidFill>
-                <a:latin typeface="Segoe UI"/>
-              </a:rPr>
-              <a:t>AI triage of HL7 and interface failures</a:t>
-            </a:r>
-          </a:p>
-        </p:txBody>
-      </p:sp>
-      <p:sp>
-        <p:nvSpPr>
-          <p:cNvPr id="17" name="TextBox 16"/>
-          <p:cNvSpPr txBox="1"/>
-          <p:nvPr/>
-        </p:nvSpPr>
-        <p:spPr>
-          <a:xfrm>
-            <a:off x="7150607" y="3291839"/>
-            <a:ext cx="1234440" cy="640080"/>
-          </a:xfrm>
-          <a:prstGeom prst="rect">
-            <a:avLst/>
-          </a:prstGeom>
-          <a:noFill/>
-        </p:spPr>
-        <p:txBody>
-          <a:bodyPr wrap="square" anchor="ctr" lIns="0" rIns="0" tIns="0" bIns="0">
-            <a:spAutoFit/>
-          </a:bodyPr>
-          <a:lstStyle/>
-          <a:p>
-            <a:pPr algn="l">
-              <a:lnSpc>
-                <a:spcPct val="105000"/>
-              </a:lnSpc>
-              <a:spcAft>
-                <a:spcPts val="0"/>
-              </a:spcAft>
-            </a:pPr>
-            <a:r>
-              <a:rPr sz="1600" b="1">
-                <a:solidFill>
-                  <a:srgbClr val="B57A0E"/>
-                </a:solidFill>
-                <a:latin typeface="Segoe UI"/>
-              </a:rPr>
-              <a:t>Medium</a:t>
-            </a:r>
-          </a:p>
-        </p:txBody>
-      </p:sp>
-      <p:sp>
-        <p:nvSpPr>
-          <p:cNvPr id="18" name="TextBox 17"/>
-          <p:cNvSpPr txBox="1"/>
-          <p:nvPr/>
-        </p:nvSpPr>
-        <p:spPr>
-          <a:xfrm>
-            <a:off x="8567927" y="3291839"/>
-            <a:ext cx="2962656" cy="640080"/>
-          </a:xfrm>
-          <a:prstGeom prst="rect">
-            <a:avLst/>
-          </a:prstGeom>
-          <a:noFill/>
-        </p:spPr>
-        <p:txBody>
-          <a:bodyPr wrap="square" anchor="ctr" lIns="0" rIns="0" tIns="0" bIns="0">
-            <a:spAutoFit/>
-          </a:bodyPr>
-          <a:lstStyle/>
-          <a:p>
-            <a:pPr algn="l">
-              <a:lnSpc>
-                <a:spcPct val="105000"/>
-              </a:lnSpc>
-              <a:spcAft>
-                <a:spcPts val="0"/>
-              </a:spcAft>
-            </a:pPr>
-            <a:r>
-              <a:rPr sz="1600" b="0">
-                <a:solidFill>
-                  <a:srgbClr val="556677"/>
-                </a:solidFill>
-                <a:latin typeface="Segoe UI"/>
-              </a:rPr>
-              <a:t>Extend Sentinel to HL7 / PACS</a:t>
-            </a:r>
-          </a:p>
-        </p:txBody>
-      </p:sp>
-      <p:sp>
-        <p:nvSpPr>
-          <p:cNvPr id="19" name="Rounded Rectangle 18"/>
-          <p:cNvSpPr/>
-          <p:nvPr/>
-        </p:nvSpPr>
-        <p:spPr>
-          <a:xfrm>
-            <a:off x="566928" y="4005071"/>
-            <a:ext cx="11057839" cy="731520"/>
+            <a:off x="4460138" y="4133088"/>
+            <a:ext cx="3271418" cy="1078992"/>
           </a:xfrm>
           <a:prstGeom prst="roundRect">
             <a:avLst>
@@ -7282,41 +7181,117 @@
           </a:fontRef>
         </p:style>
         <p:txBody>
-          <a:bodyPr rtlCol="0" anchor="ctr" wrap="square" lIns="146304" rIns="146304" tIns="91440" bIns="91440"/>
-          <a:lstStyle/>
-          <a:p>
-            <a:pPr algn="ctr"/>
-          </a:p>
-        </p:txBody>
-      </p:sp>
-      <p:sp>
-        <p:nvSpPr>
-          <p:cNvPr id="20" name="TextBox 19"/>
-          <p:cNvSpPr txBox="1"/>
+          <a:bodyPr rtlCol="0" anchor="t" wrap="square" lIns="109728" rIns="109728" tIns="73152" bIns="73152"/>
+          <a:lstStyle/>
+          <a:p>
+            <a:pPr algn="l">
+              <a:lnSpc>
+                <a:spcPct val="100000"/>
+              </a:lnSpc>
+              <a:spcAft>
+                <a:spcPts val="300"/>
+              </a:spcAft>
+            </a:pPr>
+            <a:r>
+              <a:rPr sz="1000" b="1">
+                <a:solidFill>
+                  <a:srgbClr val="1B3A5C"/>
+                </a:solidFill>
+                <a:latin typeface="Segoe UI"/>
+              </a:rPr>
+              <a:t>VALUE</a:t>
+            </a:r>
+          </a:p>
+          <a:p>
+            <a:pPr algn="l">
+              <a:lnSpc>
+                <a:spcPct val="116000"/>
+              </a:lnSpc>
+              <a:spcAft>
+                <a:spcPts val="0"/>
+              </a:spcAft>
+            </a:pPr>
+            <a:r>
+              <a:rPr sz="1200" b="0">
+                <a:solidFill>
+                  <a:srgbClr val="556677"/>
+                </a:solidFill>
+                <a:latin typeface="Segoe UI"/>
+              </a:rPr>
+              <a:t>Earlier detection, faster triage and root cause, less manual investigation</a:t>
+            </a:r>
+          </a:p>
+        </p:txBody>
+      </p:sp>
+      <p:sp>
+        <p:nvSpPr>
+          <p:cNvPr id="12" name="Rounded Rectangle 11"/>
+          <p:cNvSpPr/>
           <p:nvPr/>
         </p:nvSpPr>
         <p:spPr>
           <a:xfrm>
-            <a:off x="658368" y="4078223"/>
-            <a:ext cx="2331720" cy="640080"/>
+            <a:off x="8097316" y="2048256"/>
+            <a:ext cx="3527450" cy="3310128"/>
           </a:xfrm>
-          <a:prstGeom prst="rect">
-            <a:avLst/>
+          <a:prstGeom prst="roundRect">
+            <a:avLst>
+              <a:gd name="adj" fmla="val 4000"/>
+            </a:avLst>
           </a:prstGeom>
-          <a:noFill/>
+          <a:solidFill>
+            <a:srgbClr val="FFFFFF"/>
+          </a:solidFill>
+          <a:ln w="12700">
+            <a:solidFill>
+              <a:srgbClr val="D6DEE6"/>
+            </a:solidFill>
+          </a:ln>
+          <a:effectLst/>
         </p:spPr>
-        <p:txBody>
-          <a:bodyPr wrap="square" anchor="ctr" lIns="0" rIns="0" tIns="0" bIns="0">
-            <a:spAutoFit/>
-          </a:bodyPr>
-          <a:lstStyle/>
+        <p:style>
+          <a:lnRef idx="1">
+            <a:schemeClr val="accent1"/>
+          </a:lnRef>
+          <a:fillRef idx="3">
+            <a:schemeClr val="accent1"/>
+          </a:fillRef>
+          <a:effectRef idx="2">
+            <a:schemeClr val="accent1"/>
+          </a:effectRef>
+          <a:fontRef idx="minor">
+            <a:schemeClr val="lt1"/>
+          </a:fontRef>
+        </p:style>
+        <p:txBody>
+          <a:bodyPr rtlCol="0" anchor="t" wrap="square" lIns="146304" rIns="146304" tIns="182880" bIns="91440"/>
+          <a:lstStyle/>
+          <a:p>
+            <a:pPr algn="l">
+              <a:lnSpc>
+                <a:spcPct val="100000"/>
+              </a:lnSpc>
+              <a:spcAft>
+                <a:spcPts val="200"/>
+              </a:spcAft>
+            </a:pPr>
+            <a:r>
+              <a:rPr sz="1200" b="1">
+                <a:solidFill>
+                  <a:srgbClr val="0B2545"/>
+                </a:solidFill>
+                <a:latin typeface="Segoe UI"/>
+              </a:rPr>
+              <a:t>03</a:t>
+            </a:r>
+          </a:p>
           <a:p>
             <a:pPr algn="l">
               <a:lnSpc>
                 <a:spcPct val="105000"/>
               </a:lnSpc>
               <a:spcAft>
-                <a:spcPts val="0"/>
+                <a:spcPts val="1000"/>
               </a:spcAft>
             </a:pPr>
             <a:r>
@@ -7326,315 +7301,202 @@
                 </a:solidFill>
                 <a:latin typeface="Segoe UI"/>
               </a:rPr>
-              <a:t>Engineering productivity</a:t>
-            </a:r>
-          </a:p>
-        </p:txBody>
-      </p:sp>
-      <p:sp>
-        <p:nvSpPr>
-          <p:cNvPr id="21" name="TextBox 20"/>
-          <p:cNvSpPr txBox="1"/>
+              <a:t>Engineering Productivity</a:t>
+            </a:r>
+          </a:p>
+          <a:p>
+            <a:pPr algn="l">
+              <a:lnSpc>
+                <a:spcPct val="108000"/>
+              </a:lnSpc>
+              <a:spcAft>
+                <a:spcPts val="700"/>
+              </a:spcAft>
+            </a:pPr>
+            <a:r>
+              <a:rPr sz="1400" b="1">
+                <a:solidFill>
+                  <a:srgbClr val="0B2545"/>
+                </a:solidFill>
+                <a:latin typeface="Segoe UI"/>
+              </a:rPr>
+              <a:t>▪  </a:t>
+            </a:r>
+            <a:r>
+              <a:rPr sz="1400" b="0">
+                <a:solidFill>
+                  <a:srgbClr val="1B3A5C"/>
+                </a:solidFill>
+                <a:latin typeface="Segoe UI"/>
+              </a:rPr>
+              <a:t>AI-Assisted Test Orchestration</a:t>
+            </a:r>
+          </a:p>
+          <a:p>
+            <a:pPr algn="l">
+              <a:lnSpc>
+                <a:spcPct val="108000"/>
+              </a:lnSpc>
+              <a:spcAft>
+                <a:spcPts val="700"/>
+              </a:spcAft>
+            </a:pPr>
+            <a:r>
+              <a:rPr sz="1400" b="1">
+                <a:solidFill>
+                  <a:srgbClr val="0B2545"/>
+                </a:solidFill>
+                <a:latin typeface="Segoe UI"/>
+              </a:rPr>
+              <a:t>▪  </a:t>
+            </a:r>
+            <a:r>
+              <a:rPr sz="1400" b="0">
+                <a:solidFill>
+                  <a:srgbClr val="1B3A5C"/>
+                </a:solidFill>
+                <a:latin typeface="Segoe UI"/>
+              </a:rPr>
+              <a:t>Codebase Knowledge Assistant</a:t>
+            </a:r>
+          </a:p>
+        </p:txBody>
+      </p:sp>
+      <p:sp>
+        <p:nvSpPr>
+          <p:cNvPr id="13" name="Rectangle 12"/>
+          <p:cNvSpPr/>
           <p:nvPr/>
         </p:nvSpPr>
         <p:spPr>
           <a:xfrm>
-            <a:off x="3172968" y="4078223"/>
-            <a:ext cx="3794759" cy="640080"/>
+            <a:off x="8097316" y="2048256"/>
+            <a:ext cx="3527450" cy="63500"/>
           </a:xfrm>
           <a:prstGeom prst="rect">
             <a:avLst/>
           </a:prstGeom>
-          <a:noFill/>
+          <a:solidFill>
+            <a:srgbClr val="0B2545"/>
+          </a:solidFill>
+          <a:ln>
+            <a:noFill/>
+          </a:ln>
+          <a:effectLst/>
         </p:spPr>
-        <p:txBody>
-          <a:bodyPr wrap="square" anchor="ctr" lIns="0" rIns="0" tIns="0" bIns="0">
-            <a:spAutoFit/>
-          </a:bodyPr>
+        <p:style>
+          <a:lnRef idx="1">
+            <a:schemeClr val="accent1"/>
+          </a:lnRef>
+          <a:fillRef idx="3">
+            <a:schemeClr val="accent1"/>
+          </a:fillRef>
+          <a:effectRef idx="2">
+            <a:schemeClr val="accent1"/>
+          </a:effectRef>
+          <a:fontRef idx="minor">
+            <a:schemeClr val="lt1"/>
+          </a:fontRef>
+        </p:style>
+        <p:txBody>
+          <a:bodyPr rtlCol="0" anchor="ctr"/>
+          <a:lstStyle/>
+          <a:p>
+            <a:pPr algn="ctr"/>
+          </a:p>
+        </p:txBody>
+      </p:sp>
+      <p:sp>
+        <p:nvSpPr>
+          <p:cNvPr id="14" name="Rounded Rectangle 13"/>
+          <p:cNvSpPr/>
+          <p:nvPr/>
+        </p:nvSpPr>
+        <p:spPr>
+          <a:xfrm>
+            <a:off x="8225332" y="4133088"/>
+            <a:ext cx="3271418" cy="1078992"/>
+          </a:xfrm>
+          <a:prstGeom prst="roundRect">
+            <a:avLst>
+              <a:gd name="adj" fmla="val 8000"/>
+            </a:avLst>
+          </a:prstGeom>
+          <a:solidFill>
+            <a:srgbClr val="F2F5F8"/>
+          </a:solidFill>
+          <a:ln>
+            <a:noFill/>
+          </a:ln>
+          <a:effectLst/>
+        </p:spPr>
+        <p:style>
+          <a:lnRef idx="1">
+            <a:schemeClr val="accent1"/>
+          </a:lnRef>
+          <a:fillRef idx="3">
+            <a:schemeClr val="accent1"/>
+          </a:fillRef>
+          <a:effectRef idx="2">
+            <a:schemeClr val="accent1"/>
+          </a:effectRef>
+          <a:fontRef idx="minor">
+            <a:schemeClr val="lt1"/>
+          </a:fontRef>
+        </p:style>
+        <p:txBody>
+          <a:bodyPr rtlCol="0" anchor="t" wrap="square" lIns="109728" rIns="109728" tIns="73152" bIns="73152"/>
           <a:lstStyle/>
           <a:p>
             <a:pPr algn="l">
               <a:lnSpc>
-                <a:spcPct val="105000"/>
+                <a:spcPct val="100000"/>
+              </a:lnSpc>
+              <a:spcAft>
+                <a:spcPts val="300"/>
+              </a:spcAft>
+            </a:pPr>
+            <a:r>
+              <a:rPr sz="1000" b="1">
+                <a:solidFill>
+                  <a:srgbClr val="0B2545"/>
+                </a:solidFill>
+                <a:latin typeface="Segoe UI"/>
+              </a:rPr>
+              <a:t>VALUE</a:t>
+            </a:r>
+          </a:p>
+          <a:p>
+            <a:pPr algn="l">
+              <a:lnSpc>
+                <a:spcPct val="116000"/>
               </a:lnSpc>
               <a:spcAft>
                 <a:spcPts val="0"/>
               </a:spcAft>
             </a:pPr>
             <a:r>
-              <a:rPr sz="1600" b="0">
+              <a:rPr sz="1200" b="0">
                 <a:solidFill>
                   <a:srgbClr val="556677"/>
                 </a:solidFill>
                 <a:latin typeface="Segoe UI"/>
               </a:rPr>
-              <a:t>AI test automation and codebase access</a:t>
-            </a:r>
-          </a:p>
-        </p:txBody>
-      </p:sp>
-      <p:sp>
-        <p:nvSpPr>
-          <p:cNvPr id="22" name="TextBox 21"/>
-          <p:cNvSpPr txBox="1"/>
+              <a:t>Faster validation, better regression coverage, reusable knowledge</a:t>
+            </a:r>
+          </a:p>
+        </p:txBody>
+      </p:sp>
+      <p:sp>
+        <p:nvSpPr>
+          <p:cNvPr id="15" name="Rounded Rectangle 14"/>
+          <p:cNvSpPr/>
           <p:nvPr/>
         </p:nvSpPr>
         <p:spPr>
           <a:xfrm>
-            <a:off x="7150607" y="4078223"/>
-            <a:ext cx="1234440" cy="640080"/>
-          </a:xfrm>
-          <a:prstGeom prst="rect">
-            <a:avLst/>
-          </a:prstGeom>
-          <a:noFill/>
-        </p:spPr>
-        <p:txBody>
-          <a:bodyPr wrap="square" anchor="ctr" lIns="0" rIns="0" tIns="0" bIns="0">
-            <a:spAutoFit/>
-          </a:bodyPr>
-          <a:lstStyle/>
-          <a:p>
-            <a:pPr algn="l">
-              <a:lnSpc>
-                <a:spcPct val="105000"/>
-              </a:lnSpc>
-              <a:spcAft>
-                <a:spcPts val="0"/>
-              </a:spcAft>
-            </a:pPr>
-            <a:r>
-              <a:rPr sz="1600" b="1">
-                <a:solidFill>
-                  <a:srgbClr val="B57A0E"/>
-                </a:solidFill>
-                <a:latin typeface="Segoe UI"/>
-              </a:rPr>
-              <a:t>Small–Medium</a:t>
-            </a:r>
-          </a:p>
-        </p:txBody>
-      </p:sp>
-      <p:sp>
-        <p:nvSpPr>
-          <p:cNvPr id="23" name="TextBox 22"/>
-          <p:cNvSpPr txBox="1"/>
-          <p:nvPr/>
-        </p:nvSpPr>
-        <p:spPr>
-          <a:xfrm>
-            <a:off x="8567927" y="4078223"/>
-            <a:ext cx="2962656" cy="640080"/>
-          </a:xfrm>
-          <a:prstGeom prst="rect">
-            <a:avLst/>
-          </a:prstGeom>
-          <a:noFill/>
-        </p:spPr>
-        <p:txBody>
-          <a:bodyPr wrap="square" anchor="ctr" lIns="0" rIns="0" tIns="0" bIns="0">
-            <a:spAutoFit/>
-          </a:bodyPr>
-          <a:lstStyle/>
-          <a:p>
-            <a:pPr algn="l">
-              <a:lnSpc>
-                <a:spcPct val="105000"/>
-              </a:lnSpc>
-              <a:spcAft>
-                <a:spcPts val="0"/>
-              </a:spcAft>
-            </a:pPr>
-            <a:r>
-              <a:rPr sz="1600" b="0">
-                <a:solidFill>
-                  <a:srgbClr val="556677"/>
-                </a:solidFill>
-                <a:latin typeface="Segoe UI"/>
-              </a:rPr>
-              <a:t>Continue the existing POC</a:t>
-            </a:r>
-          </a:p>
-        </p:txBody>
-      </p:sp>
-      <p:sp>
-        <p:nvSpPr>
-          <p:cNvPr id="24" name="TextBox 23"/>
-          <p:cNvSpPr txBox="1"/>
-          <p:nvPr/>
-        </p:nvSpPr>
-        <p:spPr>
-          <a:xfrm>
-            <a:off x="658368" y="4864607"/>
-            <a:ext cx="2331720" cy="640080"/>
-          </a:xfrm>
-          <a:prstGeom prst="rect">
-            <a:avLst/>
-          </a:prstGeom>
-          <a:noFill/>
-        </p:spPr>
-        <p:txBody>
-          <a:bodyPr wrap="square" anchor="ctr" lIns="0" rIns="0" tIns="0" bIns="0">
-            <a:spAutoFit/>
-          </a:bodyPr>
-          <a:lstStyle/>
-          <a:p>
-            <a:pPr algn="l">
-              <a:lnSpc>
-                <a:spcPct val="105000"/>
-              </a:lnSpc>
-              <a:spcAft>
-                <a:spcPts val="0"/>
-              </a:spcAft>
-            </a:pPr>
-            <a:r>
-              <a:rPr sz="1600" b="1">
-                <a:solidFill>
-                  <a:srgbClr val="0B2545"/>
-                </a:solidFill>
-                <a:latin typeface="Segoe UI"/>
-              </a:rPr>
-              <a:t>PACS independence &amp; platform</a:t>
-            </a:r>
-          </a:p>
-        </p:txBody>
-      </p:sp>
-      <p:sp>
-        <p:nvSpPr>
-          <p:cNvPr id="25" name="TextBox 24"/>
-          <p:cNvSpPr txBox="1"/>
-          <p:nvPr/>
-        </p:nvSpPr>
-        <p:spPr>
-          <a:xfrm>
-            <a:off x="3172968" y="4864607"/>
-            <a:ext cx="3794759" cy="640080"/>
-          </a:xfrm>
-          <a:prstGeom prst="rect">
-            <a:avLst/>
-          </a:prstGeom>
-          <a:noFill/>
-        </p:spPr>
-        <p:txBody>
-          <a:bodyPr wrap="square" anchor="ctr" lIns="0" rIns="0" tIns="0" bIns="0">
-            <a:spAutoFit/>
-          </a:bodyPr>
-          <a:lstStyle/>
-          <a:p>
-            <a:pPr algn="l">
-              <a:lnSpc>
-                <a:spcPct val="105000"/>
-              </a:lnSpc>
-              <a:spcAft>
-                <a:spcPts val="0"/>
-              </a:spcAft>
-            </a:pPr>
-            <a:r>
-              <a:rPr sz="1600" b="0">
-                <a:solidFill>
-                  <a:srgbClr val="556677"/>
-                </a:solidFill>
-                <a:latin typeface="Segoe UI"/>
-              </a:rPr>
-              <a:t>Retire EMR dependency; object storage</a:t>
-            </a:r>
-          </a:p>
-        </p:txBody>
-      </p:sp>
-      <p:sp>
-        <p:nvSpPr>
-          <p:cNvPr id="26" name="TextBox 25"/>
-          <p:cNvSpPr txBox="1"/>
-          <p:nvPr/>
-        </p:nvSpPr>
-        <p:spPr>
-          <a:xfrm>
-            <a:off x="7150607" y="4864607"/>
-            <a:ext cx="1234440" cy="640080"/>
-          </a:xfrm>
-          <a:prstGeom prst="rect">
-            <a:avLst/>
-          </a:prstGeom>
-          <a:noFill/>
-        </p:spPr>
-        <p:txBody>
-          <a:bodyPr wrap="square" anchor="ctr" lIns="0" rIns="0" tIns="0" bIns="0">
-            <a:spAutoFit/>
-          </a:bodyPr>
-          <a:lstStyle/>
-          <a:p>
-            <a:pPr algn="l">
-              <a:lnSpc>
-                <a:spcPct val="105000"/>
-              </a:lnSpc>
-              <a:spcAft>
-                <a:spcPts val="0"/>
-              </a:spcAft>
-            </a:pPr>
-            <a:r>
-              <a:rPr sz="1600" b="1">
-                <a:solidFill>
-                  <a:srgbClr val="B57A0E"/>
-                </a:solidFill>
-                <a:latin typeface="Segoe UI"/>
-              </a:rPr>
-              <a:t>Large</a:t>
-            </a:r>
-          </a:p>
-        </p:txBody>
-      </p:sp>
-      <p:sp>
-        <p:nvSpPr>
-          <p:cNvPr id="27" name="TextBox 26"/>
-          <p:cNvSpPr txBox="1"/>
-          <p:nvPr/>
-        </p:nvSpPr>
-        <p:spPr>
-          <a:xfrm>
-            <a:off x="8567927" y="4864607"/>
-            <a:ext cx="2962656" cy="640080"/>
-          </a:xfrm>
-          <a:prstGeom prst="rect">
-            <a:avLst/>
-          </a:prstGeom>
-          <a:noFill/>
-        </p:spPr>
-        <p:txBody>
-          <a:bodyPr wrap="square" anchor="ctr" lIns="0" rIns="0" tIns="0" bIns="0">
-            <a:spAutoFit/>
-          </a:bodyPr>
-          <a:lstStyle/>
-          <a:p>
-            <a:pPr algn="l">
-              <a:lnSpc>
-                <a:spcPct val="105000"/>
-              </a:lnSpc>
-              <a:spcAft>
-                <a:spcPts val="0"/>
-              </a:spcAft>
-            </a:pPr>
-            <a:r>
-              <a:rPr sz="1600" b="0">
-                <a:solidFill>
-                  <a:srgbClr val="556677"/>
-                </a:solidFill>
-                <a:latin typeface="Segoe UI"/>
-              </a:rPr>
-              <a:t>Run the object-storage POC first</a:t>
-            </a:r>
-          </a:p>
-        </p:txBody>
-      </p:sp>
-      <p:sp>
-        <p:nvSpPr>
-          <p:cNvPr id="28" name="Rounded Rectangle 27"/>
-          <p:cNvSpPr/>
-          <p:nvPr/>
-        </p:nvSpPr>
-        <p:spPr>
-          <a:xfrm>
-            <a:off x="566928" y="5705855"/>
-            <a:ext cx="11057839" cy="841248"/>
+            <a:off x="566928" y="5632704"/>
+            <a:ext cx="11057839" cy="640080"/>
           </a:xfrm>
           <a:prstGeom prst="roundRect">
             <a:avLst>
@@ -7669,39 +7531,29 @@
           <a:p>
             <a:pPr algn="ctr">
               <a:lnSpc>
-                <a:spcPct val="115000"/>
-              </a:lnSpc>
-              <a:spcAft>
-                <a:spcPts val="400"/>
-              </a:spcAft>
-            </a:pPr>
-            <a:r>
-              <a:rPr sz="1100" b="1">
-                <a:solidFill>
-                  <a:srgbClr val="E6F3F3"/>
-                </a:solidFill>
-                <a:latin typeface="Segoe UI"/>
-              </a:rPr>
-              <a:t>RECOMMENDATION — NO ASK DOCUMENTED IN SOURCES</a:t>
-            </a:r>
-          </a:p>
-          <a:p>
-            <a:pPr>
-              <a:lnSpc>
-                <a:spcPct val="105000"/>
+                <a:spcPct val="100000"/>
               </a:lnSpc>
               <a:spcAft>
                 <a:spcPts val="0"/>
               </a:spcAft>
             </a:pPr>
             <a:r>
-              <a:rPr sz="1800" b="1">
+              <a:rPr sz="1500" b="1">
                 <a:solidFill>
                   <a:srgbClr val="FFFFFF"/>
                 </a:solidFill>
                 <a:latin typeface="Segoe UI"/>
               </a:rPr>
-              <a:t>Approve discovery funding for the discrepancy detector; confirm HL7/PACS in the next Sentinel increment.</a:t>
+              <a:t>Portfolio intent:  </a:t>
+            </a:r>
+            <a:r>
+              <a:rPr sz="1500" b="0">
+                <a:solidFill>
+                  <a:srgbClr val="E6F3F3"/>
+                </a:solidFill>
+                <a:latin typeface="Segoe UI"/>
+              </a:rPr>
+              <a:t>Prioritize pilots that improve safety, reduce operational burden and scale team productivity.</a:t>
             </a:r>
           </a:p>
         </p:txBody>

</xml_diff>

<commit_message>
Add linked AI Dashboard screenshot appendix to executive deck
Co-authored-by: mohammadmoharam <223458661+mohammadmoharam@users.noreply.github.com>
</commit_message>
<xml_diff>
--- a/MS-AI/Executive-Presentation/AI-Executive-Overview.pptx
+++ b/MS-AI/Executive-Presentation/AI-Executive-Overview.pptx
@@ -8,6 +8,10 @@
     <p:sldId id="256" r:id="rId7"/>
     <p:sldId id="257" r:id="rId9"/>
     <p:sldId id="258" r:id="rId10"/>
+    <p:sldId id="259" r:id="rId11"/>
+    <p:sldId id="260" r:id="rId12"/>
+    <p:sldId id="261" r:id="rId13"/>
+    <p:sldId id="262" r:id="rId14"/>
   </p:sldIdLst>
   <p:sldSz cx="12191695" cy="6858000" type="screen4x3"/>
   <p:notesSz cx="6858000" cy="9144000"/>
@@ -1228,6 +1232,390 @@
           <a:p>
             <a:r>
               <a:t>validation.</a:t>
+            </a:r>
+          </a:p>
+        </p:txBody>
+      </p:sp>
+      <p:sp>
+        <p:nvSpPr>
+          <p:cNvPr id="4" name="Slide Number Placeholder 3"/>
+          <p:cNvSpPr>
+            <a:spLocks noGrp="1"/>
+          </p:cNvSpPr>
+          <p:nvPr>
+            <p:ph type="sldNum" idx="5" sz="quarter"/>
+          </p:nvPr>
+        </p:nvSpPr>
+        <p:spPr/>
+      </p:sp>
+    </p:spTree>
+  </p:cSld>
+  <p:clrMapOvr>
+    <a:masterClrMapping/>
+  </p:clrMapOvr>
+</p:notes>
+</file>
+
+<file path=ppt/notesSlides/notesSlide4.xml><?xml version="1.0" encoding="utf-8"?>
+<p:notes xmlns:a="http://schemas.openxmlformats.org/drawingml/2006/main" xmlns:p="http://schemas.openxmlformats.org/presentationml/2006/main" xmlns:r="http://schemas.openxmlformats.org/officeDocument/2006/relationships">
+  <p:cSld>
+    <p:spTree>
+      <p:nvGrpSpPr>
+        <p:cNvPr id="1" name=""/>
+        <p:cNvGrpSpPr/>
+        <p:nvPr/>
+      </p:nvGrpSpPr>
+      <p:grpSpPr>
+        <a:xfrm>
+          <a:off x="0" y="0"/>
+          <a:ext cx="0" cy="0"/>
+          <a:chOff x="0" y="0"/>
+          <a:chExt cx="0" cy="0"/>
+        </a:xfrm>
+      </p:grpSpPr>
+      <p:sp>
+        <p:nvSpPr>
+          <p:cNvPr id="2" name="Slide Image Placeholder 1"/>
+          <p:cNvSpPr>
+            <a:spLocks noGrp="1"/>
+          </p:cNvSpPr>
+          <p:nvPr>
+            <p:ph type="sldImg" idx="2"/>
+          </p:nvPr>
+        </p:nvSpPr>
+        <p:spPr/>
+      </p:sp>
+      <p:sp>
+        <p:nvSpPr>
+          <p:cNvPr id="3" name="Notes Placeholder 2"/>
+          <p:cNvSpPr>
+            <a:spLocks noGrp="1"/>
+          </p:cNvSpPr>
+          <p:nvPr>
+            <p:ph type="body" idx="3" sz="quarter"/>
+          </p:nvPr>
+        </p:nvSpPr>
+        <p:spPr/>
+        <p:txBody>
+          <a:bodyPr/>
+          <a:lstStyle/>
+          <a:p>
+            <a:r>
+              <a:t>Supporting screenshot 1 of 4 for the AI Operations Intelligence</a:t>
+            </a:r>
+          </a:p>
+          <a:p>
+            <a:r>
+              <a:t>Dashboard (slide 2): Storage Monitoring — Drive usage and capacity planning with AI volume-capacity forecasts. Optional deep dive only; it is not part</a:t>
+            </a:r>
+          </a:p>
+          <a:p>
+            <a:r>
+              <a:t>of the three-slide executive story. Use "Back to Slide 2" to return to the main flow.</a:t>
+            </a:r>
+          </a:p>
+          <a:p/>
+          <a:p>
+            <a:r>
+              <a:t>Source image: MS-AI/AI Dashboard/Screenshots/Screenshot_1.png, MS-TEST environment. The signed-in</a:t>
+            </a:r>
+          </a:p>
+          <a:p>
+            <a:r>
+              <a:t>user chip (and, on the automation slide, the requester email address) is pixelated; no</a:t>
+            </a:r>
+          </a:p>
+          <a:p>
+            <a:r>
+              <a:t>credentials, API keys, patient data or configuration secrets are shown.</a:t>
+            </a:r>
+          </a:p>
+        </p:txBody>
+      </p:sp>
+      <p:sp>
+        <p:nvSpPr>
+          <p:cNvPr id="4" name="Slide Number Placeholder 3"/>
+          <p:cNvSpPr>
+            <a:spLocks noGrp="1"/>
+          </p:cNvSpPr>
+          <p:nvPr>
+            <p:ph type="sldNum" idx="5" sz="quarter"/>
+          </p:nvPr>
+        </p:nvSpPr>
+        <p:spPr/>
+      </p:sp>
+    </p:spTree>
+  </p:cSld>
+  <p:clrMapOvr>
+    <a:masterClrMapping/>
+  </p:clrMapOvr>
+</p:notes>
+</file>
+
+<file path=ppt/notesSlides/notesSlide5.xml><?xml version="1.0" encoding="utf-8"?>
+<p:notes xmlns:a="http://schemas.openxmlformats.org/drawingml/2006/main" xmlns:p="http://schemas.openxmlformats.org/presentationml/2006/main" xmlns:r="http://schemas.openxmlformats.org/officeDocument/2006/relationships">
+  <p:cSld>
+    <p:spTree>
+      <p:nvGrpSpPr>
+        <p:cNvPr id="1" name=""/>
+        <p:cNvGrpSpPr/>
+        <p:nvPr/>
+      </p:nvGrpSpPr>
+      <p:grpSpPr>
+        <a:xfrm>
+          <a:off x="0" y="0"/>
+          <a:ext cx="0" cy="0"/>
+          <a:chOff x="0" y="0"/>
+          <a:chExt cx="0" cy="0"/>
+        </a:xfrm>
+      </p:grpSpPr>
+      <p:sp>
+        <p:nvSpPr>
+          <p:cNvPr id="2" name="Slide Image Placeholder 1"/>
+          <p:cNvSpPr>
+            <a:spLocks noGrp="1"/>
+          </p:cNvSpPr>
+          <p:nvPr>
+            <p:ph type="sldImg" idx="2"/>
+          </p:nvPr>
+        </p:nvSpPr>
+        <p:spPr/>
+      </p:sp>
+      <p:sp>
+        <p:nvSpPr>
+          <p:cNvPr id="3" name="Notes Placeholder 2"/>
+          <p:cNvSpPr>
+            <a:spLocks noGrp="1"/>
+          </p:cNvSpPr>
+          <p:nvPr>
+            <p:ph type="body" idx="3" sz="quarter"/>
+          </p:nvPr>
+        </p:nvSpPr>
+        <p:spPr/>
+        <p:txBody>
+          <a:bodyPr/>
+          <a:lstStyle/>
+          <a:p>
+            <a:r>
+              <a:t>Supporting screenshot 2 of 4 for the AI Operations Intelligence</a:t>
+            </a:r>
+          </a:p>
+          <a:p>
+            <a:r>
+              <a:t>Dashboard (slide 2): CPU &amp; Memory Process Insights — Top resource consumers per server. Optional deep dive only; it is not part</a:t>
+            </a:r>
+          </a:p>
+          <a:p>
+            <a:r>
+              <a:t>of the three-slide executive story. Use "Back to Slide 2" to return to the main flow.</a:t>
+            </a:r>
+          </a:p>
+          <a:p/>
+          <a:p>
+            <a:r>
+              <a:t>Source image: MS-AI/AI Dashboard/Screenshots/Screenshot_2.png, MS-TEST environment. The signed-in</a:t>
+            </a:r>
+          </a:p>
+          <a:p>
+            <a:r>
+              <a:t>user chip (and, on the automation slide, the requester email address) is pixelated; no</a:t>
+            </a:r>
+          </a:p>
+          <a:p>
+            <a:r>
+              <a:t>credentials, API keys, patient data or configuration secrets are shown.</a:t>
+            </a:r>
+          </a:p>
+        </p:txBody>
+      </p:sp>
+      <p:sp>
+        <p:nvSpPr>
+          <p:cNvPr id="4" name="Slide Number Placeholder 3"/>
+          <p:cNvSpPr>
+            <a:spLocks noGrp="1"/>
+          </p:cNvSpPr>
+          <p:nvPr>
+            <p:ph type="sldNum" idx="5" sz="quarter"/>
+          </p:nvPr>
+        </p:nvSpPr>
+        <p:spPr/>
+      </p:sp>
+    </p:spTree>
+  </p:cSld>
+  <p:clrMapOvr>
+    <a:masterClrMapping/>
+  </p:clrMapOvr>
+</p:notes>
+</file>
+
+<file path=ppt/notesSlides/notesSlide6.xml><?xml version="1.0" encoding="utf-8"?>
+<p:notes xmlns:a="http://schemas.openxmlformats.org/drawingml/2006/main" xmlns:p="http://schemas.openxmlformats.org/presentationml/2006/main" xmlns:r="http://schemas.openxmlformats.org/officeDocument/2006/relationships">
+  <p:cSld>
+    <p:spTree>
+      <p:nvGrpSpPr>
+        <p:cNvPr id="1" name=""/>
+        <p:cNvGrpSpPr/>
+        <p:nvPr/>
+      </p:nvGrpSpPr>
+      <p:grpSpPr>
+        <a:xfrm>
+          <a:off x="0" y="0"/>
+          <a:ext cx="0" cy="0"/>
+          <a:chOff x="0" y="0"/>
+          <a:chExt cx="0" cy="0"/>
+        </a:xfrm>
+      </p:grpSpPr>
+      <p:sp>
+        <p:nvSpPr>
+          <p:cNvPr id="2" name="Slide Image Placeholder 1"/>
+          <p:cNvSpPr>
+            <a:spLocks noGrp="1"/>
+          </p:cNvSpPr>
+          <p:nvPr>
+            <p:ph type="sldImg" idx="2"/>
+          </p:nvPr>
+        </p:nvSpPr>
+        <p:spPr/>
+      </p:sp>
+      <p:sp>
+        <p:nvSpPr>
+          <p:cNvPr id="3" name="Notes Placeholder 2"/>
+          <p:cNvSpPr>
+            <a:spLocks noGrp="1"/>
+          </p:cNvSpPr>
+          <p:nvPr>
+            <p:ph type="body" idx="3" sz="quarter"/>
+          </p:nvPr>
+        </p:nvSpPr>
+        <p:spPr/>
+        <p:txBody>
+          <a:bodyPr/>
+          <a:lstStyle/>
+          <a:p>
+            <a:r>
+              <a:t>Supporting screenshot 3 of 4 for the AI Operations Intelligence</a:t>
+            </a:r>
+          </a:p>
+          <a:p>
+            <a:r>
+              <a:t>Dashboard (slide 2): Alert Management &amp; Failures Control Center — Real-time monitoring and incident response. Optional deep dive only; it is not part</a:t>
+            </a:r>
+          </a:p>
+          <a:p>
+            <a:r>
+              <a:t>of the three-slide executive story. Use "Back to Slide 2" to return to the main flow.</a:t>
+            </a:r>
+          </a:p>
+          <a:p/>
+          <a:p>
+            <a:r>
+              <a:t>Source image: MS-AI/AI Dashboard/Screenshots/Screenshot_3.png, MS-TEST environment. The signed-in</a:t>
+            </a:r>
+          </a:p>
+          <a:p>
+            <a:r>
+              <a:t>user chip (and, on the automation slide, the requester email address) is pixelated; no</a:t>
+            </a:r>
+          </a:p>
+          <a:p>
+            <a:r>
+              <a:t>credentials, API keys, patient data or configuration secrets are shown.</a:t>
+            </a:r>
+          </a:p>
+        </p:txBody>
+      </p:sp>
+      <p:sp>
+        <p:nvSpPr>
+          <p:cNvPr id="4" name="Slide Number Placeholder 3"/>
+          <p:cNvSpPr>
+            <a:spLocks noGrp="1"/>
+          </p:cNvSpPr>
+          <p:nvPr>
+            <p:ph type="sldNum" idx="5" sz="quarter"/>
+          </p:nvPr>
+        </p:nvSpPr>
+        <p:spPr/>
+      </p:sp>
+    </p:spTree>
+  </p:cSld>
+  <p:clrMapOvr>
+    <a:masterClrMapping/>
+  </p:clrMapOvr>
+</p:notes>
+</file>
+
+<file path=ppt/notesSlides/notesSlide7.xml><?xml version="1.0" encoding="utf-8"?>
+<p:notes xmlns:a="http://schemas.openxmlformats.org/drawingml/2006/main" xmlns:p="http://schemas.openxmlformats.org/presentationml/2006/main" xmlns:r="http://schemas.openxmlformats.org/officeDocument/2006/relationships">
+  <p:cSld>
+    <p:spTree>
+      <p:nvGrpSpPr>
+        <p:cNvPr id="1" name=""/>
+        <p:cNvGrpSpPr/>
+        <p:nvPr/>
+      </p:nvGrpSpPr>
+      <p:grpSpPr>
+        <a:xfrm>
+          <a:off x="0" y="0"/>
+          <a:ext cx="0" cy="0"/>
+          <a:chOff x="0" y="0"/>
+          <a:chExt cx="0" cy="0"/>
+        </a:xfrm>
+      </p:grpSpPr>
+      <p:sp>
+        <p:nvSpPr>
+          <p:cNvPr id="2" name="Slide Image Placeholder 1"/>
+          <p:cNvSpPr>
+            <a:spLocks noGrp="1"/>
+          </p:cNvSpPr>
+          <p:nvPr>
+            <p:ph type="sldImg" idx="2"/>
+          </p:nvPr>
+        </p:nvSpPr>
+        <p:spPr/>
+      </p:sp>
+      <p:sp>
+        <p:nvSpPr>
+          <p:cNvPr id="3" name="Notes Placeholder 2"/>
+          <p:cNvSpPr>
+            <a:spLocks noGrp="1"/>
+          </p:cNvSpPr>
+          <p:nvPr>
+            <p:ph type="body" idx="3" sz="quarter"/>
+          </p:nvPr>
+        </p:nvSpPr>
+        <p:spPr/>
+        <p:txBody>
+          <a:bodyPr/>
+          <a:lstStyle/>
+          <a:p>
+            <a:r>
+              <a:t>Supporting screenshot 4 of 4 for the AI Operations Intelligence</a:t>
+            </a:r>
+          </a:p>
+          <a:p>
+            <a:r>
+              <a:t>Dashboard (slide 2): Automation Rules &amp; Actions Engine — Threshold-based automated actions. Optional deep dive only; it is not part</a:t>
+            </a:r>
+          </a:p>
+          <a:p>
+            <a:r>
+              <a:t>of the three-slide executive story. Use "Back to Slide 2" to return to the main flow.</a:t>
+            </a:r>
+          </a:p>
+          <a:p/>
+          <a:p>
+            <a:r>
+              <a:t>Source image: MS-AI/AI Dashboard/Screenshots/Screenshot_4.png, MS-TEST environment. The signed-in</a:t>
+            </a:r>
+          </a:p>
+          <a:p>
+            <a:r>
+              <a:t>user chip (and, on the automation slide, the requester email address) is pixelated; no</a:t>
+            </a:r>
+          </a:p>
+          <a:p>
+            <a:r>
+              <a:t>credentials, API keys, patient data or configuration secrets are shown.</a:t>
             </a:r>
           </a:p>
         </p:txBody>
@@ -6507,6 +6895,72 @@
           </a:p>
         </p:txBody>
       </p:sp>
+      <p:sp>
+        <p:nvSpPr>
+          <p:cNvPr id="16" name="screenshot-appendix-link">
+            <a:hlinkClick action="ppaction://hlinksldjump" r:id="rId3"/>
+          </p:cNvPr>
+          <p:cNvSpPr/>
+          <p:nvPr/>
+        </p:nvSpPr>
+        <p:spPr>
+          <a:xfrm>
+            <a:off x="9521647" y="6382512"/>
+            <a:ext cx="2103120" cy="292608"/>
+          </a:xfrm>
+          <a:prstGeom prst="roundRect">
+            <a:avLst>
+              <a:gd name="adj" fmla="val 50000"/>
+            </a:avLst>
+          </a:prstGeom>
+          <a:solidFill>
+            <a:srgbClr val="FFFFFF"/>
+          </a:solidFill>
+          <a:ln w="12700">
+            <a:solidFill>
+              <a:srgbClr val="0E8C8B"/>
+            </a:solidFill>
+          </a:ln>
+          <a:effectLst/>
+        </p:spPr>
+        <p:style>
+          <a:lnRef idx="1">
+            <a:schemeClr val="accent1"/>
+          </a:lnRef>
+          <a:fillRef idx="3">
+            <a:schemeClr val="accent1"/>
+          </a:fillRef>
+          <a:effectRef idx="2">
+            <a:schemeClr val="accent1"/>
+          </a:effectRef>
+          <a:fontRef idx="minor">
+            <a:schemeClr val="lt1"/>
+          </a:fontRef>
+        </p:style>
+        <p:txBody>
+          <a:bodyPr rtlCol="0" anchor="ctr" wrap="square" lIns="73152" rIns="73152" tIns="0" bIns="0"/>
+          <a:lstStyle/>
+          <a:p>
+            <a:pPr algn="ctr">
+              <a:lnSpc>
+                <a:spcPct val="100000"/>
+              </a:lnSpc>
+              <a:spcAft>
+                <a:spcPts val="0"/>
+              </a:spcAft>
+            </a:pPr>
+            <a:r>
+              <a:rPr sz="1150" b="1">
+                <a:solidFill>
+                  <a:srgbClr val="0E8C8B"/>
+                </a:solidFill>
+                <a:latin typeface="Segoe UI"/>
+              </a:rPr>
+              <a:t>View Dashboard Screenshots ›</a:t>
+            </a:r>
+          </a:p>
+        </p:txBody>
+      </p:sp>
     </p:spTree>
   </p:cSld>
   <p:clrMapOvr>
@@ -7554,6 +8008,1922 @@
                 <a:latin typeface="Segoe UI"/>
               </a:rPr>
               <a:t>Prioritize pilots that improve safety, reduce operational burden and scale team productivity.</a:t>
+            </a:r>
+          </a:p>
+        </p:txBody>
+      </p:sp>
+    </p:spTree>
+  </p:cSld>
+  <p:clrMapOvr>
+    <a:masterClrMapping/>
+  </p:clrMapOvr>
+</p:sld>
+</file>
+
+<file path=ppt/slides/slide4.xml><?xml version="1.0" encoding="utf-8"?>
+<p:sld xmlns:a="http://schemas.openxmlformats.org/drawingml/2006/main" xmlns:p="http://schemas.openxmlformats.org/presentationml/2006/main" xmlns:r="http://schemas.openxmlformats.org/officeDocument/2006/relationships">
+  <p:cSld>
+    <p:spTree>
+      <p:nvGrpSpPr>
+        <p:cNvPr id="1" name=""/>
+        <p:cNvGrpSpPr/>
+        <p:nvPr/>
+      </p:nvGrpSpPr>
+      <p:grpSpPr/>
+      <p:sp>
+        <p:nvSpPr>
+          <p:cNvPr id="2" name="Rectangle 1"/>
+          <p:cNvSpPr/>
+          <p:nvPr/>
+        </p:nvSpPr>
+        <p:spPr>
+          <a:xfrm>
+            <a:off x="0" y="0"/>
+            <a:ext cx="146304" cy="6858000"/>
+          </a:xfrm>
+          <a:prstGeom prst="rect">
+            <a:avLst/>
+          </a:prstGeom>
+          <a:solidFill>
+            <a:srgbClr val="0B2545"/>
+          </a:solidFill>
+          <a:ln>
+            <a:noFill/>
+          </a:ln>
+          <a:effectLst/>
+        </p:spPr>
+        <p:style>
+          <a:lnRef idx="1">
+            <a:schemeClr val="accent1"/>
+          </a:lnRef>
+          <a:fillRef idx="3">
+            <a:schemeClr val="accent1"/>
+          </a:fillRef>
+          <a:effectRef idx="2">
+            <a:schemeClr val="accent1"/>
+          </a:effectRef>
+          <a:fontRef idx="minor">
+            <a:schemeClr val="lt1"/>
+          </a:fontRef>
+        </p:style>
+        <p:txBody>
+          <a:bodyPr rtlCol="0" anchor="ctr"/>
+          <a:lstStyle/>
+          <a:p>
+            <a:pPr algn="ctr"/>
+          </a:p>
+        </p:txBody>
+      </p:sp>
+      <p:sp>
+        <p:nvSpPr>
+          <p:cNvPr id="3" name="TextBox 2"/>
+          <p:cNvSpPr txBox="1"/>
+          <p:nvPr/>
+        </p:nvSpPr>
+        <p:spPr>
+          <a:xfrm>
+            <a:off x="566928" y="310896"/>
+            <a:ext cx="11057839" cy="237744"/>
+          </a:xfrm>
+          <a:prstGeom prst="rect">
+            <a:avLst/>
+          </a:prstGeom>
+          <a:noFill/>
+        </p:spPr>
+        <p:txBody>
+          <a:bodyPr wrap="square" anchor="t" lIns="0" rIns="0" tIns="0" bIns="0">
+            <a:spAutoFit/>
+          </a:bodyPr>
+          <a:lstStyle/>
+          <a:p>
+            <a:pPr algn="l">
+              <a:lnSpc>
+                <a:spcPct val="115000"/>
+              </a:lnSpc>
+              <a:spcAft>
+                <a:spcPts val="0"/>
+              </a:spcAft>
+            </a:pPr>
+            <a:r>
+              <a:rPr sz="1100" b="1">
+                <a:solidFill>
+                  <a:srgbClr val="0E8C8B"/>
+                </a:solidFill>
+                <a:latin typeface="Segoe UI"/>
+              </a:rPr>
+              <a:t>SUPPORTING SCREENSHOTS — OPTIONAL DEEP DIVE</a:t>
+            </a:r>
+          </a:p>
+        </p:txBody>
+      </p:sp>
+      <p:sp>
+        <p:nvSpPr>
+          <p:cNvPr id="4" name="TextBox 3"/>
+          <p:cNvSpPr txBox="1"/>
+          <p:nvPr/>
+        </p:nvSpPr>
+        <p:spPr>
+          <a:xfrm>
+            <a:off x="566928" y="548640"/>
+            <a:ext cx="7498079" cy="402336"/>
+          </a:xfrm>
+          <a:prstGeom prst="rect">
+            <a:avLst/>
+          </a:prstGeom>
+          <a:noFill/>
+        </p:spPr>
+        <p:txBody>
+          <a:bodyPr wrap="square" anchor="t" lIns="0" rIns="0" tIns="0" bIns="0">
+            <a:spAutoFit/>
+          </a:bodyPr>
+          <a:lstStyle/>
+          <a:p>
+            <a:pPr algn="l">
+              <a:lnSpc>
+                <a:spcPct val="100000"/>
+              </a:lnSpc>
+              <a:spcAft>
+                <a:spcPts val="0"/>
+              </a:spcAft>
+            </a:pPr>
+            <a:r>
+              <a:rPr sz="2400" b="1">
+                <a:solidFill>
+                  <a:srgbClr val="0B2545"/>
+                </a:solidFill>
+                <a:latin typeface="Segoe UI"/>
+              </a:rPr>
+              <a:t>AI Dashboard Screenshots</a:t>
+            </a:r>
+          </a:p>
+        </p:txBody>
+      </p:sp>
+      <p:sp>
+        <p:nvSpPr>
+          <p:cNvPr id="5" name="TextBox 4"/>
+          <p:cNvSpPr txBox="1"/>
+          <p:nvPr/>
+        </p:nvSpPr>
+        <p:spPr>
+          <a:xfrm>
+            <a:off x="566928" y="969264"/>
+            <a:ext cx="8595360" cy="310896"/>
+          </a:xfrm>
+          <a:prstGeom prst="rect">
+            <a:avLst/>
+          </a:prstGeom>
+          <a:noFill/>
+        </p:spPr>
+        <p:txBody>
+          <a:bodyPr wrap="square" anchor="t" lIns="0" rIns="0" tIns="0" bIns="0">
+            <a:spAutoFit/>
+          </a:bodyPr>
+          <a:lstStyle/>
+          <a:p>
+            <a:pPr algn="l">
+              <a:lnSpc>
+                <a:spcPct val="105000"/>
+              </a:lnSpc>
+              <a:spcAft>
+                <a:spcPts val="0"/>
+              </a:spcAft>
+            </a:pPr>
+            <a:r>
+              <a:rPr sz="1300" b="1">
+                <a:solidFill>
+                  <a:srgbClr val="556677"/>
+                </a:solidFill>
+                <a:latin typeface="Segoe UI"/>
+              </a:rPr>
+              <a:t>1 of 4  ·  </a:t>
+            </a:r>
+            <a:r>
+              <a:rPr sz="1300" b="1">
+                <a:solidFill>
+                  <a:srgbClr val="1B3A5C"/>
+                </a:solidFill>
+                <a:latin typeface="Segoe UI"/>
+              </a:rPr>
+              <a:t>Storage Monitoring</a:t>
+            </a:r>
+            <a:r>
+              <a:rPr sz="1300" b="0">
+                <a:solidFill>
+                  <a:srgbClr val="556677"/>
+                </a:solidFill>
+                <a:latin typeface="Segoe UI"/>
+              </a:rPr>
+              <a:t>  — Drive usage and capacity planning with AI volume-capacity forecasts</a:t>
+            </a:r>
+          </a:p>
+        </p:txBody>
+      </p:sp>
+      <p:pic>
+        <p:nvPicPr>
+          <p:cNvPr id="6" name="Picture 5" descr="Screenshot_1.png"/>
+          <p:cNvPicPr>
+            <a:picLocks noChangeAspect="1"/>
+          </p:cNvPicPr>
+          <p:nvPr/>
+        </p:nvPicPr>
+        <p:blipFill>
+          <a:blip r:embed="rId2"/>
+          <a:stretch>
+            <a:fillRect/>
+          </a:stretch>
+        </p:blipFill>
+        <p:spPr>
+          <a:xfrm>
+            <a:off x="1260457" y="1389888"/>
+            <a:ext cx="9670781" cy="4791456"/>
+          </a:xfrm>
+          <a:prstGeom prst="rect">
+            <a:avLst/>
+          </a:prstGeom>
+        </p:spPr>
+      </p:pic>
+      <p:sp>
+        <p:nvSpPr>
+          <p:cNvPr id="7" name="Rectangle 6"/>
+          <p:cNvSpPr/>
+          <p:nvPr/>
+        </p:nvSpPr>
+        <p:spPr>
+          <a:xfrm>
+            <a:off x="1250932" y="1380363"/>
+            <a:ext cx="9689831" cy="4810506"/>
+          </a:xfrm>
+          <a:prstGeom prst="rect">
+            <a:avLst/>
+          </a:prstGeom>
+          <a:noFill/>
+          <a:ln w="12700">
+            <a:solidFill>
+              <a:srgbClr val="D6DEE6"/>
+            </a:solidFill>
+          </a:ln>
+          <a:effectLst/>
+        </p:spPr>
+        <p:style>
+          <a:lnRef idx="1">
+            <a:schemeClr val="accent1"/>
+          </a:lnRef>
+          <a:fillRef idx="3">
+            <a:schemeClr val="accent1"/>
+          </a:fillRef>
+          <a:effectRef idx="2">
+            <a:schemeClr val="accent1"/>
+          </a:effectRef>
+          <a:fontRef idx="minor">
+            <a:schemeClr val="lt1"/>
+          </a:fontRef>
+        </p:style>
+        <p:txBody>
+          <a:bodyPr rtlCol="0" anchor="ctr" wrap="square" lIns="146304" rIns="146304" tIns="91440" bIns="91440"/>
+          <a:lstStyle/>
+          <a:p>
+            <a:pPr algn="ctr"/>
+          </a:p>
+        </p:txBody>
+      </p:sp>
+      <p:sp>
+        <p:nvSpPr>
+          <p:cNvPr id="8" name="TextBox 7"/>
+          <p:cNvSpPr txBox="1"/>
+          <p:nvPr/>
+        </p:nvSpPr>
+        <p:spPr>
+          <a:xfrm>
+            <a:off x="566928" y="6272784"/>
+            <a:ext cx="5486400" cy="274320"/>
+          </a:xfrm>
+          <a:prstGeom prst="rect">
+            <a:avLst/>
+          </a:prstGeom>
+          <a:noFill/>
+        </p:spPr>
+        <p:txBody>
+          <a:bodyPr wrap="square" anchor="t" lIns="0" rIns="0" tIns="0" bIns="0">
+            <a:spAutoFit/>
+          </a:bodyPr>
+          <a:lstStyle/>
+          <a:p>
+            <a:pPr algn="l">
+              <a:lnSpc>
+                <a:spcPct val="100000"/>
+              </a:lnSpc>
+              <a:spcAft>
+                <a:spcPts val="0"/>
+              </a:spcAft>
+            </a:pPr>
+            <a:r>
+              <a:rPr sz="1000" b="0">
+                <a:solidFill>
+                  <a:srgbClr val="556677"/>
+                </a:solidFill>
+                <a:latin typeface="Segoe UI"/>
+              </a:rPr>
+              <a:t>Source: MS-AI/AI Dashboard/Screenshots/Screenshot_1.png — user identity redacted</a:t>
+            </a:r>
+          </a:p>
+        </p:txBody>
+      </p:sp>
+      <p:sp>
+        <p:nvSpPr>
+          <p:cNvPr id="9" name="Rounded Rectangle 8">
+            <a:hlinkClick action="ppaction://hlinksldjump" r:id="rId3"/>
+          </p:cNvPr>
+          <p:cNvSpPr/>
+          <p:nvPr/>
+        </p:nvSpPr>
+        <p:spPr>
+          <a:xfrm>
+            <a:off x="10051999" y="6254496"/>
+            <a:ext cx="1572768" cy="310896"/>
+          </a:xfrm>
+          <a:prstGeom prst="roundRect">
+            <a:avLst>
+              <a:gd name="adj" fmla="val 50000"/>
+            </a:avLst>
+          </a:prstGeom>
+          <a:solidFill>
+            <a:srgbClr val="0B2545"/>
+          </a:solidFill>
+          <a:ln>
+            <a:noFill/>
+          </a:ln>
+          <a:effectLst/>
+        </p:spPr>
+        <p:style>
+          <a:lnRef idx="1">
+            <a:schemeClr val="accent1"/>
+          </a:lnRef>
+          <a:fillRef idx="3">
+            <a:schemeClr val="accent1"/>
+          </a:fillRef>
+          <a:effectRef idx="2">
+            <a:schemeClr val="accent1"/>
+          </a:effectRef>
+          <a:fontRef idx="minor">
+            <a:schemeClr val="lt1"/>
+          </a:fontRef>
+        </p:style>
+        <p:txBody>
+          <a:bodyPr rtlCol="0" anchor="ctr" wrap="square" lIns="73152" rIns="73152" tIns="0" bIns="0"/>
+          <a:lstStyle/>
+          <a:p>
+            <a:pPr algn="ctr">
+              <a:lnSpc>
+                <a:spcPct val="100000"/>
+              </a:lnSpc>
+              <a:spcAft>
+                <a:spcPts val="0"/>
+              </a:spcAft>
+            </a:pPr>
+            <a:r>
+              <a:rPr sz="1150" b="1">
+                <a:solidFill>
+                  <a:srgbClr val="FFFFFF"/>
+                </a:solidFill>
+                <a:latin typeface="Segoe UI"/>
+              </a:rPr>
+              <a:t>Back to Slide 2</a:t>
+            </a:r>
+          </a:p>
+        </p:txBody>
+      </p:sp>
+      <p:sp>
+        <p:nvSpPr>
+          <p:cNvPr id="10" name="Rounded Rectangle 9">
+            <a:hlinkClick action="ppaction://hlinksldjump" r:id="rId4"/>
+          </p:cNvPr>
+          <p:cNvSpPr/>
+          <p:nvPr/>
+        </p:nvSpPr>
+        <p:spPr>
+          <a:xfrm>
+            <a:off x="8369503" y="6254496"/>
+            <a:ext cx="1572768" cy="310896"/>
+          </a:xfrm>
+          <a:prstGeom prst="roundRect">
+            <a:avLst>
+              <a:gd name="adj" fmla="val 50000"/>
+            </a:avLst>
+          </a:prstGeom>
+          <a:solidFill>
+            <a:srgbClr val="FFFFFF"/>
+          </a:solidFill>
+          <a:ln w="12700">
+            <a:solidFill>
+              <a:srgbClr val="D6DEE6"/>
+            </a:solidFill>
+          </a:ln>
+          <a:effectLst/>
+        </p:spPr>
+        <p:style>
+          <a:lnRef idx="1">
+            <a:schemeClr val="accent1"/>
+          </a:lnRef>
+          <a:fillRef idx="3">
+            <a:schemeClr val="accent1"/>
+          </a:fillRef>
+          <a:effectRef idx="2">
+            <a:schemeClr val="accent1"/>
+          </a:effectRef>
+          <a:fontRef idx="minor">
+            <a:schemeClr val="lt1"/>
+          </a:fontRef>
+        </p:style>
+        <p:txBody>
+          <a:bodyPr rtlCol="0" anchor="ctr" wrap="square" lIns="73152" rIns="73152" tIns="0" bIns="0"/>
+          <a:lstStyle/>
+          <a:p>
+            <a:pPr algn="ctr">
+              <a:lnSpc>
+                <a:spcPct val="100000"/>
+              </a:lnSpc>
+              <a:spcAft>
+                <a:spcPts val="0"/>
+              </a:spcAft>
+            </a:pPr>
+            <a:r>
+              <a:rPr sz="1150" b="1">
+                <a:solidFill>
+                  <a:srgbClr val="1B3A5C"/>
+                </a:solidFill>
+                <a:latin typeface="Segoe UI"/>
+              </a:rPr>
+              <a:t>Next Screenshot ›</a:t>
+            </a:r>
+          </a:p>
+        </p:txBody>
+      </p:sp>
+    </p:spTree>
+  </p:cSld>
+  <p:clrMapOvr>
+    <a:masterClrMapping/>
+  </p:clrMapOvr>
+</p:sld>
+</file>
+
+<file path=ppt/slides/slide5.xml><?xml version="1.0" encoding="utf-8"?>
+<p:sld xmlns:a="http://schemas.openxmlformats.org/drawingml/2006/main" xmlns:p="http://schemas.openxmlformats.org/presentationml/2006/main" xmlns:r="http://schemas.openxmlformats.org/officeDocument/2006/relationships">
+  <p:cSld>
+    <p:spTree>
+      <p:nvGrpSpPr>
+        <p:cNvPr id="1" name=""/>
+        <p:cNvGrpSpPr/>
+        <p:nvPr/>
+      </p:nvGrpSpPr>
+      <p:grpSpPr/>
+      <p:sp>
+        <p:nvSpPr>
+          <p:cNvPr id="2" name="Rectangle 1"/>
+          <p:cNvSpPr/>
+          <p:nvPr/>
+        </p:nvSpPr>
+        <p:spPr>
+          <a:xfrm>
+            <a:off x="0" y="0"/>
+            <a:ext cx="146304" cy="6858000"/>
+          </a:xfrm>
+          <a:prstGeom prst="rect">
+            <a:avLst/>
+          </a:prstGeom>
+          <a:solidFill>
+            <a:srgbClr val="0B2545"/>
+          </a:solidFill>
+          <a:ln>
+            <a:noFill/>
+          </a:ln>
+          <a:effectLst/>
+        </p:spPr>
+        <p:style>
+          <a:lnRef idx="1">
+            <a:schemeClr val="accent1"/>
+          </a:lnRef>
+          <a:fillRef idx="3">
+            <a:schemeClr val="accent1"/>
+          </a:fillRef>
+          <a:effectRef idx="2">
+            <a:schemeClr val="accent1"/>
+          </a:effectRef>
+          <a:fontRef idx="minor">
+            <a:schemeClr val="lt1"/>
+          </a:fontRef>
+        </p:style>
+        <p:txBody>
+          <a:bodyPr rtlCol="0" anchor="ctr"/>
+          <a:lstStyle/>
+          <a:p>
+            <a:pPr algn="ctr"/>
+          </a:p>
+        </p:txBody>
+      </p:sp>
+      <p:sp>
+        <p:nvSpPr>
+          <p:cNvPr id="3" name="TextBox 2"/>
+          <p:cNvSpPr txBox="1"/>
+          <p:nvPr/>
+        </p:nvSpPr>
+        <p:spPr>
+          <a:xfrm>
+            <a:off x="566928" y="310896"/>
+            <a:ext cx="11057839" cy="237744"/>
+          </a:xfrm>
+          <a:prstGeom prst="rect">
+            <a:avLst/>
+          </a:prstGeom>
+          <a:noFill/>
+        </p:spPr>
+        <p:txBody>
+          <a:bodyPr wrap="square" anchor="t" lIns="0" rIns="0" tIns="0" bIns="0">
+            <a:spAutoFit/>
+          </a:bodyPr>
+          <a:lstStyle/>
+          <a:p>
+            <a:pPr algn="l">
+              <a:lnSpc>
+                <a:spcPct val="115000"/>
+              </a:lnSpc>
+              <a:spcAft>
+                <a:spcPts val="0"/>
+              </a:spcAft>
+            </a:pPr>
+            <a:r>
+              <a:rPr sz="1100" b="1">
+                <a:solidFill>
+                  <a:srgbClr val="0E8C8B"/>
+                </a:solidFill>
+                <a:latin typeface="Segoe UI"/>
+              </a:rPr>
+              <a:t>SUPPORTING SCREENSHOTS — OPTIONAL DEEP DIVE</a:t>
+            </a:r>
+          </a:p>
+        </p:txBody>
+      </p:sp>
+      <p:sp>
+        <p:nvSpPr>
+          <p:cNvPr id="4" name="TextBox 3"/>
+          <p:cNvSpPr txBox="1"/>
+          <p:nvPr/>
+        </p:nvSpPr>
+        <p:spPr>
+          <a:xfrm>
+            <a:off x="566928" y="548640"/>
+            <a:ext cx="7498079" cy="402336"/>
+          </a:xfrm>
+          <a:prstGeom prst="rect">
+            <a:avLst/>
+          </a:prstGeom>
+          <a:noFill/>
+        </p:spPr>
+        <p:txBody>
+          <a:bodyPr wrap="square" anchor="t" lIns="0" rIns="0" tIns="0" bIns="0">
+            <a:spAutoFit/>
+          </a:bodyPr>
+          <a:lstStyle/>
+          <a:p>
+            <a:pPr algn="l">
+              <a:lnSpc>
+                <a:spcPct val="100000"/>
+              </a:lnSpc>
+              <a:spcAft>
+                <a:spcPts val="0"/>
+              </a:spcAft>
+            </a:pPr>
+            <a:r>
+              <a:rPr sz="2400" b="1">
+                <a:solidFill>
+                  <a:srgbClr val="0B2545"/>
+                </a:solidFill>
+                <a:latin typeface="Segoe UI"/>
+              </a:rPr>
+              <a:t>AI Dashboard Screenshots</a:t>
+            </a:r>
+          </a:p>
+        </p:txBody>
+      </p:sp>
+      <p:sp>
+        <p:nvSpPr>
+          <p:cNvPr id="5" name="TextBox 4"/>
+          <p:cNvSpPr txBox="1"/>
+          <p:nvPr/>
+        </p:nvSpPr>
+        <p:spPr>
+          <a:xfrm>
+            <a:off x="566928" y="969264"/>
+            <a:ext cx="8595360" cy="310896"/>
+          </a:xfrm>
+          <a:prstGeom prst="rect">
+            <a:avLst/>
+          </a:prstGeom>
+          <a:noFill/>
+        </p:spPr>
+        <p:txBody>
+          <a:bodyPr wrap="square" anchor="t" lIns="0" rIns="0" tIns="0" bIns="0">
+            <a:spAutoFit/>
+          </a:bodyPr>
+          <a:lstStyle/>
+          <a:p>
+            <a:pPr algn="l">
+              <a:lnSpc>
+                <a:spcPct val="105000"/>
+              </a:lnSpc>
+              <a:spcAft>
+                <a:spcPts val="0"/>
+              </a:spcAft>
+            </a:pPr>
+            <a:r>
+              <a:rPr sz="1300" b="1">
+                <a:solidFill>
+                  <a:srgbClr val="556677"/>
+                </a:solidFill>
+                <a:latin typeface="Segoe UI"/>
+              </a:rPr>
+              <a:t>2 of 4  ·  </a:t>
+            </a:r>
+            <a:r>
+              <a:rPr sz="1300" b="1">
+                <a:solidFill>
+                  <a:srgbClr val="1B3A5C"/>
+                </a:solidFill>
+                <a:latin typeface="Segoe UI"/>
+              </a:rPr>
+              <a:t>CPU &amp; Memory Process Insights</a:t>
+            </a:r>
+            <a:r>
+              <a:rPr sz="1300" b="0">
+                <a:solidFill>
+                  <a:srgbClr val="556677"/>
+                </a:solidFill>
+                <a:latin typeface="Segoe UI"/>
+              </a:rPr>
+              <a:t>  — Top resource consumers per server</a:t>
+            </a:r>
+          </a:p>
+        </p:txBody>
+      </p:sp>
+      <p:pic>
+        <p:nvPicPr>
+          <p:cNvPr id="6" name="Picture 5" descr="Screenshot_2.png"/>
+          <p:cNvPicPr>
+            <a:picLocks noChangeAspect="1"/>
+          </p:cNvPicPr>
+          <p:nvPr/>
+        </p:nvPicPr>
+        <p:blipFill>
+          <a:blip r:embed="rId2"/>
+          <a:stretch>
+            <a:fillRect/>
+          </a:stretch>
+        </p:blipFill>
+        <p:spPr>
+          <a:xfrm>
+            <a:off x="690468" y="1389888"/>
+            <a:ext cx="10810758" cy="4791456"/>
+          </a:xfrm>
+          <a:prstGeom prst="rect">
+            <a:avLst/>
+          </a:prstGeom>
+        </p:spPr>
+      </p:pic>
+      <p:sp>
+        <p:nvSpPr>
+          <p:cNvPr id="7" name="Rectangle 6"/>
+          <p:cNvSpPr/>
+          <p:nvPr/>
+        </p:nvSpPr>
+        <p:spPr>
+          <a:xfrm>
+            <a:off x="680943" y="1380363"/>
+            <a:ext cx="10829808" cy="4810506"/>
+          </a:xfrm>
+          <a:prstGeom prst="rect">
+            <a:avLst/>
+          </a:prstGeom>
+          <a:noFill/>
+          <a:ln w="12700">
+            <a:solidFill>
+              <a:srgbClr val="D6DEE6"/>
+            </a:solidFill>
+          </a:ln>
+          <a:effectLst/>
+        </p:spPr>
+        <p:style>
+          <a:lnRef idx="1">
+            <a:schemeClr val="accent1"/>
+          </a:lnRef>
+          <a:fillRef idx="3">
+            <a:schemeClr val="accent1"/>
+          </a:fillRef>
+          <a:effectRef idx="2">
+            <a:schemeClr val="accent1"/>
+          </a:effectRef>
+          <a:fontRef idx="minor">
+            <a:schemeClr val="lt1"/>
+          </a:fontRef>
+        </p:style>
+        <p:txBody>
+          <a:bodyPr rtlCol="0" anchor="ctr" wrap="square" lIns="146304" rIns="146304" tIns="91440" bIns="91440"/>
+          <a:lstStyle/>
+          <a:p>
+            <a:pPr algn="ctr"/>
+          </a:p>
+        </p:txBody>
+      </p:sp>
+      <p:sp>
+        <p:nvSpPr>
+          <p:cNvPr id="8" name="TextBox 7"/>
+          <p:cNvSpPr txBox="1"/>
+          <p:nvPr/>
+        </p:nvSpPr>
+        <p:spPr>
+          <a:xfrm>
+            <a:off x="566928" y="6272784"/>
+            <a:ext cx="5486400" cy="274320"/>
+          </a:xfrm>
+          <a:prstGeom prst="rect">
+            <a:avLst/>
+          </a:prstGeom>
+          <a:noFill/>
+        </p:spPr>
+        <p:txBody>
+          <a:bodyPr wrap="square" anchor="t" lIns="0" rIns="0" tIns="0" bIns="0">
+            <a:spAutoFit/>
+          </a:bodyPr>
+          <a:lstStyle/>
+          <a:p>
+            <a:pPr algn="l">
+              <a:lnSpc>
+                <a:spcPct val="100000"/>
+              </a:lnSpc>
+              <a:spcAft>
+                <a:spcPts val="0"/>
+              </a:spcAft>
+            </a:pPr>
+            <a:r>
+              <a:rPr sz="1000" b="0">
+                <a:solidFill>
+                  <a:srgbClr val="556677"/>
+                </a:solidFill>
+                <a:latin typeface="Segoe UI"/>
+              </a:rPr>
+              <a:t>Source: MS-AI/AI Dashboard/Screenshots/Screenshot_2.png — user identity redacted</a:t>
+            </a:r>
+          </a:p>
+        </p:txBody>
+      </p:sp>
+      <p:sp>
+        <p:nvSpPr>
+          <p:cNvPr id="9" name="Rounded Rectangle 8">
+            <a:hlinkClick action="ppaction://hlinksldjump" r:id="rId3"/>
+          </p:cNvPr>
+          <p:cNvSpPr/>
+          <p:nvPr/>
+        </p:nvSpPr>
+        <p:spPr>
+          <a:xfrm>
+            <a:off x="10051999" y="6254496"/>
+            <a:ext cx="1572768" cy="310896"/>
+          </a:xfrm>
+          <a:prstGeom prst="roundRect">
+            <a:avLst>
+              <a:gd name="adj" fmla="val 50000"/>
+            </a:avLst>
+          </a:prstGeom>
+          <a:solidFill>
+            <a:srgbClr val="0B2545"/>
+          </a:solidFill>
+          <a:ln>
+            <a:noFill/>
+          </a:ln>
+          <a:effectLst/>
+        </p:spPr>
+        <p:style>
+          <a:lnRef idx="1">
+            <a:schemeClr val="accent1"/>
+          </a:lnRef>
+          <a:fillRef idx="3">
+            <a:schemeClr val="accent1"/>
+          </a:fillRef>
+          <a:effectRef idx="2">
+            <a:schemeClr val="accent1"/>
+          </a:effectRef>
+          <a:fontRef idx="minor">
+            <a:schemeClr val="lt1"/>
+          </a:fontRef>
+        </p:style>
+        <p:txBody>
+          <a:bodyPr rtlCol="0" anchor="ctr" wrap="square" lIns="73152" rIns="73152" tIns="0" bIns="0"/>
+          <a:lstStyle/>
+          <a:p>
+            <a:pPr algn="ctr">
+              <a:lnSpc>
+                <a:spcPct val="100000"/>
+              </a:lnSpc>
+              <a:spcAft>
+                <a:spcPts val="0"/>
+              </a:spcAft>
+            </a:pPr>
+            <a:r>
+              <a:rPr sz="1150" b="1">
+                <a:solidFill>
+                  <a:srgbClr val="FFFFFF"/>
+                </a:solidFill>
+                <a:latin typeface="Segoe UI"/>
+              </a:rPr>
+              <a:t>Back to Slide 2</a:t>
+            </a:r>
+          </a:p>
+        </p:txBody>
+      </p:sp>
+      <p:sp>
+        <p:nvSpPr>
+          <p:cNvPr id="10" name="Rounded Rectangle 9">
+            <a:hlinkClick action="ppaction://hlinksldjump" r:id="rId4"/>
+          </p:cNvPr>
+          <p:cNvSpPr/>
+          <p:nvPr/>
+        </p:nvSpPr>
+        <p:spPr>
+          <a:xfrm>
+            <a:off x="8369503" y="6254496"/>
+            <a:ext cx="1572768" cy="310896"/>
+          </a:xfrm>
+          <a:prstGeom prst="roundRect">
+            <a:avLst>
+              <a:gd name="adj" fmla="val 50000"/>
+            </a:avLst>
+          </a:prstGeom>
+          <a:solidFill>
+            <a:srgbClr val="FFFFFF"/>
+          </a:solidFill>
+          <a:ln w="12700">
+            <a:solidFill>
+              <a:srgbClr val="D6DEE6"/>
+            </a:solidFill>
+          </a:ln>
+          <a:effectLst/>
+        </p:spPr>
+        <p:style>
+          <a:lnRef idx="1">
+            <a:schemeClr val="accent1"/>
+          </a:lnRef>
+          <a:fillRef idx="3">
+            <a:schemeClr val="accent1"/>
+          </a:fillRef>
+          <a:effectRef idx="2">
+            <a:schemeClr val="accent1"/>
+          </a:effectRef>
+          <a:fontRef idx="minor">
+            <a:schemeClr val="lt1"/>
+          </a:fontRef>
+        </p:style>
+        <p:txBody>
+          <a:bodyPr rtlCol="0" anchor="ctr" wrap="square" lIns="73152" rIns="73152" tIns="0" bIns="0"/>
+          <a:lstStyle/>
+          <a:p>
+            <a:pPr algn="ctr">
+              <a:lnSpc>
+                <a:spcPct val="100000"/>
+              </a:lnSpc>
+              <a:spcAft>
+                <a:spcPts val="0"/>
+              </a:spcAft>
+            </a:pPr>
+            <a:r>
+              <a:rPr sz="1150" b="1">
+                <a:solidFill>
+                  <a:srgbClr val="1B3A5C"/>
+                </a:solidFill>
+                <a:latin typeface="Segoe UI"/>
+              </a:rPr>
+              <a:t>Next Screenshot ›</a:t>
+            </a:r>
+          </a:p>
+        </p:txBody>
+      </p:sp>
+      <p:sp>
+        <p:nvSpPr>
+          <p:cNvPr id="11" name="Rounded Rectangle 10">
+            <a:hlinkClick action="ppaction://hlinksldjump" r:id="rId5"/>
+          </p:cNvPr>
+          <p:cNvSpPr/>
+          <p:nvPr/>
+        </p:nvSpPr>
+        <p:spPr>
+          <a:xfrm>
+            <a:off x="6687007" y="6254496"/>
+            <a:ext cx="1572768" cy="310896"/>
+          </a:xfrm>
+          <a:prstGeom prst="roundRect">
+            <a:avLst>
+              <a:gd name="adj" fmla="val 50000"/>
+            </a:avLst>
+          </a:prstGeom>
+          <a:solidFill>
+            <a:srgbClr val="FFFFFF"/>
+          </a:solidFill>
+          <a:ln w="12700">
+            <a:solidFill>
+              <a:srgbClr val="D6DEE6"/>
+            </a:solidFill>
+          </a:ln>
+          <a:effectLst/>
+        </p:spPr>
+        <p:style>
+          <a:lnRef idx="1">
+            <a:schemeClr val="accent1"/>
+          </a:lnRef>
+          <a:fillRef idx="3">
+            <a:schemeClr val="accent1"/>
+          </a:fillRef>
+          <a:effectRef idx="2">
+            <a:schemeClr val="accent1"/>
+          </a:effectRef>
+          <a:fontRef idx="minor">
+            <a:schemeClr val="lt1"/>
+          </a:fontRef>
+        </p:style>
+        <p:txBody>
+          <a:bodyPr rtlCol="0" anchor="ctr" wrap="square" lIns="73152" rIns="73152" tIns="0" bIns="0"/>
+          <a:lstStyle/>
+          <a:p>
+            <a:pPr algn="ctr">
+              <a:lnSpc>
+                <a:spcPct val="100000"/>
+              </a:lnSpc>
+              <a:spcAft>
+                <a:spcPts val="0"/>
+              </a:spcAft>
+            </a:pPr>
+            <a:r>
+              <a:rPr sz="1150" b="1">
+                <a:solidFill>
+                  <a:srgbClr val="1B3A5C"/>
+                </a:solidFill>
+                <a:latin typeface="Segoe UI"/>
+              </a:rPr>
+              <a:t>‹ Previous</a:t>
+            </a:r>
+          </a:p>
+        </p:txBody>
+      </p:sp>
+    </p:spTree>
+  </p:cSld>
+  <p:clrMapOvr>
+    <a:masterClrMapping/>
+  </p:clrMapOvr>
+</p:sld>
+</file>
+
+<file path=ppt/slides/slide6.xml><?xml version="1.0" encoding="utf-8"?>
+<p:sld xmlns:a="http://schemas.openxmlformats.org/drawingml/2006/main" xmlns:p="http://schemas.openxmlformats.org/presentationml/2006/main" xmlns:r="http://schemas.openxmlformats.org/officeDocument/2006/relationships">
+  <p:cSld>
+    <p:spTree>
+      <p:nvGrpSpPr>
+        <p:cNvPr id="1" name=""/>
+        <p:cNvGrpSpPr/>
+        <p:nvPr/>
+      </p:nvGrpSpPr>
+      <p:grpSpPr/>
+      <p:sp>
+        <p:nvSpPr>
+          <p:cNvPr id="2" name="Rectangle 1"/>
+          <p:cNvSpPr/>
+          <p:nvPr/>
+        </p:nvSpPr>
+        <p:spPr>
+          <a:xfrm>
+            <a:off x="0" y="0"/>
+            <a:ext cx="146304" cy="6858000"/>
+          </a:xfrm>
+          <a:prstGeom prst="rect">
+            <a:avLst/>
+          </a:prstGeom>
+          <a:solidFill>
+            <a:srgbClr val="0B2545"/>
+          </a:solidFill>
+          <a:ln>
+            <a:noFill/>
+          </a:ln>
+          <a:effectLst/>
+        </p:spPr>
+        <p:style>
+          <a:lnRef idx="1">
+            <a:schemeClr val="accent1"/>
+          </a:lnRef>
+          <a:fillRef idx="3">
+            <a:schemeClr val="accent1"/>
+          </a:fillRef>
+          <a:effectRef idx="2">
+            <a:schemeClr val="accent1"/>
+          </a:effectRef>
+          <a:fontRef idx="minor">
+            <a:schemeClr val="lt1"/>
+          </a:fontRef>
+        </p:style>
+        <p:txBody>
+          <a:bodyPr rtlCol="0" anchor="ctr"/>
+          <a:lstStyle/>
+          <a:p>
+            <a:pPr algn="ctr"/>
+          </a:p>
+        </p:txBody>
+      </p:sp>
+      <p:sp>
+        <p:nvSpPr>
+          <p:cNvPr id="3" name="TextBox 2"/>
+          <p:cNvSpPr txBox="1"/>
+          <p:nvPr/>
+        </p:nvSpPr>
+        <p:spPr>
+          <a:xfrm>
+            <a:off x="566928" y="310896"/>
+            <a:ext cx="11057839" cy="237744"/>
+          </a:xfrm>
+          <a:prstGeom prst="rect">
+            <a:avLst/>
+          </a:prstGeom>
+          <a:noFill/>
+        </p:spPr>
+        <p:txBody>
+          <a:bodyPr wrap="square" anchor="t" lIns="0" rIns="0" tIns="0" bIns="0">
+            <a:spAutoFit/>
+          </a:bodyPr>
+          <a:lstStyle/>
+          <a:p>
+            <a:pPr algn="l">
+              <a:lnSpc>
+                <a:spcPct val="115000"/>
+              </a:lnSpc>
+              <a:spcAft>
+                <a:spcPts val="0"/>
+              </a:spcAft>
+            </a:pPr>
+            <a:r>
+              <a:rPr sz="1100" b="1">
+                <a:solidFill>
+                  <a:srgbClr val="0E8C8B"/>
+                </a:solidFill>
+                <a:latin typeface="Segoe UI"/>
+              </a:rPr>
+              <a:t>SUPPORTING SCREENSHOTS — OPTIONAL DEEP DIVE</a:t>
+            </a:r>
+          </a:p>
+        </p:txBody>
+      </p:sp>
+      <p:sp>
+        <p:nvSpPr>
+          <p:cNvPr id="4" name="TextBox 3"/>
+          <p:cNvSpPr txBox="1"/>
+          <p:nvPr/>
+        </p:nvSpPr>
+        <p:spPr>
+          <a:xfrm>
+            <a:off x="566928" y="548640"/>
+            <a:ext cx="7498079" cy="402336"/>
+          </a:xfrm>
+          <a:prstGeom prst="rect">
+            <a:avLst/>
+          </a:prstGeom>
+          <a:noFill/>
+        </p:spPr>
+        <p:txBody>
+          <a:bodyPr wrap="square" anchor="t" lIns="0" rIns="0" tIns="0" bIns="0">
+            <a:spAutoFit/>
+          </a:bodyPr>
+          <a:lstStyle/>
+          <a:p>
+            <a:pPr algn="l">
+              <a:lnSpc>
+                <a:spcPct val="100000"/>
+              </a:lnSpc>
+              <a:spcAft>
+                <a:spcPts val="0"/>
+              </a:spcAft>
+            </a:pPr>
+            <a:r>
+              <a:rPr sz="2400" b="1">
+                <a:solidFill>
+                  <a:srgbClr val="0B2545"/>
+                </a:solidFill>
+                <a:latin typeface="Segoe UI"/>
+              </a:rPr>
+              <a:t>AI Dashboard Screenshots</a:t>
+            </a:r>
+          </a:p>
+        </p:txBody>
+      </p:sp>
+      <p:sp>
+        <p:nvSpPr>
+          <p:cNvPr id="5" name="TextBox 4"/>
+          <p:cNvSpPr txBox="1"/>
+          <p:nvPr/>
+        </p:nvSpPr>
+        <p:spPr>
+          <a:xfrm>
+            <a:off x="566928" y="969264"/>
+            <a:ext cx="8595360" cy="310896"/>
+          </a:xfrm>
+          <a:prstGeom prst="rect">
+            <a:avLst/>
+          </a:prstGeom>
+          <a:noFill/>
+        </p:spPr>
+        <p:txBody>
+          <a:bodyPr wrap="square" anchor="t" lIns="0" rIns="0" tIns="0" bIns="0">
+            <a:spAutoFit/>
+          </a:bodyPr>
+          <a:lstStyle/>
+          <a:p>
+            <a:pPr algn="l">
+              <a:lnSpc>
+                <a:spcPct val="105000"/>
+              </a:lnSpc>
+              <a:spcAft>
+                <a:spcPts val="0"/>
+              </a:spcAft>
+            </a:pPr>
+            <a:r>
+              <a:rPr sz="1300" b="1">
+                <a:solidFill>
+                  <a:srgbClr val="556677"/>
+                </a:solidFill>
+                <a:latin typeface="Segoe UI"/>
+              </a:rPr>
+              <a:t>3 of 4  ·  </a:t>
+            </a:r>
+            <a:r>
+              <a:rPr sz="1300" b="1">
+                <a:solidFill>
+                  <a:srgbClr val="1B3A5C"/>
+                </a:solidFill>
+                <a:latin typeface="Segoe UI"/>
+              </a:rPr>
+              <a:t>Alert Management &amp; Failures Control Center</a:t>
+            </a:r>
+            <a:r>
+              <a:rPr sz="1300" b="0">
+                <a:solidFill>
+                  <a:srgbClr val="556677"/>
+                </a:solidFill>
+                <a:latin typeface="Segoe UI"/>
+              </a:rPr>
+              <a:t>  — Real-time monitoring and incident response</a:t>
+            </a:r>
+          </a:p>
+        </p:txBody>
+      </p:sp>
+      <p:pic>
+        <p:nvPicPr>
+          <p:cNvPr id="6" name="Picture 5" descr="Screenshot_3.png"/>
+          <p:cNvPicPr>
+            <a:picLocks noChangeAspect="1"/>
+          </p:cNvPicPr>
+          <p:nvPr/>
+        </p:nvPicPr>
+        <p:blipFill>
+          <a:blip r:embed="rId2"/>
+          <a:stretch>
+            <a:fillRect/>
+          </a:stretch>
+        </p:blipFill>
+        <p:spPr>
+          <a:xfrm>
+            <a:off x="1270975" y="1389888"/>
+            <a:ext cx="9649745" cy="4791456"/>
+          </a:xfrm>
+          <a:prstGeom prst="rect">
+            <a:avLst/>
+          </a:prstGeom>
+        </p:spPr>
+      </p:pic>
+      <p:sp>
+        <p:nvSpPr>
+          <p:cNvPr id="7" name="Rectangle 6"/>
+          <p:cNvSpPr/>
+          <p:nvPr/>
+        </p:nvSpPr>
+        <p:spPr>
+          <a:xfrm>
+            <a:off x="1261450" y="1380363"/>
+            <a:ext cx="9668795" cy="4810506"/>
+          </a:xfrm>
+          <a:prstGeom prst="rect">
+            <a:avLst/>
+          </a:prstGeom>
+          <a:noFill/>
+          <a:ln w="12700">
+            <a:solidFill>
+              <a:srgbClr val="D6DEE6"/>
+            </a:solidFill>
+          </a:ln>
+          <a:effectLst/>
+        </p:spPr>
+        <p:style>
+          <a:lnRef idx="1">
+            <a:schemeClr val="accent1"/>
+          </a:lnRef>
+          <a:fillRef idx="3">
+            <a:schemeClr val="accent1"/>
+          </a:fillRef>
+          <a:effectRef idx="2">
+            <a:schemeClr val="accent1"/>
+          </a:effectRef>
+          <a:fontRef idx="minor">
+            <a:schemeClr val="lt1"/>
+          </a:fontRef>
+        </p:style>
+        <p:txBody>
+          <a:bodyPr rtlCol="0" anchor="ctr" wrap="square" lIns="146304" rIns="146304" tIns="91440" bIns="91440"/>
+          <a:lstStyle/>
+          <a:p>
+            <a:pPr algn="ctr"/>
+          </a:p>
+        </p:txBody>
+      </p:sp>
+      <p:sp>
+        <p:nvSpPr>
+          <p:cNvPr id="8" name="TextBox 7"/>
+          <p:cNvSpPr txBox="1"/>
+          <p:nvPr/>
+        </p:nvSpPr>
+        <p:spPr>
+          <a:xfrm>
+            <a:off x="566928" y="6272784"/>
+            <a:ext cx="5486400" cy="274320"/>
+          </a:xfrm>
+          <a:prstGeom prst="rect">
+            <a:avLst/>
+          </a:prstGeom>
+          <a:noFill/>
+        </p:spPr>
+        <p:txBody>
+          <a:bodyPr wrap="square" anchor="t" lIns="0" rIns="0" tIns="0" bIns="0">
+            <a:spAutoFit/>
+          </a:bodyPr>
+          <a:lstStyle/>
+          <a:p>
+            <a:pPr algn="l">
+              <a:lnSpc>
+                <a:spcPct val="100000"/>
+              </a:lnSpc>
+              <a:spcAft>
+                <a:spcPts val="0"/>
+              </a:spcAft>
+            </a:pPr>
+            <a:r>
+              <a:rPr sz="1000" b="0">
+                <a:solidFill>
+                  <a:srgbClr val="556677"/>
+                </a:solidFill>
+                <a:latin typeface="Segoe UI"/>
+              </a:rPr>
+              <a:t>Source: MS-AI/AI Dashboard/Screenshots/Screenshot_3.png — user identity redacted</a:t>
+            </a:r>
+          </a:p>
+        </p:txBody>
+      </p:sp>
+      <p:sp>
+        <p:nvSpPr>
+          <p:cNvPr id="9" name="Rounded Rectangle 8">
+            <a:hlinkClick action="ppaction://hlinksldjump" r:id="rId3"/>
+          </p:cNvPr>
+          <p:cNvSpPr/>
+          <p:nvPr/>
+        </p:nvSpPr>
+        <p:spPr>
+          <a:xfrm>
+            <a:off x="10051999" y="6254496"/>
+            <a:ext cx="1572768" cy="310896"/>
+          </a:xfrm>
+          <a:prstGeom prst="roundRect">
+            <a:avLst>
+              <a:gd name="adj" fmla="val 50000"/>
+            </a:avLst>
+          </a:prstGeom>
+          <a:solidFill>
+            <a:srgbClr val="0B2545"/>
+          </a:solidFill>
+          <a:ln>
+            <a:noFill/>
+          </a:ln>
+          <a:effectLst/>
+        </p:spPr>
+        <p:style>
+          <a:lnRef idx="1">
+            <a:schemeClr val="accent1"/>
+          </a:lnRef>
+          <a:fillRef idx="3">
+            <a:schemeClr val="accent1"/>
+          </a:fillRef>
+          <a:effectRef idx="2">
+            <a:schemeClr val="accent1"/>
+          </a:effectRef>
+          <a:fontRef idx="minor">
+            <a:schemeClr val="lt1"/>
+          </a:fontRef>
+        </p:style>
+        <p:txBody>
+          <a:bodyPr rtlCol="0" anchor="ctr" wrap="square" lIns="73152" rIns="73152" tIns="0" bIns="0"/>
+          <a:lstStyle/>
+          <a:p>
+            <a:pPr algn="ctr">
+              <a:lnSpc>
+                <a:spcPct val="100000"/>
+              </a:lnSpc>
+              <a:spcAft>
+                <a:spcPts val="0"/>
+              </a:spcAft>
+            </a:pPr>
+            <a:r>
+              <a:rPr sz="1150" b="1">
+                <a:solidFill>
+                  <a:srgbClr val="FFFFFF"/>
+                </a:solidFill>
+                <a:latin typeface="Segoe UI"/>
+              </a:rPr>
+              <a:t>Back to Slide 2</a:t>
+            </a:r>
+          </a:p>
+        </p:txBody>
+      </p:sp>
+      <p:sp>
+        <p:nvSpPr>
+          <p:cNvPr id="10" name="Rounded Rectangle 9">
+            <a:hlinkClick action="ppaction://hlinksldjump" r:id="rId4"/>
+          </p:cNvPr>
+          <p:cNvSpPr/>
+          <p:nvPr/>
+        </p:nvSpPr>
+        <p:spPr>
+          <a:xfrm>
+            <a:off x="8369503" y="6254496"/>
+            <a:ext cx="1572768" cy="310896"/>
+          </a:xfrm>
+          <a:prstGeom prst="roundRect">
+            <a:avLst>
+              <a:gd name="adj" fmla="val 50000"/>
+            </a:avLst>
+          </a:prstGeom>
+          <a:solidFill>
+            <a:srgbClr val="FFFFFF"/>
+          </a:solidFill>
+          <a:ln w="12700">
+            <a:solidFill>
+              <a:srgbClr val="D6DEE6"/>
+            </a:solidFill>
+          </a:ln>
+          <a:effectLst/>
+        </p:spPr>
+        <p:style>
+          <a:lnRef idx="1">
+            <a:schemeClr val="accent1"/>
+          </a:lnRef>
+          <a:fillRef idx="3">
+            <a:schemeClr val="accent1"/>
+          </a:fillRef>
+          <a:effectRef idx="2">
+            <a:schemeClr val="accent1"/>
+          </a:effectRef>
+          <a:fontRef idx="minor">
+            <a:schemeClr val="lt1"/>
+          </a:fontRef>
+        </p:style>
+        <p:txBody>
+          <a:bodyPr rtlCol="0" anchor="ctr" wrap="square" lIns="73152" rIns="73152" tIns="0" bIns="0"/>
+          <a:lstStyle/>
+          <a:p>
+            <a:pPr algn="ctr">
+              <a:lnSpc>
+                <a:spcPct val="100000"/>
+              </a:lnSpc>
+              <a:spcAft>
+                <a:spcPts val="0"/>
+              </a:spcAft>
+            </a:pPr>
+            <a:r>
+              <a:rPr sz="1150" b="1">
+                <a:solidFill>
+                  <a:srgbClr val="1B3A5C"/>
+                </a:solidFill>
+                <a:latin typeface="Segoe UI"/>
+              </a:rPr>
+              <a:t>Next Screenshot ›</a:t>
+            </a:r>
+          </a:p>
+        </p:txBody>
+      </p:sp>
+      <p:sp>
+        <p:nvSpPr>
+          <p:cNvPr id="11" name="Rounded Rectangle 10">
+            <a:hlinkClick action="ppaction://hlinksldjump" r:id="rId5"/>
+          </p:cNvPr>
+          <p:cNvSpPr/>
+          <p:nvPr/>
+        </p:nvSpPr>
+        <p:spPr>
+          <a:xfrm>
+            <a:off x="6687007" y="6254496"/>
+            <a:ext cx="1572768" cy="310896"/>
+          </a:xfrm>
+          <a:prstGeom prst="roundRect">
+            <a:avLst>
+              <a:gd name="adj" fmla="val 50000"/>
+            </a:avLst>
+          </a:prstGeom>
+          <a:solidFill>
+            <a:srgbClr val="FFFFFF"/>
+          </a:solidFill>
+          <a:ln w="12700">
+            <a:solidFill>
+              <a:srgbClr val="D6DEE6"/>
+            </a:solidFill>
+          </a:ln>
+          <a:effectLst/>
+        </p:spPr>
+        <p:style>
+          <a:lnRef idx="1">
+            <a:schemeClr val="accent1"/>
+          </a:lnRef>
+          <a:fillRef idx="3">
+            <a:schemeClr val="accent1"/>
+          </a:fillRef>
+          <a:effectRef idx="2">
+            <a:schemeClr val="accent1"/>
+          </a:effectRef>
+          <a:fontRef idx="minor">
+            <a:schemeClr val="lt1"/>
+          </a:fontRef>
+        </p:style>
+        <p:txBody>
+          <a:bodyPr rtlCol="0" anchor="ctr" wrap="square" lIns="73152" rIns="73152" tIns="0" bIns="0"/>
+          <a:lstStyle/>
+          <a:p>
+            <a:pPr algn="ctr">
+              <a:lnSpc>
+                <a:spcPct val="100000"/>
+              </a:lnSpc>
+              <a:spcAft>
+                <a:spcPts val="0"/>
+              </a:spcAft>
+            </a:pPr>
+            <a:r>
+              <a:rPr sz="1150" b="1">
+                <a:solidFill>
+                  <a:srgbClr val="1B3A5C"/>
+                </a:solidFill>
+                <a:latin typeface="Segoe UI"/>
+              </a:rPr>
+              <a:t>‹ Previous</a:t>
+            </a:r>
+          </a:p>
+        </p:txBody>
+      </p:sp>
+    </p:spTree>
+  </p:cSld>
+  <p:clrMapOvr>
+    <a:masterClrMapping/>
+  </p:clrMapOvr>
+</p:sld>
+</file>
+
+<file path=ppt/slides/slide7.xml><?xml version="1.0" encoding="utf-8"?>
+<p:sld xmlns:a="http://schemas.openxmlformats.org/drawingml/2006/main" xmlns:p="http://schemas.openxmlformats.org/presentationml/2006/main" xmlns:r="http://schemas.openxmlformats.org/officeDocument/2006/relationships">
+  <p:cSld>
+    <p:spTree>
+      <p:nvGrpSpPr>
+        <p:cNvPr id="1" name=""/>
+        <p:cNvGrpSpPr/>
+        <p:nvPr/>
+      </p:nvGrpSpPr>
+      <p:grpSpPr/>
+      <p:sp>
+        <p:nvSpPr>
+          <p:cNvPr id="2" name="Rectangle 1"/>
+          <p:cNvSpPr/>
+          <p:nvPr/>
+        </p:nvSpPr>
+        <p:spPr>
+          <a:xfrm>
+            <a:off x="0" y="0"/>
+            <a:ext cx="146304" cy="6858000"/>
+          </a:xfrm>
+          <a:prstGeom prst="rect">
+            <a:avLst/>
+          </a:prstGeom>
+          <a:solidFill>
+            <a:srgbClr val="0B2545"/>
+          </a:solidFill>
+          <a:ln>
+            <a:noFill/>
+          </a:ln>
+          <a:effectLst/>
+        </p:spPr>
+        <p:style>
+          <a:lnRef idx="1">
+            <a:schemeClr val="accent1"/>
+          </a:lnRef>
+          <a:fillRef idx="3">
+            <a:schemeClr val="accent1"/>
+          </a:fillRef>
+          <a:effectRef idx="2">
+            <a:schemeClr val="accent1"/>
+          </a:effectRef>
+          <a:fontRef idx="minor">
+            <a:schemeClr val="lt1"/>
+          </a:fontRef>
+        </p:style>
+        <p:txBody>
+          <a:bodyPr rtlCol="0" anchor="ctr"/>
+          <a:lstStyle/>
+          <a:p>
+            <a:pPr algn="ctr"/>
+          </a:p>
+        </p:txBody>
+      </p:sp>
+      <p:sp>
+        <p:nvSpPr>
+          <p:cNvPr id="3" name="TextBox 2"/>
+          <p:cNvSpPr txBox="1"/>
+          <p:nvPr/>
+        </p:nvSpPr>
+        <p:spPr>
+          <a:xfrm>
+            <a:off x="566928" y="310896"/>
+            <a:ext cx="11057839" cy="237744"/>
+          </a:xfrm>
+          <a:prstGeom prst="rect">
+            <a:avLst/>
+          </a:prstGeom>
+          <a:noFill/>
+        </p:spPr>
+        <p:txBody>
+          <a:bodyPr wrap="square" anchor="t" lIns="0" rIns="0" tIns="0" bIns="0">
+            <a:spAutoFit/>
+          </a:bodyPr>
+          <a:lstStyle/>
+          <a:p>
+            <a:pPr algn="l">
+              <a:lnSpc>
+                <a:spcPct val="115000"/>
+              </a:lnSpc>
+              <a:spcAft>
+                <a:spcPts val="0"/>
+              </a:spcAft>
+            </a:pPr>
+            <a:r>
+              <a:rPr sz="1100" b="1">
+                <a:solidFill>
+                  <a:srgbClr val="0E8C8B"/>
+                </a:solidFill>
+                <a:latin typeface="Segoe UI"/>
+              </a:rPr>
+              <a:t>SUPPORTING SCREENSHOTS — OPTIONAL DEEP DIVE</a:t>
+            </a:r>
+          </a:p>
+        </p:txBody>
+      </p:sp>
+      <p:sp>
+        <p:nvSpPr>
+          <p:cNvPr id="4" name="TextBox 3"/>
+          <p:cNvSpPr txBox="1"/>
+          <p:nvPr/>
+        </p:nvSpPr>
+        <p:spPr>
+          <a:xfrm>
+            <a:off x="566928" y="548640"/>
+            <a:ext cx="7498079" cy="402336"/>
+          </a:xfrm>
+          <a:prstGeom prst="rect">
+            <a:avLst/>
+          </a:prstGeom>
+          <a:noFill/>
+        </p:spPr>
+        <p:txBody>
+          <a:bodyPr wrap="square" anchor="t" lIns="0" rIns="0" tIns="0" bIns="0">
+            <a:spAutoFit/>
+          </a:bodyPr>
+          <a:lstStyle/>
+          <a:p>
+            <a:pPr algn="l">
+              <a:lnSpc>
+                <a:spcPct val="100000"/>
+              </a:lnSpc>
+              <a:spcAft>
+                <a:spcPts val="0"/>
+              </a:spcAft>
+            </a:pPr>
+            <a:r>
+              <a:rPr sz="2400" b="1">
+                <a:solidFill>
+                  <a:srgbClr val="0B2545"/>
+                </a:solidFill>
+                <a:latin typeface="Segoe UI"/>
+              </a:rPr>
+              <a:t>AI Dashboard Screenshots</a:t>
+            </a:r>
+          </a:p>
+        </p:txBody>
+      </p:sp>
+      <p:sp>
+        <p:nvSpPr>
+          <p:cNvPr id="5" name="TextBox 4"/>
+          <p:cNvSpPr txBox="1"/>
+          <p:nvPr/>
+        </p:nvSpPr>
+        <p:spPr>
+          <a:xfrm>
+            <a:off x="566928" y="969264"/>
+            <a:ext cx="8595360" cy="310896"/>
+          </a:xfrm>
+          <a:prstGeom prst="rect">
+            <a:avLst/>
+          </a:prstGeom>
+          <a:noFill/>
+        </p:spPr>
+        <p:txBody>
+          <a:bodyPr wrap="square" anchor="t" lIns="0" rIns="0" tIns="0" bIns="0">
+            <a:spAutoFit/>
+          </a:bodyPr>
+          <a:lstStyle/>
+          <a:p>
+            <a:pPr algn="l">
+              <a:lnSpc>
+                <a:spcPct val="105000"/>
+              </a:lnSpc>
+              <a:spcAft>
+                <a:spcPts val="0"/>
+              </a:spcAft>
+            </a:pPr>
+            <a:r>
+              <a:rPr sz="1300" b="1">
+                <a:solidFill>
+                  <a:srgbClr val="556677"/>
+                </a:solidFill>
+                <a:latin typeface="Segoe UI"/>
+              </a:rPr>
+              <a:t>4 of 4  ·  </a:t>
+            </a:r>
+            <a:r>
+              <a:rPr sz="1300" b="1">
+                <a:solidFill>
+                  <a:srgbClr val="1B3A5C"/>
+                </a:solidFill>
+                <a:latin typeface="Segoe UI"/>
+              </a:rPr>
+              <a:t>Automation Rules &amp; Actions Engine</a:t>
+            </a:r>
+            <a:r>
+              <a:rPr sz="1300" b="0">
+                <a:solidFill>
+                  <a:srgbClr val="556677"/>
+                </a:solidFill>
+                <a:latin typeface="Segoe UI"/>
+              </a:rPr>
+              <a:t>  — Threshold-based automated actions</a:t>
+            </a:r>
+          </a:p>
+        </p:txBody>
+      </p:sp>
+      <p:pic>
+        <p:nvPicPr>
+          <p:cNvPr id="6" name="Picture 5" descr="Screenshot_4.png"/>
+          <p:cNvPicPr>
+            <a:picLocks noChangeAspect="1"/>
+          </p:cNvPicPr>
+          <p:nvPr/>
+        </p:nvPicPr>
+        <p:blipFill>
+          <a:blip r:embed="rId2"/>
+          <a:stretch>
+            <a:fillRect/>
+          </a:stretch>
+        </p:blipFill>
+        <p:spPr>
+          <a:xfrm>
+            <a:off x="1276267" y="1389888"/>
+            <a:ext cx="9639161" cy="4791456"/>
+          </a:xfrm>
+          <a:prstGeom prst="rect">
+            <a:avLst/>
+          </a:prstGeom>
+        </p:spPr>
+      </p:pic>
+      <p:sp>
+        <p:nvSpPr>
+          <p:cNvPr id="7" name="Rectangle 6"/>
+          <p:cNvSpPr/>
+          <p:nvPr/>
+        </p:nvSpPr>
+        <p:spPr>
+          <a:xfrm>
+            <a:off x="1266742" y="1380363"/>
+            <a:ext cx="9658211" cy="4810506"/>
+          </a:xfrm>
+          <a:prstGeom prst="rect">
+            <a:avLst/>
+          </a:prstGeom>
+          <a:noFill/>
+          <a:ln w="12700">
+            <a:solidFill>
+              <a:srgbClr val="D6DEE6"/>
+            </a:solidFill>
+          </a:ln>
+          <a:effectLst/>
+        </p:spPr>
+        <p:style>
+          <a:lnRef idx="1">
+            <a:schemeClr val="accent1"/>
+          </a:lnRef>
+          <a:fillRef idx="3">
+            <a:schemeClr val="accent1"/>
+          </a:fillRef>
+          <a:effectRef idx="2">
+            <a:schemeClr val="accent1"/>
+          </a:effectRef>
+          <a:fontRef idx="minor">
+            <a:schemeClr val="lt1"/>
+          </a:fontRef>
+        </p:style>
+        <p:txBody>
+          <a:bodyPr rtlCol="0" anchor="ctr" wrap="square" lIns="146304" rIns="146304" tIns="91440" bIns="91440"/>
+          <a:lstStyle/>
+          <a:p>
+            <a:pPr algn="ctr"/>
+          </a:p>
+        </p:txBody>
+      </p:sp>
+      <p:sp>
+        <p:nvSpPr>
+          <p:cNvPr id="8" name="TextBox 7"/>
+          <p:cNvSpPr txBox="1"/>
+          <p:nvPr/>
+        </p:nvSpPr>
+        <p:spPr>
+          <a:xfrm>
+            <a:off x="566928" y="6272784"/>
+            <a:ext cx="5486400" cy="274320"/>
+          </a:xfrm>
+          <a:prstGeom prst="rect">
+            <a:avLst/>
+          </a:prstGeom>
+          <a:noFill/>
+        </p:spPr>
+        <p:txBody>
+          <a:bodyPr wrap="square" anchor="t" lIns="0" rIns="0" tIns="0" bIns="0">
+            <a:spAutoFit/>
+          </a:bodyPr>
+          <a:lstStyle/>
+          <a:p>
+            <a:pPr algn="l">
+              <a:lnSpc>
+                <a:spcPct val="100000"/>
+              </a:lnSpc>
+              <a:spcAft>
+                <a:spcPts val="0"/>
+              </a:spcAft>
+            </a:pPr>
+            <a:r>
+              <a:rPr sz="1000" b="0">
+                <a:solidFill>
+                  <a:srgbClr val="556677"/>
+                </a:solidFill>
+                <a:latin typeface="Segoe UI"/>
+              </a:rPr>
+              <a:t>Source: MS-AI/AI Dashboard/Screenshots/Screenshot_4.png — user identity redacted</a:t>
+            </a:r>
+          </a:p>
+        </p:txBody>
+      </p:sp>
+      <p:sp>
+        <p:nvSpPr>
+          <p:cNvPr id="9" name="Rounded Rectangle 8">
+            <a:hlinkClick action="ppaction://hlinksldjump" r:id="rId3"/>
+          </p:cNvPr>
+          <p:cNvSpPr/>
+          <p:nvPr/>
+        </p:nvSpPr>
+        <p:spPr>
+          <a:xfrm>
+            <a:off x="10051999" y="6254496"/>
+            <a:ext cx="1572768" cy="310896"/>
+          </a:xfrm>
+          <a:prstGeom prst="roundRect">
+            <a:avLst>
+              <a:gd name="adj" fmla="val 50000"/>
+            </a:avLst>
+          </a:prstGeom>
+          <a:solidFill>
+            <a:srgbClr val="0B2545"/>
+          </a:solidFill>
+          <a:ln>
+            <a:noFill/>
+          </a:ln>
+          <a:effectLst/>
+        </p:spPr>
+        <p:style>
+          <a:lnRef idx="1">
+            <a:schemeClr val="accent1"/>
+          </a:lnRef>
+          <a:fillRef idx="3">
+            <a:schemeClr val="accent1"/>
+          </a:fillRef>
+          <a:effectRef idx="2">
+            <a:schemeClr val="accent1"/>
+          </a:effectRef>
+          <a:fontRef idx="minor">
+            <a:schemeClr val="lt1"/>
+          </a:fontRef>
+        </p:style>
+        <p:txBody>
+          <a:bodyPr rtlCol="0" anchor="ctr" wrap="square" lIns="73152" rIns="73152" tIns="0" bIns="0"/>
+          <a:lstStyle/>
+          <a:p>
+            <a:pPr algn="ctr">
+              <a:lnSpc>
+                <a:spcPct val="100000"/>
+              </a:lnSpc>
+              <a:spcAft>
+                <a:spcPts val="0"/>
+              </a:spcAft>
+            </a:pPr>
+            <a:r>
+              <a:rPr sz="1150" b="1">
+                <a:solidFill>
+                  <a:srgbClr val="FFFFFF"/>
+                </a:solidFill>
+                <a:latin typeface="Segoe UI"/>
+              </a:rPr>
+              <a:t>Back to Slide 2</a:t>
+            </a:r>
+          </a:p>
+        </p:txBody>
+      </p:sp>
+      <p:sp>
+        <p:nvSpPr>
+          <p:cNvPr id="10" name="Rounded Rectangle 9">
+            <a:hlinkClick action="ppaction://hlinksldjump" r:id="rId4"/>
+          </p:cNvPr>
+          <p:cNvSpPr/>
+          <p:nvPr/>
+        </p:nvSpPr>
+        <p:spPr>
+          <a:xfrm>
+            <a:off x="8369503" y="6254496"/>
+            <a:ext cx="1572768" cy="310896"/>
+          </a:xfrm>
+          <a:prstGeom prst="roundRect">
+            <a:avLst>
+              <a:gd name="adj" fmla="val 50000"/>
+            </a:avLst>
+          </a:prstGeom>
+          <a:solidFill>
+            <a:srgbClr val="FFFFFF"/>
+          </a:solidFill>
+          <a:ln w="12700">
+            <a:solidFill>
+              <a:srgbClr val="D6DEE6"/>
+            </a:solidFill>
+          </a:ln>
+          <a:effectLst/>
+        </p:spPr>
+        <p:style>
+          <a:lnRef idx="1">
+            <a:schemeClr val="accent1"/>
+          </a:lnRef>
+          <a:fillRef idx="3">
+            <a:schemeClr val="accent1"/>
+          </a:fillRef>
+          <a:effectRef idx="2">
+            <a:schemeClr val="accent1"/>
+          </a:effectRef>
+          <a:fontRef idx="minor">
+            <a:schemeClr val="lt1"/>
+          </a:fontRef>
+        </p:style>
+        <p:txBody>
+          <a:bodyPr rtlCol="0" anchor="ctr" wrap="square" lIns="73152" rIns="73152" tIns="0" bIns="0"/>
+          <a:lstStyle/>
+          <a:p>
+            <a:pPr algn="ctr">
+              <a:lnSpc>
+                <a:spcPct val="100000"/>
+              </a:lnSpc>
+              <a:spcAft>
+                <a:spcPts val="0"/>
+              </a:spcAft>
+            </a:pPr>
+            <a:r>
+              <a:rPr sz="1150" b="1">
+                <a:solidFill>
+                  <a:srgbClr val="1B3A5C"/>
+                </a:solidFill>
+                <a:latin typeface="Segoe UI"/>
+              </a:rPr>
+              <a:t>‹ Previous</a:t>
             </a:r>
           </a:p>
         </p:txBody>

</xml_diff>